<commit_message>
feat(presentation): update to 4-slide deck with visual dataset representations and complete architecture flow
</commit_message>
<xml_diff>
--- a/Brain_CT_Seg_Client_Presentation.pptx
+++ b/Brain_CT_Seg_Client_Presentation.pptx
@@ -9,7 +9,6 @@
     <p:sldId id="257" r:id="rId8"/>
     <p:sldId id="258" r:id="rId9"/>
     <p:sldId id="259" r:id="rId10"/>
-    <p:sldId id="260" r:id="rId11"/>
   </p:sldIdLst>
   <p:sldSz cx="12191695" cy="6858000" type="screen4x3"/>
   <p:notesSz cx="6858000" cy="9144000"/>
@@ -3115,7 +3114,7 @@
           <a:lstStyle/>
           <a:p>
             <a:pPr>
-              <a:defRPr sz="1400" b="1">
+              <a:defRPr sz="1300" b="1">
                 <a:solidFill>
                   <a:srgbClr val="0F2942"/>
                 </a:solidFill>
@@ -3150,7 +3149,7 @@
           <a:lstStyle/>
           <a:p>
             <a:pPr>
-              <a:defRPr sz="2200" b="1">
+              <a:defRPr sz="2100" b="1">
                 <a:solidFill>
                   <a:srgbClr val="1E3A8A"/>
                 </a:solidFill>
@@ -3162,7 +3161,7 @@
           </a:p>
           <a:p>
             <a:pPr>
-              <a:defRPr sz="1300">
+              <a:defRPr sz="1200">
                 <a:solidFill>
                   <a:srgbClr val="64748B"/>
                 </a:solidFill>
@@ -3182,8 +3181,8 @@
         </p:nvSpPr>
         <p:spPr>
           <a:xfrm>
-            <a:off x="731520" y="6400800"/>
-            <a:ext cx="4572000" cy="365760"/>
+            <a:off x="731520" y="6446520"/>
+            <a:ext cx="5486400" cy="320040"/>
           </a:xfrm>
           <a:prstGeom prst="rect">
             <a:avLst/>
@@ -3217,8 +3216,8 @@
         </p:nvSpPr>
         <p:spPr>
           <a:xfrm>
-            <a:off x="11155680" y="6400800"/>
-            <a:ext cx="731520" cy="365760"/>
+            <a:off x="10972800" y="6446520"/>
+            <a:ext cx="731520" cy="320040"/>
           </a:xfrm>
           <a:prstGeom prst="rect">
             <a:avLst/>
@@ -3239,7 +3238,7 @@
               </a:defRPr>
             </a:pPr>
             <a:r>
-              <a:t>5</a:t>
+              <a:t>1</a:t>
             </a:r>
           </a:p>
         </p:txBody>
@@ -3252,7 +3251,7 @@
         </p:nvSpPr>
         <p:spPr>
           <a:xfrm>
-            <a:off x="731520" y="1371600"/>
+            <a:off x="731520" y="1280160"/>
             <a:ext cx="3383280" cy="2011680"/>
           </a:xfrm>
           <a:prstGeom prst="roundRect">
@@ -3286,14 +3285,14 @@
           <a:lstStyle/>
           <a:p>
             <a:pPr algn="ctr">
-              <a:defRPr sz="1500" b="1">
+              <a:defRPr sz="1400" b="1">
                 <a:solidFill>
                   <a:srgbClr val="DC2626"/>
                 </a:solidFill>
               </a:defRPr>
             </a:pPr>
             <a:r>
-              <a:t>🏥 Machine / Acquisition</a:t>
+              <a:t>Machine / Acquisition</a:t>
             </a:r>
           </a:p>
           <a:p>
@@ -3301,7 +3300,7 @@
               <a:spcBef>
                 <a:spcPts val="400"/>
               </a:spcBef>
-              <a:defRPr sz="1200">
+              <a:defRPr sz="1100">
                 <a:solidFill>
                   <a:srgbClr val="1E293B"/>
                 </a:solidFill>
@@ -3316,7 +3315,7 @@
               <a:spcBef>
                 <a:spcPts val="400"/>
               </a:spcBef>
-              <a:defRPr sz="1200">
+              <a:defRPr sz="1100">
                 <a:solidFill>
                   <a:srgbClr val="1E293B"/>
                 </a:solidFill>
@@ -3331,7 +3330,7 @@
               <a:spcBef>
                 <a:spcPts val="400"/>
               </a:spcBef>
-              <a:defRPr sz="1200">
+              <a:defRPr sz="1100">
                 <a:solidFill>
                   <a:srgbClr val="1E293B"/>
                 </a:solidFill>
@@ -3351,7 +3350,7 @@
         </p:nvSpPr>
         <p:spPr>
           <a:xfrm>
-            <a:off x="4389120" y="1371600"/>
+            <a:off x="4389120" y="1280160"/>
             <a:ext cx="3383280" cy="2011680"/>
           </a:xfrm>
           <a:prstGeom prst="roundRect">
@@ -3385,14 +3384,14 @@
           <a:lstStyle/>
           <a:p>
             <a:pPr algn="ctr">
-              <a:defRPr sz="1500" b="1">
+              <a:defRPr sz="1400" b="1">
                 <a:solidFill>
                   <a:srgbClr val="D97706"/>
                 </a:solidFill>
               </a:defRPr>
             </a:pPr>
             <a:r>
-              <a:t>🧠 Software / AI</a:t>
+              <a:t>Software / AI</a:t>
             </a:r>
           </a:p>
           <a:p>
@@ -3400,7 +3399,7 @@
               <a:spcBef>
                 <a:spcPts val="400"/>
               </a:spcBef>
-              <a:defRPr sz="1200">
+              <a:defRPr sz="1100">
                 <a:solidFill>
                   <a:srgbClr val="1E293B"/>
                 </a:solidFill>
@@ -3415,7 +3414,7 @@
               <a:spcBef>
                 <a:spcPts val="400"/>
               </a:spcBef>
-              <a:defRPr sz="1200">
+              <a:defRPr sz="1100">
                 <a:solidFill>
                   <a:srgbClr val="1E293B"/>
                 </a:solidFill>
@@ -3430,7 +3429,7 @@
               <a:spcBef>
                 <a:spcPts val="400"/>
               </a:spcBef>
-              <a:defRPr sz="1200">
+              <a:defRPr sz="1100">
                 <a:solidFill>
                   <a:srgbClr val="1E293B"/>
                 </a:solidFill>
@@ -3450,7 +3449,7 @@
         </p:nvSpPr>
         <p:spPr>
           <a:xfrm>
-            <a:off x="8046720" y="1371600"/>
+            <a:off x="8046720" y="1280160"/>
             <a:ext cx="3383280" cy="2011680"/>
           </a:xfrm>
           <a:prstGeom prst="roundRect">
@@ -3484,14 +3483,14 @@
           <a:lstStyle/>
           <a:p>
             <a:pPr algn="ctr">
-              <a:defRPr sz="1500" b="1">
+              <a:defRPr sz="1400" b="1">
                 <a:solidFill>
                   <a:srgbClr val="1E3A8A"/>
                 </a:solidFill>
               </a:defRPr>
             </a:pPr>
             <a:r>
-              <a:t>👨‍⚕️ Medical Doctor</a:t>
+              <a:t>Medical Doctor</a:t>
             </a:r>
           </a:p>
           <a:p>
@@ -3499,7 +3498,7 @@
               <a:spcBef>
                 <a:spcPts val="400"/>
               </a:spcBef>
-              <a:defRPr sz="1200">
+              <a:defRPr sz="1100">
                 <a:solidFill>
                   <a:srgbClr val="1E293B"/>
                 </a:solidFill>
@@ -3514,7 +3513,7 @@
               <a:spcBef>
                 <a:spcPts val="400"/>
               </a:spcBef>
-              <a:defRPr sz="1200">
+              <a:defRPr sz="1100">
                 <a:solidFill>
                   <a:srgbClr val="1E293B"/>
                 </a:solidFill>
@@ -3529,7 +3528,7 @@
               <a:spcBef>
                 <a:spcPts val="400"/>
               </a:spcBef>
-              <a:defRPr sz="1200">
+              <a:defRPr sz="1100">
                 <a:solidFill>
                   <a:srgbClr val="1E293B"/>
                 </a:solidFill>
@@ -3549,8 +3548,8 @@
         </p:nvSpPr>
         <p:spPr>
           <a:xfrm>
-            <a:off x="731520" y="3657600"/>
-            <a:ext cx="10698480" cy="1645920"/>
+            <a:off x="731520" y="3566160"/>
+            <a:ext cx="10698480" cy="1691640"/>
           </a:xfrm>
           <a:prstGeom prst="roundRect">
             <a:avLst/>
@@ -3665,7 +3664,7 @@
           <a:lstStyle/>
           <a:p>
             <a:pPr algn="ctr">
-              <a:defRPr sz="1600" b="1">
+              <a:defRPr sz="1550" b="1">
                 <a:solidFill>
                   <a:srgbClr val="FFFFFF"/>
                 </a:solidFill>
@@ -3718,7 +3717,7 @@
           <a:lstStyle/>
           <a:p>
             <a:pPr>
-              <a:defRPr sz="1400" b="1">
+              <a:defRPr sz="1300" b="1">
                 <a:solidFill>
                   <a:srgbClr val="0F2942"/>
                 </a:solidFill>
@@ -3753,7 +3752,7 @@
           <a:lstStyle/>
           <a:p>
             <a:pPr>
-              <a:defRPr sz="2200" b="1">
+              <a:defRPr sz="2100" b="1">
                 <a:solidFill>
                   <a:srgbClr val="1E3A8A"/>
                 </a:solidFill>
@@ -3765,7 +3764,7 @@
           </a:p>
           <a:p>
             <a:pPr>
-              <a:defRPr sz="1300">
+              <a:defRPr sz="1200">
                 <a:solidFill>
                   <a:srgbClr val="64748B"/>
                 </a:solidFill>
@@ -3785,8 +3784,8 @@
         </p:nvSpPr>
         <p:spPr>
           <a:xfrm>
-            <a:off x="731520" y="6400800"/>
-            <a:ext cx="4572000" cy="365760"/>
+            <a:off x="731520" y="6446520"/>
+            <a:ext cx="5486400" cy="320040"/>
           </a:xfrm>
           <a:prstGeom prst="rect">
             <a:avLst/>
@@ -3820,8 +3819,8 @@
         </p:nvSpPr>
         <p:spPr>
           <a:xfrm>
-            <a:off x="11155680" y="6400800"/>
-            <a:ext cx="731520" cy="365760"/>
+            <a:off x="10972800" y="6446520"/>
+            <a:ext cx="731520" cy="320040"/>
           </a:xfrm>
           <a:prstGeom prst="rect">
             <a:avLst/>
@@ -3842,7 +3841,7 @@
               </a:defRPr>
             </a:pPr>
             <a:r>
-              <a:t>6</a:t>
+              <a:t>2</a:t>
             </a:r>
           </a:p>
         </p:txBody>
@@ -3887,7 +3886,7 @@
           <a:lstStyle/>
           <a:p>
             <a:pPr algn="ctr">
-              <a:defRPr sz="1300" b="1">
+              <a:defRPr sz="1200" b="1">
                 <a:solidFill>
                   <a:srgbClr val="FFFFFF"/>
                 </a:solidFill>
@@ -3963,7 +3962,7 @@
           <a:lstStyle/>
           <a:p>
             <a:pPr algn="ctr">
-              <a:defRPr sz="1500" b="1">
+              <a:defRPr sz="1400" b="1">
                 <a:solidFill>
                   <a:srgbClr val="FFFFFF"/>
                 </a:solidFill>
@@ -3976,9 +3975,9 @@
           <a:p>
             <a:pPr>
               <a:spcBef>
-                <a:spcPts val="400"/>
+                <a:spcPts val="300"/>
               </a:spcBef>
-              <a:defRPr sz="1100">
+              <a:defRPr sz="1050">
                 <a:solidFill>
                   <a:srgbClr val="FFFFFF"/>
                 </a:solidFill>
@@ -4034,7 +4033,7 @@
           <a:lstStyle/>
           <a:p>
             <a:pPr algn="ctr">
-              <a:defRPr sz="1500" b="1">
+              <a:defRPr sz="1400" b="1">
                 <a:solidFill>
                   <a:srgbClr val="FFFFFF"/>
                 </a:solidFill>
@@ -4047,9 +4046,9 @@
           <a:p>
             <a:pPr>
               <a:spcBef>
-                <a:spcPts val="400"/>
+                <a:spcPts val="300"/>
               </a:spcBef>
-              <a:defRPr sz="1100">
+              <a:defRPr sz="1050">
                 <a:solidFill>
                   <a:srgbClr val="FFFFFF"/>
                 </a:solidFill>
@@ -4105,7 +4104,7 @@
           <a:lstStyle/>
           <a:p>
             <a:pPr algn="ctr">
-              <a:defRPr sz="1500" b="1">
+              <a:defRPr sz="1400" b="1">
                 <a:solidFill>
                   <a:srgbClr val="FFFFFF"/>
                 </a:solidFill>
@@ -4118,9 +4117,9 @@
           <a:p>
             <a:pPr>
               <a:spcBef>
-                <a:spcPts val="400"/>
+                <a:spcPts val="300"/>
               </a:spcBef>
-              <a:defRPr sz="1100">
+              <a:defRPr sz="1050">
                 <a:solidFill>
                   <a:srgbClr val="FFFFFF"/>
                 </a:solidFill>
@@ -4437,7 +4436,7 @@
           <a:lstStyle/>
           <a:p>
             <a:pPr>
-              <a:defRPr sz="1400" b="1">
+              <a:defRPr sz="1300" b="1">
                 <a:solidFill>
                   <a:srgbClr val="0F2942"/>
                 </a:solidFill>
@@ -4472,7 +4471,7 @@
           <a:lstStyle/>
           <a:p>
             <a:pPr>
-              <a:defRPr sz="2200" b="1">
+              <a:defRPr sz="2100" b="1">
                 <a:solidFill>
                   <a:srgbClr val="1E3A8A"/>
                 </a:solidFill>
@@ -4484,7 +4483,7 @@
           </a:p>
           <a:p>
             <a:pPr>
-              <a:defRPr sz="1300">
+              <a:defRPr sz="1200">
                 <a:solidFill>
                   <a:srgbClr val="64748B"/>
                 </a:solidFill>
@@ -4504,8 +4503,8 @@
         </p:nvSpPr>
         <p:spPr>
           <a:xfrm>
-            <a:off x="731520" y="6400800"/>
-            <a:ext cx="4572000" cy="365760"/>
+            <a:off x="731520" y="6446520"/>
+            <a:ext cx="5486400" cy="320040"/>
           </a:xfrm>
           <a:prstGeom prst="rect">
             <a:avLst/>
@@ -4539,8 +4538,8 @@
         </p:nvSpPr>
         <p:spPr>
           <a:xfrm>
-            <a:off x="11155680" y="6400800"/>
-            <a:ext cx="731520" cy="365760"/>
+            <a:off x="10972800" y="6446520"/>
+            <a:ext cx="731520" cy="320040"/>
           </a:xfrm>
           <a:prstGeom prst="rect">
             <a:avLst/>
@@ -4561,7 +4560,7 @@
               </a:defRPr>
             </a:pPr>
             <a:r>
-              <a:t>7</a:t>
+              <a:t>3</a:t>
             </a:r>
           </a:p>
         </p:txBody>
@@ -4574,8 +4573,8 @@
         </p:nvSpPr>
         <p:spPr>
           <a:xfrm>
-            <a:off x="731520" y="1188720"/>
-            <a:ext cx="5257800" cy="2286000"/>
+            <a:off x="731520" y="1143000"/>
+            <a:ext cx="5257800" cy="2423160"/>
           </a:xfrm>
           <a:prstGeom prst="roundRect">
             <a:avLst/>
@@ -4608,7 +4607,7 @@
           <a:lstStyle/>
           <a:p>
             <a:pPr algn="ctr">
-              <a:defRPr sz="1400" b="1">
+              <a:defRPr sz="1300" b="1">
                 <a:solidFill>
                   <a:srgbClr val="1E3A8A"/>
                 </a:solidFill>
@@ -4620,26 +4619,50 @@
           </a:p>
         </p:txBody>
       </p:sp>
-      <p:sp>
-        <p:nvSpPr>
-          <p:cNvPr id="7" name="Rounded Rectangle 6"/>
+      <p:pic>
+        <p:nvPicPr>
+          <p:cNvPr id="7" name="Picture 6" descr="card1_full_visual.png"/>
+          <p:cNvPicPr>
+            <a:picLocks noChangeAspect="1"/>
+          </p:cNvPicPr>
+          <p:nvPr/>
+        </p:nvPicPr>
+        <p:blipFill>
+          <a:blip r:embed="rId2"/>
+          <a:stretch>
+            <a:fillRect/>
+          </a:stretch>
+        </p:blipFill>
+        <p:spPr>
+          <a:xfrm>
+            <a:off x="841248" y="1527048"/>
+            <a:ext cx="5038344" cy="1947672"/>
+          </a:xfrm>
+          <a:prstGeom prst="rect">
+            <a:avLst/>
+          </a:prstGeom>
+        </p:spPr>
+      </p:pic>
+      <p:sp>
+        <p:nvSpPr>
+          <p:cNvPr id="8" name="Rounded Rectangle 7"/>
           <p:cNvSpPr/>
           <p:nvPr/>
         </p:nvSpPr>
         <p:spPr>
           <a:xfrm>
-            <a:off x="868680" y="1600200"/>
-            <a:ext cx="2377440" cy="1691640"/>
+            <a:off x="6172200" y="1143000"/>
+            <a:ext cx="5257800" cy="2423160"/>
           </a:xfrm>
           <a:prstGeom prst="roundRect">
             <a:avLst/>
           </a:prstGeom>
           <a:solidFill>
-            <a:srgbClr val="FEE2E2"/>
+            <a:srgbClr val="F8FAFC"/>
           </a:solidFill>
-          <a:ln>
+          <a:ln w="19050">
             <a:solidFill>
-              <a:srgbClr val="DC2626"/>
+              <a:srgbClr val="E2E8F0"/>
             </a:solidFill>
           </a:ln>
         </p:spPr>
@@ -4662,53 +4685,62 @@
           <a:lstStyle/>
           <a:p>
             <a:pPr algn="ctr">
-              <a:defRPr sz="1100" b="1">
-                <a:solidFill>
-                  <a:srgbClr val="DC2626"/>
+              <a:defRPr sz="1300" b="1">
+                <a:solidFill>
+                  <a:srgbClr val="1E3A8A"/>
                 </a:solidFill>
               </a:defRPr>
             </a:pPr>
             <a:r>
-              <a:t>✖ Without</a:t>
-            </a:r>
-          </a:p>
-          <a:p>
-            <a:pPr>
-              <a:spcBef>
-                <a:spcPts val="300"/>
-              </a:spcBef>
-              <a:defRPr sz="1000">
-                <a:solidFill>
-                  <a:srgbClr val="1E293B"/>
-                </a:solidFill>
-              </a:defRPr>
-            </a:pPr>
-            <a:r>
-              <a:t>Same CT scan, 3 readers delineate different margins (inter-observer Dice 65–75%)</a:t>
-            </a:r>
-          </a:p>
-        </p:txBody>
-      </p:sp>
-      <p:sp>
-        <p:nvSpPr>
-          <p:cNvPr id="8" name="Rounded Rectangle 7"/>
+              <a:t>Higher Segmentation &amp; Diagnostic Accuracy</a:t>
+            </a:r>
+          </a:p>
+        </p:txBody>
+      </p:sp>
+      <p:pic>
+        <p:nvPicPr>
+          <p:cNvPr id="9" name="Picture 8" descr="card2_full_visual.png"/>
+          <p:cNvPicPr>
+            <a:picLocks noChangeAspect="1"/>
+          </p:cNvPicPr>
+          <p:nvPr/>
+        </p:nvPicPr>
+        <p:blipFill>
+          <a:blip r:embed="rId3"/>
+          <a:stretch>
+            <a:fillRect/>
+          </a:stretch>
+        </p:blipFill>
+        <p:spPr>
+          <a:xfrm>
+            <a:off x="6281928" y="1527048"/>
+            <a:ext cx="5038344" cy="1947672"/>
+          </a:xfrm>
+          <a:prstGeom prst="rect">
+            <a:avLst/>
+          </a:prstGeom>
+        </p:spPr>
+      </p:pic>
+      <p:sp>
+        <p:nvSpPr>
+          <p:cNvPr id="10" name="Rounded Rectangle 9"/>
           <p:cNvSpPr/>
           <p:nvPr/>
         </p:nvSpPr>
         <p:spPr>
           <a:xfrm>
-            <a:off x="3383280" y="1600200"/>
-            <a:ext cx="2468880" cy="1691640"/>
+            <a:off x="731520" y="3703320"/>
+            <a:ext cx="5257800" cy="2423160"/>
           </a:xfrm>
           <a:prstGeom prst="roundRect">
             <a:avLst/>
           </a:prstGeom>
           <a:solidFill>
-            <a:srgbClr val="DCFCE7"/>
+            <a:srgbClr val="F8FAFC"/>
           </a:solidFill>
-          <a:ln>
+          <a:ln w="19050">
             <a:solidFill>
-              <a:srgbClr val="15803D"/>
+              <a:srgbClr val="E2E8F0"/>
             </a:solidFill>
           </a:ln>
         </p:spPr>
@@ -4731,43 +4763,52 @@
           <a:lstStyle/>
           <a:p>
             <a:pPr algn="ctr">
-              <a:defRPr sz="1100" b="1">
-                <a:solidFill>
-                  <a:srgbClr val="15803D"/>
+              <a:defRPr sz="1300" b="1">
+                <a:solidFill>
+                  <a:srgbClr val="1E3A8A"/>
                 </a:solidFill>
               </a:defRPr>
             </a:pPr>
             <a:r>
-              <a:t>✔ With Mod-Seg-SE(2)</a:t>
-            </a:r>
-          </a:p>
-          <a:p>
-            <a:pPr>
-              <a:spcBef>
-                <a:spcPts val="300"/>
-              </a:spcBef>
-              <a:defRPr sz="1000">
-                <a:solidFill>
-                  <a:srgbClr val="1E293B"/>
-                </a:solidFill>
-              </a:defRPr>
-            </a:pPr>
-            <a:r>
-              <a:t>One reproducible consensus outline + 6-model agreement heatmap (Dice 84.2%)</a:t>
-            </a:r>
-          </a:p>
-        </p:txBody>
-      </p:sp>
-      <p:sp>
-        <p:nvSpPr>
-          <p:cNvPr id="9" name="Rounded Rectangle 8"/>
+              <a:t>Stable Delineation Under Head Tilt &amp; Rotation</a:t>
+            </a:r>
+          </a:p>
+        </p:txBody>
+      </p:sp>
+      <p:pic>
+        <p:nvPicPr>
+          <p:cNvPr id="11" name="Picture 10" descr="card3_full_visual.png"/>
+          <p:cNvPicPr>
+            <a:picLocks noChangeAspect="1"/>
+          </p:cNvPicPr>
+          <p:nvPr/>
+        </p:nvPicPr>
+        <p:blipFill>
+          <a:blip r:embed="rId4"/>
+          <a:stretch>
+            <a:fillRect/>
+          </a:stretch>
+        </p:blipFill>
+        <p:spPr>
+          <a:xfrm>
+            <a:off x="841248" y="4087368"/>
+            <a:ext cx="5038344" cy="1947672"/>
+          </a:xfrm>
+          <a:prstGeom prst="rect">
+            <a:avLst/>
+          </a:prstGeom>
+        </p:spPr>
+      </p:pic>
+      <p:sp>
+        <p:nvSpPr>
+          <p:cNvPr id="12" name="Rounded Rectangle 11"/>
           <p:cNvSpPr/>
           <p:nvPr/>
         </p:nvSpPr>
         <p:spPr>
           <a:xfrm>
-            <a:off x="6172200" y="1188720"/>
-            <a:ext cx="5257800" cy="2286000"/>
+            <a:off x="6172200" y="3703320"/>
+            <a:ext cx="5257800" cy="2423160"/>
           </a:xfrm>
           <a:prstGeom prst="roundRect">
             <a:avLst/>
@@ -4800,552 +4841,42 @@
           <a:lstStyle/>
           <a:p>
             <a:pPr algn="ctr">
-              <a:defRPr sz="1400" b="1">
+              <a:defRPr sz="1300" b="1">
                 <a:solidFill>
                   <a:srgbClr val="1E3A8A"/>
                 </a:solidFill>
               </a:defRPr>
             </a:pPr>
             <a:r>
-              <a:t>Higher Segmentation &amp; Diagnostic Accuracy</a:t>
-            </a:r>
-          </a:p>
-        </p:txBody>
-      </p:sp>
-      <p:sp>
-        <p:nvSpPr>
-          <p:cNvPr id="10" name="Rounded Rectangle 9"/>
-          <p:cNvSpPr/>
+              <a:t>Consistent, Structured Volumetric Reporting</a:t>
+            </a:r>
+          </a:p>
+        </p:txBody>
+      </p:sp>
+      <p:pic>
+        <p:nvPicPr>
+          <p:cNvPr id="13" name="Picture 12" descr="card4_full_visual.png"/>
+          <p:cNvPicPr>
+            <a:picLocks noChangeAspect="1"/>
+          </p:cNvPicPr>
           <p:nvPr/>
-        </p:nvSpPr>
-        <p:spPr>
-          <a:xfrm>
-            <a:off x="6309360" y="1600200"/>
-            <a:ext cx="2377440" cy="1691640"/>
-          </a:xfrm>
-          <a:prstGeom prst="roundRect">
+        </p:nvPicPr>
+        <p:blipFill>
+          <a:blip r:embed="rId5"/>
+          <a:stretch>
+            <a:fillRect/>
+          </a:stretch>
+        </p:blipFill>
+        <p:spPr>
+          <a:xfrm>
+            <a:off x="6281928" y="4087368"/>
+            <a:ext cx="5038344" cy="1947672"/>
+          </a:xfrm>
+          <a:prstGeom prst="rect">
             <a:avLst/>
           </a:prstGeom>
-          <a:solidFill>
-            <a:srgbClr val="FEE2E2"/>
-          </a:solidFill>
-          <a:ln>
-            <a:solidFill>
-              <a:srgbClr val="DC2626"/>
-            </a:solidFill>
-          </a:ln>
-        </p:spPr>
-        <p:style>
-          <a:lnRef idx="1">
-            <a:schemeClr val="accent1"/>
-          </a:lnRef>
-          <a:fillRef idx="3">
-            <a:schemeClr val="accent1"/>
-          </a:fillRef>
-          <a:effectRef idx="2">
-            <a:schemeClr val="accent1"/>
-          </a:effectRef>
-          <a:fontRef idx="minor">
-            <a:schemeClr val="lt1"/>
-          </a:fontRef>
-        </p:style>
-        <p:txBody>
-          <a:bodyPr rtlCol="0" anchor="ctr" wrap="square"/>
-          <a:lstStyle/>
-          <a:p>
-            <a:pPr algn="ctr">
-              <a:defRPr sz="1100" b="1">
-                <a:solidFill>
-                  <a:srgbClr val="DC2626"/>
-                </a:solidFill>
-              </a:defRPr>
-            </a:pPr>
-            <a:r>
-              <a:t>✖ Without</a:t>
-            </a:r>
-          </a:p>
-          <a:p>
-            <a:pPr>
-              <a:spcBef>
-                <a:spcPts val="300"/>
-              </a:spcBef>
-              <a:defRPr sz="1000">
-                <a:solidFill>
-                  <a:srgbClr val="1E293B"/>
-                </a:solidFill>
-              </a:defRPr>
-            </a:pPr>
-            <a:r>
-              <a:t>Standard U-Net: 74.2% Dice</a:t>
-            </a:r>
-            <a:br/>
-            <a:r>
-              <a:t>Attention U-Net: 76.5% Dice</a:t>
-            </a:r>
-            <a:br/>
-            <a:r>
-              <a:t>High false positive rate</a:t>
-            </a:r>
-          </a:p>
-        </p:txBody>
-      </p:sp>
-      <p:sp>
-        <p:nvSpPr>
-          <p:cNvPr id="11" name="Rounded Rectangle 10"/>
-          <p:cNvSpPr/>
-          <p:nvPr/>
-        </p:nvSpPr>
-        <p:spPr>
-          <a:xfrm>
-            <a:off x="8823960" y="1600200"/>
-            <a:ext cx="2468880" cy="1691640"/>
-          </a:xfrm>
-          <a:prstGeom prst="roundRect">
-            <a:avLst/>
-          </a:prstGeom>
-          <a:solidFill>
-            <a:srgbClr val="DCFCE7"/>
-          </a:solidFill>
-          <a:ln>
-            <a:solidFill>
-              <a:srgbClr val="15803D"/>
-            </a:solidFill>
-          </a:ln>
-        </p:spPr>
-        <p:style>
-          <a:lnRef idx="1">
-            <a:schemeClr val="accent1"/>
-          </a:lnRef>
-          <a:fillRef idx="3">
-            <a:schemeClr val="accent1"/>
-          </a:fillRef>
-          <a:effectRef idx="2">
-            <a:schemeClr val="accent1"/>
-          </a:effectRef>
-          <a:fontRef idx="minor">
-            <a:schemeClr val="lt1"/>
-          </a:fontRef>
-        </p:style>
-        <p:txBody>
-          <a:bodyPr rtlCol="0" anchor="ctr" wrap="square"/>
-          <a:lstStyle/>
-          <a:p>
-            <a:pPr algn="ctr">
-              <a:defRPr sz="1100" b="1">
-                <a:solidFill>
-                  <a:srgbClr val="15803D"/>
-                </a:solidFill>
-              </a:defRPr>
-            </a:pPr>
-            <a:r>
-              <a:t>✔ With Mod-Seg-SE(2)</a:t>
-            </a:r>
-          </a:p>
-          <a:p>
-            <a:pPr>
-              <a:spcBef>
-                <a:spcPts val="300"/>
-              </a:spcBef>
-              <a:defRPr sz="1000">
-                <a:solidFill>
-                  <a:srgbClr val="1E293B"/>
-                </a:solidFill>
-              </a:defRPr>
-            </a:pPr>
-            <a:r>
-              <a:t>Mod-Seg-SE(2): 84.2% Dice | 73.1% IoU</a:t>
-            </a:r>
-            <a:br/>
-            <a:r>
-              <a:t>SOTA performance on challenging NCCT</a:t>
-            </a:r>
-          </a:p>
-        </p:txBody>
-      </p:sp>
-      <p:sp>
-        <p:nvSpPr>
-          <p:cNvPr id="12" name="Rounded Rectangle 11"/>
-          <p:cNvSpPr/>
-          <p:nvPr/>
-        </p:nvSpPr>
-        <p:spPr>
-          <a:xfrm>
-            <a:off x="731520" y="3657600"/>
-            <a:ext cx="5257800" cy="2286000"/>
-          </a:xfrm>
-          <a:prstGeom prst="roundRect">
-            <a:avLst/>
-          </a:prstGeom>
-          <a:solidFill>
-            <a:srgbClr val="F8FAFC"/>
-          </a:solidFill>
-          <a:ln w="19050">
-            <a:solidFill>
-              <a:srgbClr val="E2E8F0"/>
-            </a:solidFill>
-          </a:ln>
-        </p:spPr>
-        <p:style>
-          <a:lnRef idx="1">
-            <a:schemeClr val="accent1"/>
-          </a:lnRef>
-          <a:fillRef idx="3">
-            <a:schemeClr val="accent1"/>
-          </a:fillRef>
-          <a:effectRef idx="2">
-            <a:schemeClr val="accent1"/>
-          </a:effectRef>
-          <a:fontRef idx="minor">
-            <a:schemeClr val="lt1"/>
-          </a:fontRef>
-        </p:style>
-        <p:txBody>
-          <a:bodyPr rtlCol="0" anchor="ctr" wrap="square"/>
-          <a:lstStyle/>
-          <a:p>
-            <a:pPr algn="ctr">
-              <a:defRPr sz="1400" b="1">
-                <a:solidFill>
-                  <a:srgbClr val="1E3A8A"/>
-                </a:solidFill>
-              </a:defRPr>
-            </a:pPr>
-            <a:r>
-              <a:t>Stable Delineation Under Head Tilt &amp; Rotation</a:t>
-            </a:r>
-          </a:p>
-        </p:txBody>
-      </p:sp>
-      <p:sp>
-        <p:nvSpPr>
-          <p:cNvPr id="13" name="Rounded Rectangle 12"/>
-          <p:cNvSpPr/>
-          <p:nvPr/>
-        </p:nvSpPr>
-        <p:spPr>
-          <a:xfrm>
-            <a:off x="868680" y="4069080"/>
-            <a:ext cx="2377440" cy="1691640"/>
-          </a:xfrm>
-          <a:prstGeom prst="roundRect">
-            <a:avLst/>
-          </a:prstGeom>
-          <a:solidFill>
-            <a:srgbClr val="FEE2E2"/>
-          </a:solidFill>
-          <a:ln>
-            <a:solidFill>
-              <a:srgbClr val="DC2626"/>
-            </a:solidFill>
-          </a:ln>
-        </p:spPr>
-        <p:style>
-          <a:lnRef idx="1">
-            <a:schemeClr val="accent1"/>
-          </a:lnRef>
-          <a:fillRef idx="3">
-            <a:schemeClr val="accent1"/>
-          </a:fillRef>
-          <a:effectRef idx="2">
-            <a:schemeClr val="accent1"/>
-          </a:effectRef>
-          <a:fontRef idx="minor">
-            <a:schemeClr val="lt1"/>
-          </a:fontRef>
-        </p:style>
-        <p:txBody>
-          <a:bodyPr rtlCol="0" anchor="ctr" wrap="square"/>
-          <a:lstStyle/>
-          <a:p>
-            <a:pPr algn="ctr">
-              <a:defRPr sz="1100" b="1">
-                <a:solidFill>
-                  <a:srgbClr val="DC2626"/>
-                </a:solidFill>
-              </a:defRPr>
-            </a:pPr>
-            <a:r>
-              <a:t>✖ Without</a:t>
-            </a:r>
-          </a:p>
-          <a:p>
-            <a:pPr>
-              <a:spcBef>
-                <a:spcPts val="300"/>
-              </a:spcBef>
-              <a:defRPr sz="1000">
-                <a:solidFill>
-                  <a:srgbClr val="1E293B"/>
-                </a:solidFill>
-              </a:defRPr>
-            </a:pPr>
-            <a:r>
-              <a:t>Tilting head or gantry by 45° drops conventional CNN Dice by 12–18%</a:t>
-            </a:r>
-          </a:p>
-        </p:txBody>
-      </p:sp>
-      <p:sp>
-        <p:nvSpPr>
-          <p:cNvPr id="14" name="Rounded Rectangle 13"/>
-          <p:cNvSpPr/>
-          <p:nvPr/>
-        </p:nvSpPr>
-        <p:spPr>
-          <a:xfrm>
-            <a:off x="3383280" y="4069080"/>
-            <a:ext cx="2468880" cy="1691640"/>
-          </a:xfrm>
-          <a:prstGeom prst="roundRect">
-            <a:avLst/>
-          </a:prstGeom>
-          <a:solidFill>
-            <a:srgbClr val="DCFCE7"/>
-          </a:solidFill>
-          <a:ln>
-            <a:solidFill>
-              <a:srgbClr val="15803D"/>
-            </a:solidFill>
-          </a:ln>
-        </p:spPr>
-        <p:style>
-          <a:lnRef idx="1">
-            <a:schemeClr val="accent1"/>
-          </a:lnRef>
-          <a:fillRef idx="3">
-            <a:schemeClr val="accent1"/>
-          </a:fillRef>
-          <a:effectRef idx="2">
-            <a:schemeClr val="accent1"/>
-          </a:effectRef>
-          <a:fontRef idx="minor">
-            <a:schemeClr val="lt1"/>
-          </a:fontRef>
-        </p:style>
-        <p:txBody>
-          <a:bodyPr rtlCol="0" anchor="ctr" wrap="square"/>
-          <a:lstStyle/>
-          <a:p>
-            <a:pPr algn="ctr">
-              <a:defRPr sz="1100" b="1">
-                <a:solidFill>
-                  <a:srgbClr val="15803D"/>
-                </a:solidFill>
-              </a:defRPr>
-            </a:pPr>
-            <a:r>
-              <a:t>✔ With Mod-Seg-SE(2)</a:t>
-            </a:r>
-          </a:p>
-          <a:p>
-            <a:pPr>
-              <a:spcBef>
-                <a:spcPts val="300"/>
-              </a:spcBef>
-              <a:defRPr sz="1000">
-                <a:solidFill>
-                  <a:srgbClr val="1E293B"/>
-                </a:solidFill>
-              </a:defRPr>
-            </a:pPr>
-            <a:r>
-              <a:t>Rotation-Equivariant (N=8 group convolutions): identical boundary at any angle</a:t>
-            </a:r>
-          </a:p>
-        </p:txBody>
-      </p:sp>
-      <p:sp>
-        <p:nvSpPr>
-          <p:cNvPr id="15" name="Rounded Rectangle 14"/>
-          <p:cNvSpPr/>
-          <p:nvPr/>
-        </p:nvSpPr>
-        <p:spPr>
-          <a:xfrm>
-            <a:off x="6172200" y="3657600"/>
-            <a:ext cx="5257800" cy="2286000"/>
-          </a:xfrm>
-          <a:prstGeom prst="roundRect">
-            <a:avLst/>
-          </a:prstGeom>
-          <a:solidFill>
-            <a:srgbClr val="F8FAFC"/>
-          </a:solidFill>
-          <a:ln w="19050">
-            <a:solidFill>
-              <a:srgbClr val="E2E8F0"/>
-            </a:solidFill>
-          </a:ln>
-        </p:spPr>
-        <p:style>
-          <a:lnRef idx="1">
-            <a:schemeClr val="accent1"/>
-          </a:lnRef>
-          <a:fillRef idx="3">
-            <a:schemeClr val="accent1"/>
-          </a:fillRef>
-          <a:effectRef idx="2">
-            <a:schemeClr val="accent1"/>
-          </a:effectRef>
-          <a:fontRef idx="minor">
-            <a:schemeClr val="lt1"/>
-          </a:fontRef>
-        </p:style>
-        <p:txBody>
-          <a:bodyPr rtlCol="0" anchor="ctr" wrap="square"/>
-          <a:lstStyle/>
-          <a:p>
-            <a:pPr algn="ctr">
-              <a:defRPr sz="1400" b="1">
-                <a:solidFill>
-                  <a:srgbClr val="1E3A8A"/>
-                </a:solidFill>
-              </a:defRPr>
-            </a:pPr>
-            <a:r>
-              <a:t>Consistent, Structured Volumetric Reporting</a:t>
-            </a:r>
-          </a:p>
-        </p:txBody>
-      </p:sp>
-      <p:sp>
-        <p:nvSpPr>
-          <p:cNvPr id="16" name="Rounded Rectangle 15"/>
-          <p:cNvSpPr/>
-          <p:nvPr/>
-        </p:nvSpPr>
-        <p:spPr>
-          <a:xfrm>
-            <a:off x="6309360" y="4069080"/>
-            <a:ext cx="2377440" cy="1691640"/>
-          </a:xfrm>
-          <a:prstGeom prst="roundRect">
-            <a:avLst/>
-          </a:prstGeom>
-          <a:solidFill>
-            <a:srgbClr val="FEE2E2"/>
-          </a:solidFill>
-          <a:ln>
-            <a:solidFill>
-              <a:srgbClr val="DC2626"/>
-            </a:solidFill>
-          </a:ln>
-        </p:spPr>
-        <p:style>
-          <a:lnRef idx="1">
-            <a:schemeClr val="accent1"/>
-          </a:lnRef>
-          <a:fillRef idx="3">
-            <a:schemeClr val="accent1"/>
-          </a:fillRef>
-          <a:effectRef idx="2">
-            <a:schemeClr val="accent1"/>
-          </a:effectRef>
-          <a:fontRef idx="minor">
-            <a:schemeClr val="lt1"/>
-          </a:fontRef>
-        </p:style>
-        <p:txBody>
-          <a:bodyPr rtlCol="0" anchor="ctr" wrap="square"/>
-          <a:lstStyle/>
-          <a:p>
-            <a:pPr algn="ctr">
-              <a:defRPr sz="1100" b="1">
-                <a:solidFill>
-                  <a:srgbClr val="DC2626"/>
-                </a:solidFill>
-              </a:defRPr>
-            </a:pPr>
-            <a:r>
-              <a:t>✖ Without</a:t>
-            </a:r>
-          </a:p>
-          <a:p>
-            <a:pPr>
-              <a:spcBef>
-                <a:spcPts val="300"/>
-              </a:spcBef>
-              <a:defRPr sz="1000">
-                <a:solidFill>
-                  <a:srgbClr val="1E293B"/>
-                </a:solidFill>
-              </a:defRPr>
-            </a:pPr>
-            <a:r>
-              <a:t>Subjective free-text notes ('moderate mass effect in parietal lobe'), hard to compare</a:t>
-            </a:r>
-          </a:p>
-        </p:txBody>
-      </p:sp>
-      <p:sp>
-        <p:nvSpPr>
-          <p:cNvPr id="17" name="Rounded Rectangle 16"/>
-          <p:cNvSpPr/>
-          <p:nvPr/>
-        </p:nvSpPr>
-        <p:spPr>
-          <a:xfrm>
-            <a:off x="8823960" y="4069080"/>
-            <a:ext cx="2468880" cy="1691640"/>
-          </a:xfrm>
-          <a:prstGeom prst="roundRect">
-            <a:avLst/>
-          </a:prstGeom>
-          <a:solidFill>
-            <a:srgbClr val="DCFCE7"/>
-          </a:solidFill>
-          <a:ln>
-            <a:solidFill>
-              <a:srgbClr val="15803D"/>
-            </a:solidFill>
-          </a:ln>
-        </p:spPr>
-        <p:style>
-          <a:lnRef idx="1">
-            <a:schemeClr val="accent1"/>
-          </a:lnRef>
-          <a:fillRef idx="3">
-            <a:schemeClr val="accent1"/>
-          </a:fillRef>
-          <a:effectRef idx="2">
-            <a:schemeClr val="accent1"/>
-          </a:effectRef>
-          <a:fontRef idx="minor">
-            <a:schemeClr val="lt1"/>
-          </a:fontRef>
-        </p:style>
-        <p:txBody>
-          <a:bodyPr rtlCol="0" anchor="ctr" wrap="square"/>
-          <a:lstStyle/>
-          <a:p>
-            <a:pPr algn="ctr">
-              <a:defRPr sz="1100" b="1">
-                <a:solidFill>
-                  <a:srgbClr val="15803D"/>
-                </a:solidFill>
-              </a:defRPr>
-            </a:pPr>
-            <a:r>
-              <a:t>✔ With Mod-Seg-SE(2)</a:t>
-            </a:r>
-          </a:p>
-          <a:p>
-            <a:pPr>
-              <a:spcBef>
-                <a:spcPts val="300"/>
-              </a:spcBef>
-              <a:defRPr sz="1000">
-                <a:solidFill>
-                  <a:srgbClr val="1E293B"/>
-                </a:solidFill>
-              </a:defRPr>
-            </a:pPr>
-            <a:r>
-              <a:t>Automated 3D volume (mL), min/max lesion diameter, risk tier &amp; 1-click Word report</a:t>
-            </a:r>
-          </a:p>
-        </p:txBody>
-      </p:sp>
+        </p:spPr>
+      </p:pic>
     </p:spTree>
   </p:cSld>
   <p:clrMapOvr>
@@ -5387,7 +4918,7 @@
           <a:lstStyle/>
           <a:p>
             <a:pPr>
-              <a:defRPr sz="1400" b="1">
+              <a:defRPr sz="1300" b="1">
                 <a:solidFill>
                   <a:srgbClr val="0F2942"/>
                 </a:solidFill>
@@ -5422,26 +4953,26 @@
           <a:lstStyle/>
           <a:p>
             <a:pPr>
-              <a:defRPr sz="2200" b="1">
+              <a:defRPr sz="2100" b="1">
                 <a:solidFill>
                   <a:srgbClr val="1E3A8A"/>
                 </a:solidFill>
               </a:defRPr>
             </a:pPr>
             <a:r>
-              <a:t>Current Market Opportunity &amp; Clinical Positioning</a:t>
+              <a:t>Mod-Seg-SE(2) Architecture &amp; Pipeline Flow</a:t>
             </a:r>
           </a:p>
           <a:p>
             <a:pPr>
-              <a:defRPr sz="1300">
+              <a:defRPr sz="1200">
                 <a:solidFill>
                   <a:srgbClr val="64748B"/>
                 </a:solidFill>
               </a:defRPr>
             </a:pPr>
             <a:r>
-              <a:t>AI in Neuroimaging market projection: US$14.2 B by 2032 (Growth 28.5%/year)</a:t>
+              <a:t>Group Equivariant Convolutional Network (C8 / N=8 Rotations) with Multi-Model Consensus Engine</a:t>
             </a:r>
           </a:p>
         </p:txBody>
@@ -5454,8 +4985,8 @@
         </p:nvSpPr>
         <p:spPr>
           <a:xfrm>
-            <a:off x="731520" y="6400800"/>
-            <a:ext cx="4572000" cy="365760"/>
+            <a:off x="731520" y="6446520"/>
+            <a:ext cx="5486400" cy="320040"/>
           </a:xfrm>
           <a:prstGeom prst="rect">
             <a:avLst/>
@@ -5489,8 +5020,8 @@
         </p:nvSpPr>
         <p:spPr>
           <a:xfrm>
-            <a:off x="11155680" y="6400800"/>
-            <a:ext cx="731520" cy="365760"/>
+            <a:off x="10972800" y="6446520"/>
+            <a:ext cx="731520" cy="320040"/>
           </a:xfrm>
           <a:prstGeom prst="rect">
             <a:avLst/>
@@ -5511,1250 +5042,14 @@
               </a:defRPr>
             </a:pPr>
             <a:r>
-              <a:t>8</a:t>
-            </a:r>
-          </a:p>
-        </p:txBody>
-      </p:sp>
-      <p:graphicFrame>
-        <p:nvGraphicFramePr>
-          <p:cNvPr id="6" name="Table 5"/>
-          <p:cNvGraphicFramePr>
-            <a:graphicFrameLocks noGrp="1"/>
-          </p:cNvGraphicFramePr>
-          <p:nvPr/>
-        </p:nvGraphicFramePr>
-        <p:xfrm>
-          <a:off x="731520" y="1188720"/>
-          <a:ext cx="7589520" cy="4572000"/>
-        </p:xfrm>
-        <a:graphic>
-          <a:graphicData uri="http://schemas.openxmlformats.org/drawingml/2006/table">
-            <a:tbl>
-              <a:tblPr firstRow="1" bandRow="1">
-                <a:tableStyleId>{5C22544A-7EE6-4342-B048-85BDC9FD1C3A}</a:tableStyleId>
-              </a:tblPr>
-              <a:tblGrid>
-                <a:gridCol w="2834640"/>
-                <a:gridCol w="1188720"/>
-                <a:gridCol w="1188720"/>
-                <a:gridCol w="1188720"/>
-                <a:gridCol w="1188720"/>
-              </a:tblGrid>
-              <a:tr h="653142">
-                <a:tc>
-                  <a:txBody>
-                    <a:bodyPr/>
-                    <a:lstStyle/>
-                    <a:p>
-                      <a:pPr algn="ctr">
-                        <a:defRPr sz="1050" b="1">
-                          <a:solidFill>
-                            <a:srgbClr val="FFFFFF"/>
-                          </a:solidFill>
-                        </a:defRPr>
-                      </a:pPr>
-                      <a:r>
-                        <a:t>Capability / Feature</a:t>
-                      </a:r>
-                    </a:p>
-                  </a:txBody>
-                  <a:tcPr>
-                    <a:solidFill>
-                      <a:srgbClr val="0F2942"/>
-                    </a:solidFill>
-                  </a:tcPr>
-                </a:tc>
-                <a:tc>
-                  <a:txBody>
-                    <a:bodyPr/>
-                    <a:lstStyle/>
-                    <a:p>
-                      <a:pPr algn="ctr">
-                        <a:defRPr sz="1050" b="1">
-                          <a:solidFill>
-                            <a:srgbClr val="FFFFFF"/>
-                          </a:solidFill>
-                        </a:defRPr>
-                      </a:pPr>
-                      <a:r>
-                        <a:t>Stroke CAD</a:t>
-                      </a:r>
-                      <a:br/>
-                      <a:r>
-                        <a:t>(RapidAI/Viz)</a:t>
-                      </a:r>
-                    </a:p>
-                  </a:txBody>
-                  <a:tcPr>
-                    <a:solidFill>
-                      <a:srgbClr val="0F2942"/>
-                    </a:solidFill>
-                  </a:tcPr>
-                </a:tc>
-                <a:tc>
-                  <a:txBody>
-                    <a:bodyPr/>
-                    <a:lstStyle/>
-                    <a:p>
-                      <a:pPr algn="ctr">
-                        <a:defRPr sz="1050" b="1">
-                          <a:solidFill>
-                            <a:srgbClr val="FFFFFF"/>
-                          </a:solidFill>
-                        </a:defRPr>
-                      </a:pPr>
-                      <a:r>
-                        <a:t>General AI</a:t>
-                      </a:r>
-                      <a:br/>
-                      <a:r>
-                        <a:t>(Aidoc)</a:t>
-                      </a:r>
-                    </a:p>
-                  </a:txBody>
-                  <a:tcPr>
-                    <a:solidFill>
-                      <a:srgbClr val="0F2942"/>
-                    </a:solidFill>
-                  </a:tcPr>
-                </a:tc>
-                <a:tc>
-                  <a:txBody>
-                    <a:bodyPr/>
-                    <a:lstStyle/>
-                    <a:p>
-                      <a:pPr algn="ctr">
-                        <a:defRPr sz="1050" b="1">
-                          <a:solidFill>
-                            <a:srgbClr val="FFFFFF"/>
-                          </a:solidFill>
-                        </a:defRPr>
-                      </a:pPr>
-                      <a:r>
-                        <a:t>Academic SOTA</a:t>
-                      </a:r>
-                      <a:br/>
-                      <a:r>
-                        <a:t>(nnU-Net)</a:t>
-                      </a:r>
-                    </a:p>
-                  </a:txBody>
-                  <a:tcPr>
-                    <a:solidFill>
-                      <a:srgbClr val="0F2942"/>
-                    </a:solidFill>
-                  </a:tcPr>
-                </a:tc>
-                <a:tc>
-                  <a:txBody>
-                    <a:bodyPr/>
-                    <a:lstStyle/>
-                    <a:p>
-                      <a:pPr algn="ctr">
-                        <a:defRPr sz="1050" b="1">
-                          <a:solidFill>
-                            <a:srgbClr val="FFFFFF"/>
-                          </a:solidFill>
-                        </a:defRPr>
-                      </a:pPr>
-                      <a:r>
-                        <a:t>Mod-Seg-SE(2)</a:t>
-                      </a:r>
-                      <a:br/>
-                      <a:r>
-                        <a:t>[OURS]</a:t>
-                      </a:r>
-                    </a:p>
-                  </a:txBody>
-                  <a:tcPr>
-                    <a:solidFill>
-                      <a:srgbClr val="15803D"/>
-                    </a:solidFill>
-                  </a:tcPr>
-                </a:tc>
-              </a:tr>
-              <a:tr h="653142">
-                <a:tc>
-                  <a:txBody>
-                    <a:bodyPr/>
-                    <a:lstStyle/>
-                    <a:p>
-                      <a:pPr algn="l">
-                        <a:defRPr sz="1000" b="1">
-                          <a:solidFill>
-                            <a:srgbClr val="1E293B"/>
-                          </a:solidFill>
-                        </a:defRPr>
-                      </a:pPr>
-                      <a:r>
-                        <a:t>Full 3D Multi-Planar Volumetry (Ax, Cor, Sag)</a:t>
-                      </a:r>
-                    </a:p>
-                  </a:txBody>
-                  <a:tcPr>
-                    <a:solidFill>
-                      <a:srgbClr val="F8FAFC"/>
-                    </a:solidFill>
-                  </a:tcPr>
-                </a:tc>
-                <a:tc>
-                  <a:txBody>
-                    <a:bodyPr/>
-                    <a:lstStyle/>
-                    <a:p>
-                      <a:pPr algn="ctr">
-                        <a:defRPr sz="1000">
-                          <a:solidFill>
-                            <a:srgbClr val="64748B"/>
-                          </a:solidFill>
-                        </a:defRPr>
-                      </a:pPr>
-                      <a:r>
-                        <a:t>⚪ No</a:t>
-                      </a:r>
-                    </a:p>
-                  </a:txBody>
-                  <a:tcPr>
-                    <a:solidFill>
-                      <a:srgbClr val="F8FAFC"/>
-                    </a:solidFill>
-                  </a:tcPr>
-                </a:tc>
-                <a:tc>
-                  <a:txBody>
-                    <a:bodyPr/>
-                    <a:lstStyle/>
-                    <a:p>
-                      <a:pPr algn="ctr">
-                        <a:defRPr sz="1000">
-                          <a:solidFill>
-                            <a:srgbClr val="64748B"/>
-                          </a:solidFill>
-                        </a:defRPr>
-                      </a:pPr>
-                      <a:r>
-                        <a:t>⚪ No</a:t>
-                      </a:r>
-                    </a:p>
-                  </a:txBody>
-                  <a:tcPr>
-                    <a:solidFill>
-                      <a:srgbClr val="F8FAFC"/>
-                    </a:solidFill>
-                  </a:tcPr>
-                </a:tc>
-                <a:tc>
-                  <a:txBody>
-                    <a:bodyPr/>
-                    <a:lstStyle/>
-                    <a:p>
-                      <a:pPr algn="ctr">
-                        <a:defRPr sz="1000">
-                          <a:solidFill>
-                            <a:srgbClr val="D97706"/>
-                          </a:solidFill>
-                        </a:defRPr>
-                      </a:pPr>
-                      <a:r>
-                        <a:t>🟡 Partial</a:t>
-                      </a:r>
-                    </a:p>
-                  </a:txBody>
-                  <a:tcPr>
-                    <a:solidFill>
-                      <a:srgbClr val="F8FAFC"/>
-                    </a:solidFill>
-                  </a:tcPr>
-                </a:tc>
-                <a:tc>
-                  <a:txBody>
-                    <a:bodyPr/>
-                    <a:lstStyle/>
-                    <a:p>
-                      <a:pPr algn="ctr">
-                        <a:defRPr sz="1000">
-                          <a:solidFill>
-                            <a:srgbClr val="15803D"/>
-                          </a:solidFill>
-                        </a:defRPr>
-                      </a:pPr>
-                      <a:r>
-                        <a:t>🟢 YES</a:t>
-                      </a:r>
-                    </a:p>
-                  </a:txBody>
-                  <a:tcPr>
-                    <a:solidFill>
-                      <a:srgbClr val="F0FDF4"/>
-                    </a:solidFill>
-                  </a:tcPr>
-                </a:tc>
-              </a:tr>
-              <a:tr h="653142">
-                <a:tc>
-                  <a:txBody>
-                    <a:bodyPr/>
-                    <a:lstStyle/>
-                    <a:p>
-                      <a:pPr algn="l">
-                        <a:defRPr sz="1000" b="1">
-                          <a:solidFill>
-                            <a:srgbClr val="1E293B"/>
-                          </a:solidFill>
-                        </a:defRPr>
-                      </a:pPr>
-                      <a:r>
-                        <a:t>Non-Contrast CT (NCCT) Tumor Detection</a:t>
-                      </a:r>
-                    </a:p>
-                  </a:txBody>
-                  <a:tcPr>
-                    <a:solidFill>
-                      <a:srgbClr val="FFFFFF"/>
-                    </a:solidFill>
-                  </a:tcPr>
-                </a:tc>
-                <a:tc>
-                  <a:txBody>
-                    <a:bodyPr/>
-                    <a:lstStyle/>
-                    <a:p>
-                      <a:pPr algn="ctr">
-                        <a:defRPr sz="1000">
-                          <a:solidFill>
-                            <a:srgbClr val="64748B"/>
-                          </a:solidFill>
-                        </a:defRPr>
-                      </a:pPr>
-                      <a:r>
-                        <a:t>⚪ No</a:t>
-                      </a:r>
-                    </a:p>
-                  </a:txBody>
-                  <a:tcPr>
-                    <a:solidFill>
-                      <a:srgbClr val="FFFFFF"/>
-                    </a:solidFill>
-                  </a:tcPr>
-                </a:tc>
-                <a:tc>
-                  <a:txBody>
-                    <a:bodyPr/>
-                    <a:lstStyle/>
-                    <a:p>
-                      <a:pPr algn="ctr">
-                        <a:defRPr sz="1000">
-                          <a:solidFill>
-                            <a:srgbClr val="D97706"/>
-                          </a:solidFill>
-                        </a:defRPr>
-                      </a:pPr>
-                      <a:r>
-                        <a:t>🟡 Hemorrhage</a:t>
-                      </a:r>
-                    </a:p>
-                  </a:txBody>
-                  <a:tcPr>
-                    <a:solidFill>
-                      <a:srgbClr val="FFFFFF"/>
-                    </a:solidFill>
-                  </a:tcPr>
-                </a:tc>
-                <a:tc>
-                  <a:txBody>
-                    <a:bodyPr/>
-                    <a:lstStyle/>
-                    <a:p>
-                      <a:pPr algn="ctr">
-                        <a:defRPr sz="1000">
-                          <a:solidFill>
-                            <a:srgbClr val="D97706"/>
-                          </a:solidFill>
-                        </a:defRPr>
-                      </a:pPr>
-                      <a:r>
-                        <a:t>🟡 CT Only</a:t>
-                      </a:r>
-                    </a:p>
-                  </a:txBody>
-                  <a:tcPr>
-                    <a:solidFill>
-                      <a:srgbClr val="FFFFFF"/>
-                    </a:solidFill>
-                  </a:tcPr>
-                </a:tc>
-                <a:tc>
-                  <a:txBody>
-                    <a:bodyPr/>
-                    <a:lstStyle/>
-                    <a:p>
-                      <a:pPr algn="ctr">
-                        <a:defRPr sz="1000">
-                          <a:solidFill>
-                            <a:srgbClr val="15803D"/>
-                          </a:solidFill>
-                        </a:defRPr>
-                      </a:pPr>
-                      <a:r>
-                        <a:t>🟢 YES</a:t>
-                      </a:r>
-                    </a:p>
-                  </a:txBody>
-                  <a:tcPr>
-                    <a:solidFill>
-                      <a:srgbClr val="F0FDF4"/>
-                    </a:solidFill>
-                  </a:tcPr>
-                </a:tc>
-              </a:tr>
-              <a:tr h="653142">
-                <a:tc>
-                  <a:txBody>
-                    <a:bodyPr/>
-                    <a:lstStyle/>
-                    <a:p>
-                      <a:pPr algn="l">
-                        <a:defRPr sz="1000" b="1">
-                          <a:solidFill>
-                            <a:srgbClr val="1E293B"/>
-                          </a:solidFill>
-                        </a:defRPr>
-                      </a:pPr>
-                      <a:r>
-                        <a:t>Group Equivariant Invariance (SE(2) N=8)</a:t>
-                      </a:r>
-                    </a:p>
-                  </a:txBody>
-                  <a:tcPr>
-                    <a:solidFill>
-                      <a:srgbClr val="F8FAFC"/>
-                    </a:solidFill>
-                  </a:tcPr>
-                </a:tc>
-                <a:tc>
-                  <a:txBody>
-                    <a:bodyPr/>
-                    <a:lstStyle/>
-                    <a:p>
-                      <a:pPr algn="ctr">
-                        <a:defRPr sz="1000">
-                          <a:solidFill>
-                            <a:srgbClr val="64748B"/>
-                          </a:solidFill>
-                        </a:defRPr>
-                      </a:pPr>
-                      <a:r>
-                        <a:t>⚪ No</a:t>
-                      </a:r>
-                    </a:p>
-                  </a:txBody>
-                  <a:tcPr>
-                    <a:solidFill>
-                      <a:srgbClr val="F8FAFC"/>
-                    </a:solidFill>
-                  </a:tcPr>
-                </a:tc>
-                <a:tc>
-                  <a:txBody>
-                    <a:bodyPr/>
-                    <a:lstStyle/>
-                    <a:p>
-                      <a:pPr algn="ctr">
-                        <a:defRPr sz="1000">
-                          <a:solidFill>
-                            <a:srgbClr val="64748B"/>
-                          </a:solidFill>
-                        </a:defRPr>
-                      </a:pPr>
-                      <a:r>
-                        <a:t>⚪ No</a:t>
-                      </a:r>
-                    </a:p>
-                  </a:txBody>
-                  <a:tcPr>
-                    <a:solidFill>
-                      <a:srgbClr val="F8FAFC"/>
-                    </a:solidFill>
-                  </a:tcPr>
-                </a:tc>
-                <a:tc>
-                  <a:txBody>
-                    <a:bodyPr/>
-                    <a:lstStyle/>
-                    <a:p>
-                      <a:pPr algn="ctr">
-                        <a:defRPr sz="1000">
-                          <a:solidFill>
-                            <a:srgbClr val="64748B"/>
-                          </a:solidFill>
-                        </a:defRPr>
-                      </a:pPr>
-                      <a:r>
-                        <a:t>⚪ No</a:t>
-                      </a:r>
-                    </a:p>
-                  </a:txBody>
-                  <a:tcPr>
-                    <a:solidFill>
-                      <a:srgbClr val="F8FAFC"/>
-                    </a:solidFill>
-                  </a:tcPr>
-                </a:tc>
-                <a:tc>
-                  <a:txBody>
-                    <a:bodyPr/>
-                    <a:lstStyle/>
-                    <a:p>
-                      <a:pPr algn="ctr">
-                        <a:defRPr sz="1000">
-                          <a:solidFill>
-                            <a:srgbClr val="15803D"/>
-                          </a:solidFill>
-                        </a:defRPr>
-                      </a:pPr>
-                      <a:r>
-                        <a:t>🟢 YES</a:t>
-                      </a:r>
-                    </a:p>
-                  </a:txBody>
-                  <a:tcPr>
-                    <a:solidFill>
-                      <a:srgbClr val="F0FDF4"/>
-                    </a:solidFill>
-                  </a:tcPr>
-                </a:tc>
-              </a:tr>
-              <a:tr h="653142">
-                <a:tc>
-                  <a:txBody>
-                    <a:bodyPr/>
-                    <a:lstStyle/>
-                    <a:p>
-                      <a:pPr algn="l">
-                        <a:defRPr sz="1000" b="1">
-                          <a:solidFill>
-                            <a:srgbClr val="1E293B"/>
-                          </a:solidFill>
-                        </a:defRPr>
-                      </a:pPr>
-                      <a:r>
-                        <a:t>Multi-Model Consensus &amp; Uncertainty Map</a:t>
-                      </a:r>
-                    </a:p>
-                  </a:txBody>
-                  <a:tcPr>
-                    <a:solidFill>
-                      <a:srgbClr val="FFFFFF"/>
-                    </a:solidFill>
-                  </a:tcPr>
-                </a:tc>
-                <a:tc>
-                  <a:txBody>
-                    <a:bodyPr/>
-                    <a:lstStyle/>
-                    <a:p>
-                      <a:pPr algn="ctr">
-                        <a:defRPr sz="1000">
-                          <a:solidFill>
-                            <a:srgbClr val="64748B"/>
-                          </a:solidFill>
-                        </a:defRPr>
-                      </a:pPr>
-                      <a:r>
-                        <a:t>⚪ No</a:t>
-                      </a:r>
-                    </a:p>
-                  </a:txBody>
-                  <a:tcPr>
-                    <a:solidFill>
-                      <a:srgbClr val="FFFFFF"/>
-                    </a:solidFill>
-                  </a:tcPr>
-                </a:tc>
-                <a:tc>
-                  <a:txBody>
-                    <a:bodyPr/>
-                    <a:lstStyle/>
-                    <a:p>
-                      <a:pPr algn="ctr">
-                        <a:defRPr sz="1000">
-                          <a:solidFill>
-                            <a:srgbClr val="64748B"/>
-                          </a:solidFill>
-                        </a:defRPr>
-                      </a:pPr>
-                      <a:r>
-                        <a:t>⚪ No</a:t>
-                      </a:r>
-                    </a:p>
-                  </a:txBody>
-                  <a:tcPr>
-                    <a:solidFill>
-                      <a:srgbClr val="FFFFFF"/>
-                    </a:solidFill>
-                  </a:tcPr>
-                </a:tc>
-                <a:tc>
-                  <a:txBody>
-                    <a:bodyPr/>
-                    <a:lstStyle/>
-                    <a:p>
-                      <a:pPr algn="ctr">
-                        <a:defRPr sz="1000">
-                          <a:solidFill>
-                            <a:srgbClr val="64748B"/>
-                          </a:solidFill>
-                        </a:defRPr>
-                      </a:pPr>
-                      <a:r>
-                        <a:t>⚪ No</a:t>
-                      </a:r>
-                    </a:p>
-                  </a:txBody>
-                  <a:tcPr>
-                    <a:solidFill>
-                      <a:srgbClr val="FFFFFF"/>
-                    </a:solidFill>
-                  </a:tcPr>
-                </a:tc>
-                <a:tc>
-                  <a:txBody>
-                    <a:bodyPr/>
-                    <a:lstStyle/>
-                    <a:p>
-                      <a:pPr algn="ctr">
-                        <a:defRPr sz="1000">
-                          <a:solidFill>
-                            <a:srgbClr val="15803D"/>
-                          </a:solidFill>
-                        </a:defRPr>
-                      </a:pPr>
-                      <a:r>
-                        <a:t>🟢 YES</a:t>
-                      </a:r>
-                    </a:p>
-                  </a:txBody>
-                  <a:tcPr>
-                    <a:solidFill>
-                      <a:srgbClr val="F0FDF4"/>
-                    </a:solidFill>
-                  </a:tcPr>
-                </a:tc>
-              </a:tr>
-              <a:tr h="653142">
-                <a:tc>
-                  <a:txBody>
-                    <a:bodyPr/>
-                    <a:lstStyle/>
-                    <a:p>
-                      <a:pPr algn="l">
-                        <a:defRPr sz="1000" b="1">
-                          <a:solidFill>
-                            <a:srgbClr val="1E293B"/>
-                          </a:solidFill>
-                        </a:defRPr>
-                      </a:pPr>
-                      <a:r>
-                        <a:t>Zero-Install Browser Web &amp; PACS Integration</a:t>
-                      </a:r>
-                    </a:p>
-                  </a:txBody>
-                  <a:tcPr>
-                    <a:solidFill>
-                      <a:srgbClr val="F8FAFC"/>
-                    </a:solidFill>
-                  </a:tcPr>
-                </a:tc>
-                <a:tc>
-                  <a:txBody>
-                    <a:bodyPr/>
-                    <a:lstStyle/>
-                    <a:p>
-                      <a:pPr algn="ctr">
-                        <a:defRPr sz="1000">
-                          <a:solidFill>
-                            <a:srgbClr val="D97706"/>
-                          </a:solidFill>
-                        </a:defRPr>
-                      </a:pPr>
-                      <a:r>
-                        <a:t>🟡 Scope-locked</a:t>
-                      </a:r>
-                    </a:p>
-                  </a:txBody>
-                  <a:tcPr>
-                    <a:solidFill>
-                      <a:srgbClr val="F8FAFC"/>
-                    </a:solidFill>
-                  </a:tcPr>
-                </a:tc>
-                <a:tc>
-                  <a:txBody>
-                    <a:bodyPr/>
-                    <a:lstStyle/>
-                    <a:p>
-                      <a:pPr algn="ctr">
-                        <a:defRPr sz="1000">
-                          <a:solidFill>
-                            <a:srgbClr val="D97706"/>
-                          </a:solidFill>
-                        </a:defRPr>
-                      </a:pPr>
-                      <a:r>
-                        <a:t>🟡 Cloud-locked</a:t>
-                      </a:r>
-                    </a:p>
-                  </a:txBody>
-                  <a:tcPr>
-                    <a:solidFill>
-                      <a:srgbClr val="F8FAFC"/>
-                    </a:solidFill>
-                  </a:tcPr>
-                </a:tc>
-                <a:tc>
-                  <a:txBody>
-                    <a:bodyPr/>
-                    <a:lstStyle/>
-                    <a:p>
-                      <a:pPr algn="ctr">
-                        <a:defRPr sz="1000">
-                          <a:solidFill>
-                            <a:srgbClr val="64748B"/>
-                          </a:solidFill>
-                        </a:defRPr>
-                      </a:pPr>
-                      <a:r>
-                        <a:t>⚪ Script only</a:t>
-                      </a:r>
-                    </a:p>
-                  </a:txBody>
-                  <a:tcPr>
-                    <a:solidFill>
-                      <a:srgbClr val="F8FAFC"/>
-                    </a:solidFill>
-                  </a:tcPr>
-                </a:tc>
-                <a:tc>
-                  <a:txBody>
-                    <a:bodyPr/>
-                    <a:lstStyle/>
-                    <a:p>
-                      <a:pPr algn="ctr">
-                        <a:defRPr sz="1000">
-                          <a:solidFill>
-                            <a:srgbClr val="15803D"/>
-                          </a:solidFill>
-                        </a:defRPr>
-                      </a:pPr>
-                      <a:r>
-                        <a:t>🟢 YES</a:t>
-                      </a:r>
-                    </a:p>
-                  </a:txBody>
-                  <a:tcPr>
-                    <a:solidFill>
-                      <a:srgbClr val="F0FDF4"/>
-                    </a:solidFill>
-                  </a:tcPr>
-                </a:tc>
-              </a:tr>
-              <a:tr h="653148">
-                <a:tc>
-                  <a:txBody>
-                    <a:bodyPr/>
-                    <a:lstStyle/>
-                    <a:p>
-                      <a:pPr algn="l">
-                        <a:defRPr sz="1000" b="1">
-                          <a:solidFill>
-                            <a:srgbClr val="1E293B"/>
-                          </a:solidFill>
-                        </a:defRPr>
-                      </a:pPr>
-                      <a:r>
-                        <a:t>Automated Downloadable Clinical Word/DICOM</a:t>
-                      </a:r>
-                    </a:p>
-                  </a:txBody>
-                  <a:tcPr>
-                    <a:solidFill>
-                      <a:srgbClr val="FFFFFF"/>
-                    </a:solidFill>
-                  </a:tcPr>
-                </a:tc>
-                <a:tc>
-                  <a:txBody>
-                    <a:bodyPr/>
-                    <a:lstStyle/>
-                    <a:p>
-                      <a:pPr algn="ctr">
-                        <a:defRPr sz="1000">
-                          <a:solidFill>
-                            <a:srgbClr val="64748B"/>
-                          </a:solidFill>
-                        </a:defRPr>
-                      </a:pPr>
-                      <a:r>
-                        <a:t>⚪ No</a:t>
-                      </a:r>
-                    </a:p>
-                  </a:txBody>
-                  <a:tcPr>
-                    <a:solidFill>
-                      <a:srgbClr val="FFFFFF"/>
-                    </a:solidFill>
-                  </a:tcPr>
-                </a:tc>
-                <a:tc>
-                  <a:txBody>
-                    <a:bodyPr/>
-                    <a:lstStyle/>
-                    <a:p>
-                      <a:pPr algn="ctr">
-                        <a:defRPr sz="1000">
-                          <a:solidFill>
-                            <a:srgbClr val="64748B"/>
-                          </a:solidFill>
-                        </a:defRPr>
-                      </a:pPr>
-                      <a:r>
-                        <a:t>🟡 PDF only</a:t>
-                      </a:r>
-                    </a:p>
-                  </a:txBody>
-                  <a:tcPr>
-                    <a:solidFill>
-                      <a:srgbClr val="FFFFFF"/>
-                    </a:solidFill>
-                  </a:tcPr>
-                </a:tc>
-                <a:tc>
-                  <a:txBody>
-                    <a:bodyPr/>
-                    <a:lstStyle/>
-                    <a:p>
-                      <a:pPr algn="ctr">
-                        <a:defRPr sz="1000">
-                          <a:solidFill>
-                            <a:srgbClr val="64748B"/>
-                          </a:solidFill>
-                        </a:defRPr>
-                      </a:pPr>
-                      <a:r>
-                        <a:t>⚪ No</a:t>
-                      </a:r>
-                    </a:p>
-                  </a:txBody>
-                  <a:tcPr>
-                    <a:solidFill>
-                      <a:srgbClr val="FFFFFF"/>
-                    </a:solidFill>
-                  </a:tcPr>
-                </a:tc>
-                <a:tc>
-                  <a:txBody>
-                    <a:bodyPr/>
-                    <a:lstStyle/>
-                    <a:p>
-                      <a:pPr algn="ctr">
-                        <a:defRPr sz="1000">
-                          <a:solidFill>
-                            <a:srgbClr val="15803D"/>
-                          </a:solidFill>
-                        </a:defRPr>
-                      </a:pPr>
-                      <a:r>
-                        <a:t>🟢 YES</a:t>
-                      </a:r>
-                    </a:p>
-                  </a:txBody>
-                  <a:tcPr>
-                    <a:solidFill>
-                      <a:srgbClr val="F0FDF4"/>
-                    </a:solidFill>
-                  </a:tcPr>
-                </a:tc>
-              </a:tr>
-            </a:tbl>
-          </a:graphicData>
-        </a:graphic>
-      </p:graphicFrame>
-      <p:sp>
-        <p:nvSpPr>
-          <p:cNvPr id="7" name="Rounded Rectangle 6"/>
-          <p:cNvSpPr/>
-          <p:nvPr/>
-        </p:nvSpPr>
-        <p:spPr>
-          <a:xfrm>
-            <a:off x="8595360" y="1188720"/>
-            <a:ext cx="2834640" cy="2377440"/>
-          </a:xfrm>
-          <a:prstGeom prst="roundRect">
-            <a:avLst/>
-          </a:prstGeom>
-          <a:solidFill>
-            <a:srgbClr val="FEF2F2"/>
-          </a:solidFill>
-          <a:ln>
-            <a:solidFill>
-              <a:srgbClr val="DC2626"/>
-            </a:solidFill>
-          </a:ln>
-        </p:spPr>
-        <p:style>
-          <a:lnRef idx="1">
-            <a:schemeClr val="accent1"/>
-          </a:lnRef>
-          <a:fillRef idx="3">
-            <a:schemeClr val="accent1"/>
-          </a:fillRef>
-          <a:effectRef idx="2">
-            <a:schemeClr val="accent1"/>
-          </a:effectRef>
-          <a:fontRef idx="minor">
-            <a:schemeClr val="lt1"/>
-          </a:fontRef>
-        </p:style>
-        <p:txBody>
-          <a:bodyPr rtlCol="0" anchor="ctr" wrap="square"/>
-          <a:lstStyle/>
-          <a:p>
-            <a:pPr algn="ctr">
-              <a:defRPr sz="1500" b="1">
-                <a:solidFill>
-                  <a:srgbClr val="DC2626"/>
-                </a:solidFill>
-              </a:defRPr>
-            </a:pPr>
-            <a:r>
-              <a:t>The Open Space</a:t>
-            </a:r>
-          </a:p>
-          <a:p>
-            <a:pPr>
-              <a:spcBef>
-                <a:spcPts val="400"/>
-              </a:spcBef>
-              <a:defRPr sz="1050">
-                <a:solidFill>
-                  <a:srgbClr val="1E293B"/>
-                </a:solidFill>
-              </a:defRPr>
-            </a:pPr>
-            <a:r>
-              <a:t>No approved clinical AI software performs automated brain tumor segmentation on raw Non-Contrast CT with rotation-equivariant invariance and zero-install browser deployment.</a:t>
-            </a:r>
-            <a:br/>
-            <a:br/>
-            <a:r>
-              <a:t>Traditional tools fail when heads are tilted; our platform fills this clinical void.</a:t>
-            </a:r>
-          </a:p>
-        </p:txBody>
-      </p:sp>
-      <p:sp>
-        <p:nvSpPr>
-          <p:cNvPr id="8" name="Rounded Rectangle 7"/>
-          <p:cNvSpPr/>
-          <p:nvPr/>
-        </p:nvSpPr>
-        <p:spPr>
-          <a:xfrm>
-            <a:off x="8595360" y="3749039"/>
-            <a:ext cx="2834640" cy="2011680"/>
-          </a:xfrm>
-          <a:prstGeom prst="roundRect">
-            <a:avLst/>
-          </a:prstGeom>
-          <a:solidFill>
-            <a:srgbClr val="F0F9FF"/>
-          </a:solidFill>
-          <a:ln>
-            <a:solidFill>
-              <a:srgbClr val="0284C7"/>
-            </a:solidFill>
-          </a:ln>
-        </p:spPr>
-        <p:style>
-          <a:lnRef idx="1">
-            <a:schemeClr val="accent1"/>
-          </a:lnRef>
-          <a:fillRef idx="3">
-            <a:schemeClr val="accent1"/>
-          </a:fillRef>
-          <a:effectRef idx="2">
-            <a:schemeClr val="accent1"/>
-          </a:effectRef>
-          <a:fontRef idx="minor">
-            <a:schemeClr val="lt1"/>
-          </a:fontRef>
-        </p:style>
-        <p:txBody>
-          <a:bodyPr rtlCol="0" anchor="ctr" wrap="square"/>
-          <a:lstStyle/>
-          <a:p>
-            <a:pPr algn="ctr">
-              <a:defRPr sz="1500" b="1">
-                <a:solidFill>
-                  <a:srgbClr val="1E3A8A"/>
-                </a:solidFill>
-              </a:defRPr>
-            </a:pPr>
-            <a:r>
-              <a:t>Two Buyers, One Engine</a:t>
-            </a:r>
-          </a:p>
-          <a:p>
-            <a:pPr>
-              <a:spcBef>
-                <a:spcPts val="400"/>
-              </a:spcBef>
-              <a:defRPr sz="1050">
-                <a:solidFill>
-                  <a:srgbClr val="1E293B"/>
-                </a:solidFill>
-              </a:defRPr>
-            </a:pPr>
-            <a:r>
-              <a:t>1. Hospital Routine Care: Rapid neuro-oncology triage, volumetric mass effect quantification, and surgical planning.</a:t>
-            </a:r>
-            <a:br/>
-            <a:br/>
-            <a:r>
-              <a:t>2. Clinical Drug Trials: Automated, reproducible central reading without radiologist fatigue or rater bias.</a:t>
-            </a:r>
-          </a:p>
-        </p:txBody>
-      </p:sp>
-      <p:sp>
-        <p:nvSpPr>
-          <p:cNvPr id="9" name="Rectangle 8"/>
-          <p:cNvSpPr/>
-          <p:nvPr/>
-        </p:nvSpPr>
-        <p:spPr>
-          <a:xfrm>
-            <a:off x="731520" y="5897880"/>
-            <a:ext cx="10698480" cy="365760"/>
-          </a:xfrm>
-          <a:prstGeom prst="rect">
-            <a:avLst/>
-          </a:prstGeom>
-          <a:solidFill>
-            <a:srgbClr val="FEF3C7"/>
-          </a:solidFill>
-          <a:ln>
-            <a:solidFill>
-              <a:srgbClr val="D97706"/>
-            </a:solidFill>
-          </a:ln>
-        </p:spPr>
-        <p:style>
-          <a:lnRef idx="1">
-            <a:schemeClr val="accent1"/>
-          </a:lnRef>
-          <a:fillRef idx="3">
-            <a:schemeClr val="accent1"/>
-          </a:fillRef>
-          <a:effectRef idx="2">
-            <a:schemeClr val="accent1"/>
-          </a:effectRef>
-          <a:fontRef idx="minor">
-            <a:schemeClr val="lt1"/>
-          </a:fontRef>
-        </p:style>
-        <p:txBody>
-          <a:bodyPr rtlCol="0" anchor="ctr"/>
-          <a:lstStyle/>
-          <a:p>
-            <a:pPr algn="ctr">
-              <a:defRPr sz="1000">
-                <a:solidFill>
-                  <a:srgbClr val="D97706"/>
-                </a:solidFill>
-              </a:defRPr>
-            </a:pPr>
-            <a:r>
-              <a:t>Present status: Working Web Platform Prototype (Verified on DGX-H100 &amp; Taiwan Patient Cohort). Validated on 6 Baseline Architectures.</a:t>
-            </a:r>
-          </a:p>
-        </p:txBody>
-      </p:sp>
-    </p:spTree>
-  </p:cSld>
-  <p:clrMapOvr>
-    <a:masterClrMapping/>
-  </p:clrMapOvr>
-</p:sld>
-</file>
-
-<file path=ppt/slides/slide5.xml><?xml version="1.0" encoding="utf-8"?>
-<p:sld xmlns:a="http://schemas.openxmlformats.org/drawingml/2006/main" xmlns:p="http://schemas.openxmlformats.org/presentationml/2006/main" xmlns:r="http://schemas.openxmlformats.org/officeDocument/2006/relationships">
-  <p:cSld>
-    <p:spTree>
-      <p:nvGrpSpPr>
-        <p:cNvPr id="1" name=""/>
-        <p:cNvGrpSpPr/>
-        <p:nvPr/>
-      </p:nvGrpSpPr>
-      <p:grpSpPr/>
-      <p:sp>
-        <p:nvSpPr>
-          <p:cNvPr id="2" name="TextBox 1"/>
-          <p:cNvSpPr txBox="1"/>
-          <p:nvPr/>
-        </p:nvSpPr>
-        <p:spPr>
-          <a:xfrm>
-            <a:off x="731520" y="365760"/>
-            <a:ext cx="2286000" cy="548640"/>
-          </a:xfrm>
-          <a:prstGeom prst="rect">
-            <a:avLst/>
-          </a:prstGeom>
-          <a:noFill/>
-        </p:spPr>
-        <p:txBody>
-          <a:bodyPr wrap="square">
-            <a:spAutoFit/>
-          </a:bodyPr>
-          <a:lstStyle/>
-          <a:p>
-            <a:pPr>
-              <a:defRPr sz="1400" b="1">
-                <a:solidFill>
-                  <a:srgbClr val="0F2942"/>
-                </a:solidFill>
-              </a:defRPr>
-            </a:pPr>
-            <a:r>
-              <a:t>OPTICAL SYSTEMS LAB</a:t>
-            </a:r>
-          </a:p>
-        </p:txBody>
-      </p:sp>
-      <p:sp>
-        <p:nvSpPr>
-          <p:cNvPr id="3" name="TextBox 2"/>
-          <p:cNvSpPr txBox="1"/>
-          <p:nvPr/>
-        </p:nvSpPr>
-        <p:spPr>
-          <a:xfrm>
-            <a:off x="3017520" y="320040"/>
-            <a:ext cx="8412480" cy="731520"/>
-          </a:xfrm>
-          <a:prstGeom prst="rect">
-            <a:avLst/>
-          </a:prstGeom>
-          <a:noFill/>
-        </p:spPr>
-        <p:txBody>
-          <a:bodyPr wrap="square">
-            <a:spAutoFit/>
-          </a:bodyPr>
-          <a:lstStyle/>
-          <a:p>
-            <a:pPr>
-              <a:defRPr sz="2200" b="1">
-                <a:solidFill>
-                  <a:srgbClr val="1E3A8A"/>
-                </a:solidFill>
-              </a:defRPr>
-            </a:pPr>
-            <a:r>
-              <a:t>Mod-Seg-SE(2) Architecture &amp; Training Pipeline</a:t>
-            </a:r>
-          </a:p>
-          <a:p>
-            <a:pPr>
-              <a:defRPr sz="1300">
-                <a:solidFill>
-                  <a:srgbClr val="64748B"/>
-                </a:solidFill>
-              </a:defRPr>
-            </a:pPr>
-            <a:r>
-              <a:t>Group Equivariant Convolutional Network (C8 / N=8 Rotations) for Robust Brain CT Segmentation</a:t>
-            </a:r>
-          </a:p>
-        </p:txBody>
-      </p:sp>
-      <p:sp>
-        <p:nvSpPr>
-          <p:cNvPr id="4" name="TextBox 3"/>
-          <p:cNvSpPr txBox="1"/>
-          <p:nvPr/>
-        </p:nvSpPr>
-        <p:spPr>
-          <a:xfrm>
-            <a:off x="731520" y="6400800"/>
-            <a:ext cx="4572000" cy="365760"/>
-          </a:xfrm>
-          <a:prstGeom prst="rect">
-            <a:avLst/>
-          </a:prstGeom>
-          <a:noFill/>
-        </p:spPr>
-        <p:txBody>
-          <a:bodyPr wrap="none">
-            <a:spAutoFit/>
-          </a:bodyPr>
-          <a:lstStyle/>
-          <a:p>
-            <a:pPr>
-              <a:defRPr sz="1000">
-                <a:solidFill>
-                  <a:srgbClr val="64748B"/>
-                </a:solidFill>
-              </a:defRPr>
-            </a:pPr>
-            <a:r>
-              <a:t>National Taiwan University • NTU GSAT | Brain-CTC-Seg Consortium</a:t>
-            </a:r>
-          </a:p>
-        </p:txBody>
-      </p:sp>
-      <p:sp>
-        <p:nvSpPr>
-          <p:cNvPr id="5" name="TextBox 4"/>
-          <p:cNvSpPr txBox="1"/>
-          <p:nvPr/>
-        </p:nvSpPr>
-        <p:spPr>
-          <a:xfrm>
-            <a:off x="11155680" y="6400800"/>
-            <a:ext cx="731520" cy="365760"/>
-          </a:xfrm>
-          <a:prstGeom prst="rect">
-            <a:avLst/>
-          </a:prstGeom>
-          <a:noFill/>
-        </p:spPr>
-        <p:txBody>
-          <a:bodyPr wrap="none">
-            <a:spAutoFit/>
-          </a:bodyPr>
-          <a:lstStyle/>
-          <a:p>
-            <a:pPr>
-              <a:defRPr sz="1100" b="1">
-                <a:solidFill>
-                  <a:srgbClr val="1E293B"/>
-                </a:solidFill>
-              </a:defRPr>
-            </a:pPr>
-            <a:r>
-              <a:t>9</a:t>
+              <a:t>4</a:t>
             </a:r>
           </a:p>
         </p:txBody>
       </p:sp>
       <p:pic>
         <p:nvPicPr>
-          <p:cNvPr id="6" name="Picture 5" descr="Fig5_Mod_Seg_SE2_Architecture.png"/>
+          <p:cNvPr id="6" name="Picture 5" descr="arch_flow_visual_complete.png"/>
           <p:cNvPicPr>
             <a:picLocks noChangeAspect="1"/>
           </p:cNvPicPr>
@@ -6769,237 +5064,13 @@
         <p:spPr>
           <a:xfrm>
             <a:off x="731520" y="1188720"/>
-            <a:ext cx="5120640" cy="4754880"/>
+            <a:ext cx="10725912" cy="5029200"/>
           </a:xfrm>
           <a:prstGeom prst="rect">
             <a:avLst/>
           </a:prstGeom>
         </p:spPr>
       </p:pic>
-      <p:sp>
-        <p:nvSpPr>
-          <p:cNvPr id="7" name="Rounded Rectangle 6"/>
-          <p:cNvSpPr/>
-          <p:nvPr/>
-        </p:nvSpPr>
-        <p:spPr>
-          <a:xfrm>
-            <a:off x="6035040" y="1188720"/>
-            <a:ext cx="5394960" cy="4754880"/>
-          </a:xfrm>
-          <a:prstGeom prst="roundRect">
-            <a:avLst/>
-          </a:prstGeom>
-          <a:solidFill>
-            <a:srgbClr val="F8FAFC"/>
-          </a:solidFill>
-          <a:ln w="19050">
-            <a:solidFill>
-              <a:srgbClr val="E2E8F0"/>
-            </a:solidFill>
-          </a:ln>
-        </p:spPr>
-        <p:style>
-          <a:lnRef idx="1">
-            <a:schemeClr val="accent1"/>
-          </a:lnRef>
-          <a:fillRef idx="3">
-            <a:schemeClr val="accent1"/>
-          </a:fillRef>
-          <a:effectRef idx="2">
-            <a:schemeClr val="accent1"/>
-          </a:effectRef>
-          <a:fontRef idx="minor">
-            <a:schemeClr val="lt1"/>
-          </a:fontRef>
-        </p:style>
-        <p:txBody>
-          <a:bodyPr rtlCol="0" anchor="ctr" wrap="square"/>
-          <a:lstStyle/>
-          <a:p>
-            <a:pPr algn="ctr">
-              <a:spcBef>
-                <a:spcPts val="0"/>
-              </a:spcBef>
-              <a:defRPr sz="1200" b="1">
-                <a:solidFill>
-                  <a:srgbClr val="1E3A8A"/>
-                </a:solidFill>
-              </a:defRPr>
-            </a:pPr>
-            <a:r>
-              <a:t>1. 2.5D Spatial Stacking Input</a:t>
-            </a:r>
-          </a:p>
-          <a:p>
-            <a:pPr>
-              <a:spcBef>
-                <a:spcPts val="200"/>
-              </a:spcBef>
-              <a:defRPr sz="1000">
-                <a:solidFill>
-                  <a:srgbClr val="1E293B"/>
-                </a:solidFill>
-              </a:defRPr>
-            </a:pPr>
-            <a:r>
-              <a:t>• Input tensor: [B, 3, 256, 256] stacking [img_prev, img_curr, img_next]</a:t>
-            </a:r>
-            <a:br/>
-            <a:r>
-              <a:t>• Provides 3D volumetric context without massive 3D-CNN compute overhead.</a:t>
-            </a:r>
-          </a:p>
-          <a:p>
-            <a:pPr>
-              <a:spcBef>
-                <a:spcPts val="600"/>
-              </a:spcBef>
-              <a:defRPr sz="1200" b="1">
-                <a:solidFill>
-                  <a:srgbClr val="1E3A8A"/>
-                </a:solidFill>
-              </a:defRPr>
-            </a:pPr>
-            <a:r>
-              <a:t>2. Group Equivariant R2Conv Encoder</a:t>
-            </a:r>
-          </a:p>
-          <a:p>
-            <a:pPr>
-              <a:spcBef>
-                <a:spcPts val="200"/>
-              </a:spcBef>
-              <a:defRPr sz="1000">
-                <a:solidFill>
-                  <a:srgbClr val="1E293B"/>
-                </a:solidFill>
-              </a:defRPr>
-            </a:pPr>
-            <a:r>
-              <a:t>• Discrete rotation group C8 (N=8 rotations spaced by 45°)</a:t>
-            </a:r>
-            <a:br/>
-            <a:r>
-              <a:t>• Steerable filter banks guarantee f(g • x) = g • f(x)</a:t>
-            </a:r>
-            <a:br/>
-            <a:r>
-              <a:t>• Invariant to scanner couch indexing &amp; patient head tilt.</a:t>
-            </a:r>
-          </a:p>
-          <a:p>
-            <a:pPr>
-              <a:spcBef>
-                <a:spcPts val="600"/>
-              </a:spcBef>
-              <a:defRPr sz="1200" b="1">
-                <a:solidFill>
-                  <a:srgbClr val="1E3A8A"/>
-                </a:solidFill>
-              </a:defRPr>
-            </a:pPr>
-            <a:r>
-              <a:t>3. Equivariant Bottleneck &amp; Decoder</a:t>
-            </a:r>
-          </a:p>
-          <a:p>
-            <a:pPr>
-              <a:spcBef>
-                <a:spcPts val="200"/>
-              </a:spcBef>
-              <a:defRPr sz="1000">
-                <a:solidFill>
-                  <a:srgbClr val="1E293B"/>
-                </a:solidFill>
-              </a:defRPr>
-            </a:pPr>
-            <a:r>
-              <a:t>• Pointwise Max Pooling &amp; Equivariant Group Normalization</a:t>
-            </a:r>
-            <a:br/>
-            <a:r>
-              <a:t>• R2Upsampling + skip connection direct sum concatenation</a:t>
-            </a:r>
-            <a:br/>
-            <a:r>
-              <a:t>• Preserves fine sub-millimeter tumor boundary details.</a:t>
-            </a:r>
-          </a:p>
-          <a:p>
-            <a:pPr>
-              <a:spcBef>
-                <a:spcPts val="600"/>
-              </a:spcBef>
-              <a:defRPr sz="1200" b="1">
-                <a:solidFill>
-                  <a:srgbClr val="1E3A8A"/>
-                </a:solidFill>
-              </a:defRPr>
-            </a:pPr>
-            <a:r>
-              <a:t>4. Projection Head &amp; Advanced Loss</a:t>
-            </a:r>
-          </a:p>
-          <a:p>
-            <a:pPr>
-              <a:spcBef>
-                <a:spcPts val="200"/>
-              </a:spcBef>
-              <a:defRPr sz="1000">
-                <a:solidFill>
-                  <a:srgbClr val="1E293B"/>
-                </a:solidFill>
-              </a:defRPr>
-            </a:pPr>
-            <a:r>
-              <a:t>• Equivariant-to-Trivial projection (1x1 conv) -&gt; 2-class softmax</a:t>
-            </a:r>
-            <a:br/>
-            <a:r>
-              <a:t>• AdvancedCombinedLoss: L = 2.0*Dice + 0.5*Focal + 0.5*Edge</a:t>
-            </a:r>
-            <a:br/>
-            <a:r>
-              <a:t>• Class weighting [1.0, 10.0] tackles extreme foreground/background tumor imbalance.</a:t>
-            </a:r>
-          </a:p>
-          <a:p>
-            <a:pPr>
-              <a:spcBef>
-                <a:spcPts val="600"/>
-              </a:spcBef>
-              <a:defRPr sz="1200" b="1">
-                <a:solidFill>
-                  <a:srgbClr val="1E3A8A"/>
-                </a:solidFill>
-              </a:defRPr>
-            </a:pPr>
-            <a:r>
-              <a:t>5. Validated Performance</a:t>
-            </a:r>
-          </a:p>
-          <a:p>
-            <a:pPr>
-              <a:spcBef>
-                <a:spcPts val="200"/>
-              </a:spcBef>
-              <a:defRPr sz="1000">
-                <a:solidFill>
-                  <a:srgbClr val="1E293B"/>
-                </a:solidFill>
-              </a:defRPr>
-            </a:pPr>
-            <a:r>
-              <a:t>• Mod-Seg-SE(2) achieves 84.2% Dice &amp; 73.1% IoU on challenging NCCT</a:t>
-            </a:r>
-            <a:br/>
-            <a:r>
-              <a:t>• Retains &gt;82% Dice under severe 45°/90°/180° scan rotations.</a:t>
-            </a:r>
-          </a:p>
-        </p:txBody>
-      </p:sp>
     </p:spTree>
   </p:cSld>
   <p:clrMapOvr>

</xml_diff>

<commit_message>
feat(presentation): match exact client reference slides 1-to-1 with official logos, robots, and scanner machine
</commit_message>
<xml_diff>
--- a/Brain_CT_Seg_Client_Presentation.pptx
+++ b/Brain_CT_Seg_Client_Presentation.pptx
@@ -3091,16 +3091,40 @@
         <p:nvPr/>
       </p:nvGrpSpPr>
       <p:grpSpPr/>
-      <p:sp>
-        <p:nvSpPr>
-          <p:cNvPr id="2" name="TextBox 1"/>
+      <p:pic>
+        <p:nvPicPr>
+          <p:cNvPr id="2" name="Picture 1" descr="logo_osl.png"/>
+          <p:cNvPicPr>
+            <a:picLocks noChangeAspect="1"/>
+          </p:cNvPicPr>
+          <p:nvPr/>
+        </p:nvPicPr>
+        <p:blipFill>
+          <a:blip r:embed="rId2"/>
+          <a:stretch>
+            <a:fillRect/>
+          </a:stretch>
+        </p:blipFill>
+        <p:spPr>
+          <a:xfrm>
+            <a:off x="548640" y="320040"/>
+            <a:ext cx="1645920" cy="777240"/>
+          </a:xfrm>
+          <a:prstGeom prst="rect">
+            <a:avLst/>
+          </a:prstGeom>
+        </p:spPr>
+      </p:pic>
+      <p:sp>
+        <p:nvSpPr>
+          <p:cNvPr id="3" name="TextBox 2"/>
           <p:cNvSpPr txBox="1"/>
           <p:nvPr/>
         </p:nvSpPr>
         <p:spPr>
           <a:xfrm>
-            <a:off x="731520" y="365760"/>
-            <a:ext cx="2286000" cy="548640"/>
+            <a:off x="2468880" y="320040"/>
+            <a:ext cx="8961120" cy="777240"/>
           </a:xfrm>
           <a:prstGeom prst="rect">
             <a:avLst/>
@@ -3114,28 +3138,64 @@
           <a:lstStyle/>
           <a:p>
             <a:pPr>
-              <a:defRPr sz="1300" b="1">
-                <a:solidFill>
-                  <a:srgbClr val="0F2942"/>
+              <a:defRPr sz="2100" b="1">
+                <a:solidFill>
+                  <a:srgbClr val="1E3A8A"/>
                 </a:solidFill>
               </a:defRPr>
             </a:pPr>
             <a:r>
-              <a:t>OPTICAL SYSTEMS LAB</a:t>
-            </a:r>
-          </a:p>
-        </p:txBody>
-      </p:sp>
-      <p:sp>
-        <p:nvSpPr>
-          <p:cNvPr id="3" name="TextBox 2"/>
+              <a:t>Brain-CT-Seg: AI for Brain Tumor Segmentation &amp; Risk Volumetry</a:t>
+            </a:r>
+          </a:p>
+          <a:p>
+            <a:pPr>
+              <a:defRPr sz="1200">
+                <a:solidFill>
+                  <a:srgbClr val="64748B"/>
+                </a:solidFill>
+              </a:defRPr>
+            </a:pPr>
+            <a:r>
+              <a:t>Overcoming Machine, Deep Learning, and Clinical Radiologist Barriers in Non-Contrast CT</a:t>
+            </a:r>
+          </a:p>
+        </p:txBody>
+      </p:sp>
+      <p:pic>
+        <p:nvPicPr>
+          <p:cNvPr id="4" name="Picture 3" descr="logo_ntu.png"/>
+          <p:cNvPicPr>
+            <a:picLocks noChangeAspect="1"/>
+          </p:cNvPicPr>
+          <p:nvPr/>
+        </p:nvPicPr>
+        <p:blipFill>
+          <a:blip r:embed="rId3"/>
+          <a:stretch>
+            <a:fillRect/>
+          </a:stretch>
+        </p:blipFill>
+        <p:spPr>
+          <a:xfrm>
+            <a:off x="548640" y="6217920"/>
+            <a:ext cx="2377440" cy="502920"/>
+          </a:xfrm>
+          <a:prstGeom prst="rect">
+            <a:avLst/>
+          </a:prstGeom>
+        </p:spPr>
+      </p:pic>
+      <p:sp>
+        <p:nvSpPr>
+          <p:cNvPr id="5" name="TextBox 4"/>
           <p:cNvSpPr txBox="1"/>
           <p:nvPr/>
         </p:nvSpPr>
         <p:spPr>
           <a:xfrm>
-            <a:off x="3017520" y="320040"/>
-            <a:ext cx="8412480" cy="731520"/>
+            <a:off x="11155680" y="6263640"/>
+            <a:ext cx="548640" cy="365760"/>
           </a:xfrm>
           <a:prstGeom prst="rect">
             <a:avLst/>
@@ -3143,46 +3203,34 @@
           <a:noFill/>
         </p:spPr>
         <p:txBody>
-          <a:bodyPr wrap="square">
+          <a:bodyPr wrap="none">
             <a:spAutoFit/>
           </a:bodyPr>
           <a:lstStyle/>
           <a:p>
             <a:pPr>
-              <a:defRPr sz="2100" b="1">
-                <a:solidFill>
-                  <a:srgbClr val="1E3A8A"/>
+              <a:defRPr sz="1200">
+                <a:solidFill>
+                  <a:srgbClr val="1E293B"/>
                 </a:solidFill>
               </a:defRPr>
             </a:pPr>
             <a:r>
-              <a:t>Brain-CT-Seg: AI for Brain Tumor Segmentation &amp; Risk Volumetry</a:t>
-            </a:r>
-          </a:p>
-          <a:p>
-            <a:pPr>
-              <a:defRPr sz="1200">
-                <a:solidFill>
-                  <a:srgbClr val="64748B"/>
-                </a:solidFill>
-              </a:defRPr>
-            </a:pPr>
-            <a:r>
-              <a:t>Overcoming Machine, Deep Learning, and Clinical Radiologist Barriers in Non-Contrast CT</a:t>
-            </a:r>
-          </a:p>
-        </p:txBody>
-      </p:sp>
-      <p:sp>
-        <p:nvSpPr>
-          <p:cNvPr id="4" name="TextBox 3"/>
+              <a:t>1</a:t>
+            </a:r>
+          </a:p>
+        </p:txBody>
+      </p:sp>
+      <p:sp>
+        <p:nvSpPr>
+          <p:cNvPr id="6" name="TextBox 5"/>
           <p:cNvSpPr txBox="1"/>
           <p:nvPr/>
         </p:nvSpPr>
         <p:spPr>
           <a:xfrm>
-            <a:off x="731520" y="6446520"/>
-            <a:ext cx="5486400" cy="320040"/>
+            <a:off x="1097280" y="1188720"/>
+            <a:ext cx="2926080" cy="320040"/>
           </a:xfrm>
           <a:prstGeom prst="rect">
             <a:avLst/>
@@ -3195,29 +3243,49 @@
           </a:bodyPr>
           <a:lstStyle/>
           <a:p>
-            <a:pPr>
-              <a:defRPr sz="1000">
-                <a:solidFill>
-                  <a:srgbClr val="64748B"/>
-                </a:solidFill>
-              </a:defRPr>
+            <a:pPr algn="ctr">
+              <a:defRPr sz="1500" b="1"/>
             </a:pPr>
             <a:r>
-              <a:t>National Taiwan University • NTU GSAT | Brain-CTC-Seg Consortium</a:t>
-            </a:r>
-          </a:p>
-        </p:txBody>
-      </p:sp>
-      <p:sp>
-        <p:nvSpPr>
-          <p:cNvPr id="5" name="TextBox 4"/>
+              <a:t>Machine</a:t>
+            </a:r>
+          </a:p>
+        </p:txBody>
+      </p:sp>
+      <p:pic>
+        <p:nvPicPr>
+          <p:cNvPr id="7" name="Picture 6" descr="ct_scanner_machine.jpg"/>
+          <p:cNvPicPr>
+            <a:picLocks noChangeAspect="1"/>
+          </p:cNvPicPr>
+          <p:nvPr/>
+        </p:nvPicPr>
+        <p:blipFill>
+          <a:blip r:embed="rId4"/>
+          <a:stretch>
+            <a:fillRect/>
+          </a:stretch>
+        </p:blipFill>
+        <p:spPr>
+          <a:xfrm>
+            <a:off x="1371600" y="1508760"/>
+            <a:ext cx="2377440" cy="1234440"/>
+          </a:xfrm>
+          <a:prstGeom prst="rect">
+            <a:avLst/>
+          </a:prstGeom>
+        </p:spPr>
+      </p:pic>
+      <p:sp>
+        <p:nvSpPr>
+          <p:cNvPr id="8" name="TextBox 7"/>
           <p:cNvSpPr txBox="1"/>
           <p:nvPr/>
         </p:nvSpPr>
         <p:spPr>
           <a:xfrm>
-            <a:off x="10972800" y="6446520"/>
-            <a:ext cx="731520" cy="320040"/>
+            <a:off x="1097280" y="2788920"/>
+            <a:ext cx="2926080" cy="640080"/>
           </a:xfrm>
           <a:prstGeom prst="rect">
             <a:avLst/>
@@ -3225,44 +3293,260 @@
           <a:noFill/>
         </p:spPr>
         <p:txBody>
+          <a:bodyPr wrap="square">
+            <a:spAutoFit/>
+          </a:bodyPr>
+          <a:lstStyle/>
+          <a:p>
+            <a:pPr algn="ctr">
+              <a:defRPr sz="1050">
+                <a:solidFill>
+                  <a:srgbClr val="1E293B"/>
+                </a:solidFill>
+              </a:defRPr>
+            </a:pPr>
+            <a:r>
+              <a:t>The rotation problem (head tilt &amp; couch angle)</a:t>
+            </a:r>
+          </a:p>
+          <a:p>
+            <a:pPr algn="ctr">
+              <a:defRPr sz="1050">
+                <a:solidFill>
+                  <a:srgbClr val="1E293B"/>
+                </a:solidFill>
+              </a:defRPr>
+            </a:pPr>
+            <a:r>
+              <a:t>Vendor variability (Siemens, GE, Philips)</a:t>
+            </a:r>
+          </a:p>
+        </p:txBody>
+      </p:sp>
+      <p:sp>
+        <p:nvSpPr>
+          <p:cNvPr id="9" name="TextBox 8"/>
+          <p:cNvSpPr txBox="1"/>
+          <p:nvPr/>
+        </p:nvSpPr>
+        <p:spPr>
+          <a:xfrm>
+            <a:off x="4663440" y="1188720"/>
+            <a:ext cx="2926080" cy="320040"/>
+          </a:xfrm>
+          <a:prstGeom prst="rect">
+            <a:avLst/>
+          </a:prstGeom>
+          <a:noFill/>
+        </p:spPr>
+        <p:txBody>
           <a:bodyPr wrap="none">
             <a:spAutoFit/>
           </a:bodyPr>
           <a:lstStyle/>
           <a:p>
-            <a:pPr>
-              <a:defRPr sz="1100" b="1">
+            <a:pPr algn="ctr">
+              <a:defRPr sz="1500" b="1"/>
+            </a:pPr>
+            <a:r>
+              <a:t>Software</a:t>
+            </a:r>
+          </a:p>
+        </p:txBody>
+      </p:sp>
+      <p:pic>
+        <p:nvPicPr>
+          <p:cNvPr id="10" name="Picture 9" descr="ref_software.png"/>
+          <p:cNvPicPr>
+            <a:picLocks noChangeAspect="1"/>
+          </p:cNvPicPr>
+          <p:nvPr/>
+        </p:nvPicPr>
+        <p:blipFill>
+          <a:blip r:embed="rId5"/>
+          <a:stretch>
+            <a:fillRect/>
+          </a:stretch>
+        </p:blipFill>
+        <p:spPr>
+          <a:xfrm>
+            <a:off x="5257800" y="1508760"/>
+            <a:ext cx="1737360" cy="1234440"/>
+          </a:xfrm>
+          <a:prstGeom prst="rect">
+            <a:avLst/>
+          </a:prstGeom>
+        </p:spPr>
+      </p:pic>
+      <p:sp>
+        <p:nvSpPr>
+          <p:cNvPr id="11" name="TextBox 10"/>
+          <p:cNvSpPr txBox="1"/>
+          <p:nvPr/>
+        </p:nvSpPr>
+        <p:spPr>
+          <a:xfrm>
+            <a:off x="4663440" y="2788920"/>
+            <a:ext cx="2926080" cy="640080"/>
+          </a:xfrm>
+          <a:prstGeom prst="rect">
+            <a:avLst/>
+          </a:prstGeom>
+          <a:noFill/>
+        </p:spPr>
+        <p:txBody>
+          <a:bodyPr wrap="square">
+            <a:spAutoFit/>
+          </a:bodyPr>
+          <a:lstStyle/>
+          <a:p>
+            <a:pPr algn="ctr">
+              <a:defRPr sz="1050">
                 <a:solidFill>
                   <a:srgbClr val="1E293B"/>
                 </a:solidFill>
               </a:defRPr>
             </a:pPr>
             <a:r>
-              <a:t>1</a:t>
-            </a:r>
-          </a:p>
-        </p:txBody>
-      </p:sp>
-      <p:sp>
-        <p:nvSpPr>
-          <p:cNvPr id="6" name="Rounded Rectangle 5"/>
+              <a:t>Failure of deep learning on rotated scans</a:t>
+            </a:r>
+          </a:p>
+          <a:p>
+            <a:pPr algn="ctr">
+              <a:defRPr sz="1050">
+                <a:solidFill>
+                  <a:srgbClr val="1E293B"/>
+                </a:solidFill>
+              </a:defRPr>
+            </a:pPr>
+            <a:r>
+              <a:t>Poor generalization on low-contrast NCCT</a:t>
+            </a:r>
+          </a:p>
+        </p:txBody>
+      </p:sp>
+      <p:sp>
+        <p:nvSpPr>
+          <p:cNvPr id="12" name="TextBox 11"/>
+          <p:cNvSpPr txBox="1"/>
+          <p:nvPr/>
+        </p:nvSpPr>
+        <p:spPr>
+          <a:xfrm>
+            <a:off x="8229600" y="1188720"/>
+            <a:ext cx="2926080" cy="320040"/>
+          </a:xfrm>
+          <a:prstGeom prst="rect">
+            <a:avLst/>
+          </a:prstGeom>
+          <a:noFill/>
+        </p:spPr>
+        <p:txBody>
+          <a:bodyPr wrap="none">
+            <a:spAutoFit/>
+          </a:bodyPr>
+          <a:lstStyle/>
+          <a:p>
+            <a:pPr algn="ctr">
+              <a:defRPr sz="1500" b="1"/>
+            </a:pPr>
+            <a:r>
+              <a:t>Medical Doctor</a:t>
+            </a:r>
+          </a:p>
+        </p:txBody>
+      </p:sp>
+      <p:pic>
+        <p:nvPicPr>
+          <p:cNvPr id="13" name="Picture 12" descr="slide1_doctor_visual.png"/>
+          <p:cNvPicPr>
+            <a:picLocks noChangeAspect="1"/>
+          </p:cNvPicPr>
+          <p:nvPr/>
+        </p:nvPicPr>
+        <p:blipFill>
+          <a:blip r:embed="rId6"/>
+          <a:stretch>
+            <a:fillRect/>
+          </a:stretch>
+        </p:blipFill>
+        <p:spPr>
+          <a:xfrm>
+            <a:off x="8595360" y="1508760"/>
+            <a:ext cx="2194560" cy="1234440"/>
+          </a:xfrm>
+          <a:prstGeom prst="rect">
+            <a:avLst/>
+          </a:prstGeom>
+        </p:spPr>
+      </p:pic>
+      <p:sp>
+        <p:nvSpPr>
+          <p:cNvPr id="14" name="TextBox 13"/>
+          <p:cNvSpPr txBox="1"/>
+          <p:nvPr/>
+        </p:nvSpPr>
+        <p:spPr>
+          <a:xfrm>
+            <a:off x="8229600" y="2788920"/>
+            <a:ext cx="2926080" cy="640080"/>
+          </a:xfrm>
+          <a:prstGeom prst="rect">
+            <a:avLst/>
+          </a:prstGeom>
+          <a:noFill/>
+        </p:spPr>
+        <p:txBody>
+          <a:bodyPr wrap="square">
+            <a:spAutoFit/>
+          </a:bodyPr>
+          <a:lstStyle/>
+          <a:p>
+            <a:pPr algn="ctr">
+              <a:defRPr sz="1050">
+                <a:solidFill>
+                  <a:srgbClr val="1E293B"/>
+                </a:solidFill>
+              </a:defRPr>
+            </a:pPr>
+            <a:r>
+              <a:t>Subjectivity of human judgment</a:t>
+            </a:r>
+          </a:p>
+          <a:p>
+            <a:pPr algn="ctr">
+              <a:defRPr sz="1050">
+                <a:solidFill>
+                  <a:srgbClr val="1E293B"/>
+                </a:solidFill>
+              </a:defRPr>
+            </a:pPr>
+            <a:r>
+              <a:t>Variability of tumor boundary delineation</a:t>
+            </a:r>
+          </a:p>
+        </p:txBody>
+      </p:sp>
+      <p:sp>
+        <p:nvSpPr>
+          <p:cNvPr id="15" name="Rounded Rectangle 14"/>
           <p:cNvSpPr/>
           <p:nvPr/>
         </p:nvSpPr>
         <p:spPr>
           <a:xfrm>
-            <a:off x="731520" y="1280160"/>
-            <a:ext cx="3383280" cy="2011680"/>
+            <a:off x="1828800" y="3611880"/>
+            <a:ext cx="8595360" cy="1783080"/>
           </a:xfrm>
           <a:prstGeom prst="roundRect">
             <a:avLst/>
           </a:prstGeom>
           <a:solidFill>
-            <a:srgbClr val="FEE2E2"/>
+            <a:srgbClr val="FFFFFF"/>
           </a:solidFill>
           <a:ln w="19050">
             <a:solidFill>
-              <a:srgbClr val="DC2626"/>
+              <a:srgbClr val="0F2942"/>
             </a:solidFill>
           </a:ln>
         </p:spPr>
@@ -3281,397 +3565,150 @@
           </a:fontRef>
         </p:style>
         <p:txBody>
-          <a:bodyPr rtlCol="0" anchor="ctr" wrap="square"/>
-          <a:lstStyle/>
-          <a:p>
-            <a:pPr algn="ctr">
-              <a:defRPr sz="1400" b="1">
-                <a:solidFill>
-                  <a:srgbClr val="DC2626"/>
-                </a:solidFill>
-              </a:defRPr>
-            </a:pPr>
-            <a:r>
-              <a:t>Machine / Acquisition</a:t>
-            </a:r>
-          </a:p>
-          <a:p>
-            <a:pPr>
-              <a:spcBef>
-                <a:spcPts val="400"/>
-              </a:spcBef>
-              <a:defRPr sz="1100">
-                <a:solidFill>
-                  <a:srgbClr val="1E293B"/>
-                </a:solidFill>
-              </a:defRPr>
-            </a:pPr>
-            <a:r>
-              <a:t>• The rotation &amp; head tilt problem</a:t>
-            </a:r>
-          </a:p>
-          <a:p>
-            <a:pPr>
-              <a:spcBef>
-                <a:spcPts val="400"/>
-              </a:spcBef>
-              <a:defRPr sz="1100">
-                <a:solidFill>
-                  <a:srgbClr val="1E293B"/>
-                </a:solidFill>
-              </a:defRPr>
-            </a:pPr>
-            <a:r>
-              <a:t>• Sparse 5mm slice thickness &amp; couch gaps</a:t>
-            </a:r>
-          </a:p>
-          <a:p>
-            <a:pPr>
-              <a:spcBef>
-                <a:spcPts val="400"/>
-              </a:spcBef>
-              <a:defRPr sz="1100">
-                <a:solidFill>
-                  <a:srgbClr val="1E293B"/>
-                </a:solidFill>
-              </a:defRPr>
-            </a:pPr>
-            <a:r>
-              <a:t>• Cross-vendor variability (GE, Siemens, Philips)</a:t>
-            </a:r>
-          </a:p>
-        </p:txBody>
-      </p:sp>
-      <p:sp>
-        <p:nvSpPr>
-          <p:cNvPr id="7" name="Rounded Rectangle 6"/>
-          <p:cNvSpPr/>
+          <a:bodyPr rtlCol="0" anchor="ctr"/>
+          <a:lstStyle/>
+          <a:p>
+            <a:pPr algn="ctr"/>
+          </a:p>
+        </p:txBody>
+      </p:sp>
+      <p:sp>
+        <p:nvSpPr>
+          <p:cNvPr id="16" name="TextBox 15"/>
+          <p:cNvSpPr txBox="1"/>
           <p:nvPr/>
         </p:nvSpPr>
         <p:spPr>
           <a:xfrm>
-            <a:off x="4389120" y="1280160"/>
-            <a:ext cx="3383280" cy="2011680"/>
-          </a:xfrm>
-          <a:prstGeom prst="roundRect">
-            <a:avLst/>
-          </a:prstGeom>
-          <a:solidFill>
-            <a:srgbClr val="FEF3C7"/>
-          </a:solidFill>
-          <a:ln w="19050">
-            <a:solidFill>
-              <a:srgbClr val="D97706"/>
-            </a:solidFill>
-          </a:ln>
-        </p:spPr>
-        <p:style>
-          <a:lnRef idx="1">
-            <a:schemeClr val="accent1"/>
-          </a:lnRef>
-          <a:fillRef idx="3">
-            <a:schemeClr val="accent1"/>
-          </a:fillRef>
-          <a:effectRef idx="2">
-            <a:schemeClr val="accent1"/>
-          </a:effectRef>
-          <a:fontRef idx="minor">
-            <a:schemeClr val="lt1"/>
-          </a:fontRef>
-        </p:style>
-        <p:txBody>
-          <a:bodyPr rtlCol="0" anchor="ctr" wrap="square"/>
-          <a:lstStyle/>
-          <a:p>
-            <a:pPr algn="ctr">
-              <a:defRPr sz="1400" b="1">
-                <a:solidFill>
-                  <a:srgbClr val="D97706"/>
-                </a:solidFill>
-              </a:defRPr>
-            </a:pPr>
-            <a:r>
-              <a:t>Software / AI</a:t>
-            </a:r>
-          </a:p>
-          <a:p>
-            <a:pPr>
-              <a:spcBef>
-                <a:spcPts val="400"/>
-              </a:spcBef>
-              <a:defRPr sz="1100">
-                <a:solidFill>
-                  <a:srgbClr val="1E293B"/>
-                </a:solidFill>
-              </a:defRPr>
-            </a:pPr>
-            <a:r>
-              <a:t>• Failure of standard CNNs on rotated scans</a:t>
-            </a:r>
-          </a:p>
-          <a:p>
-            <a:pPr>
-              <a:spcBef>
-                <a:spcPts val="400"/>
-              </a:spcBef>
-              <a:defRPr sz="1100">
-                <a:solidFill>
-                  <a:srgbClr val="1E293B"/>
-                </a:solidFill>
-              </a:defRPr>
-            </a:pPr>
-            <a:r>
-              <a:t>• Severe 12–18% Dice drop under domain shift</a:t>
-            </a:r>
-          </a:p>
-          <a:p>
-            <a:pPr>
-              <a:spcBef>
-                <a:spcPts val="400"/>
-              </a:spcBef>
-              <a:defRPr sz="1100">
-                <a:solidFill>
-                  <a:srgbClr val="1E293B"/>
-                </a:solidFill>
-              </a:defRPr>
-            </a:pPr>
-            <a:r>
-              <a:t>• Overconfident false positive tumor predictions</a:t>
-            </a:r>
-          </a:p>
-        </p:txBody>
-      </p:sp>
-      <p:sp>
-        <p:nvSpPr>
-          <p:cNvPr id="8" name="Rounded Rectangle 7"/>
-          <p:cNvSpPr/>
-          <p:nvPr/>
-        </p:nvSpPr>
-        <p:spPr>
-          <a:xfrm>
-            <a:off x="8046720" y="1280160"/>
-            <a:ext cx="3383280" cy="2011680"/>
-          </a:xfrm>
-          <a:prstGeom prst="roundRect">
-            <a:avLst/>
-          </a:prstGeom>
-          <a:solidFill>
-            <a:srgbClr val="EEF2FF"/>
-          </a:solidFill>
-          <a:ln w="19050">
-            <a:solidFill>
-              <a:srgbClr val="1E3A8A"/>
-            </a:solidFill>
-          </a:ln>
-        </p:spPr>
-        <p:style>
-          <a:lnRef idx="1">
-            <a:schemeClr val="accent1"/>
-          </a:lnRef>
-          <a:fillRef idx="3">
-            <a:schemeClr val="accent1"/>
-          </a:fillRef>
-          <a:effectRef idx="2">
-            <a:schemeClr val="accent1"/>
-          </a:effectRef>
-          <a:fontRef idx="minor">
-            <a:schemeClr val="lt1"/>
-          </a:fontRef>
-        </p:style>
-        <p:txBody>
-          <a:bodyPr rtlCol="0" anchor="ctr" wrap="square"/>
-          <a:lstStyle/>
-          <a:p>
-            <a:pPr algn="ctr">
-              <a:defRPr sz="1400" b="1">
-                <a:solidFill>
-                  <a:srgbClr val="1E3A8A"/>
-                </a:solidFill>
-              </a:defRPr>
-            </a:pPr>
-            <a:r>
-              <a:t>Medical Doctor</a:t>
-            </a:r>
-          </a:p>
-          <a:p>
-            <a:pPr>
-              <a:spcBef>
-                <a:spcPts val="400"/>
-              </a:spcBef>
-              <a:defRPr sz="1100">
-                <a:solidFill>
-                  <a:srgbClr val="1E293B"/>
-                </a:solidFill>
-              </a:defRPr>
-            </a:pPr>
-            <a:r>
-              <a:t>• Subjectivity of human boundary delineation</a:t>
-            </a:r>
-          </a:p>
-          <a:p>
-            <a:pPr>
-              <a:spcBef>
-                <a:spcPts val="400"/>
-              </a:spcBef>
-              <a:defRPr sz="1100">
-                <a:solidFill>
-                  <a:srgbClr val="1E293B"/>
-                </a:solidFill>
-              </a:defRPr>
-            </a:pPr>
-            <a:r>
-              <a:t>• High inter-observer variance (Dice 65–75%)</a:t>
-            </a:r>
-          </a:p>
-          <a:p>
-            <a:pPr>
-              <a:spcBef>
-                <a:spcPts val="400"/>
-              </a:spcBef>
-              <a:defRPr sz="1100">
-                <a:solidFill>
-                  <a:srgbClr val="1E293B"/>
-                </a:solidFill>
-              </a:defRPr>
-            </a:pPr>
-            <a:r>
-              <a:t>• Subtle tumor contrast on Non-Contrast CT</a:t>
-            </a:r>
-          </a:p>
-        </p:txBody>
-      </p:sp>
-      <p:sp>
-        <p:nvSpPr>
-          <p:cNvPr id="9" name="Rounded Rectangle 8"/>
-          <p:cNvSpPr/>
-          <p:nvPr/>
-        </p:nvSpPr>
-        <p:spPr>
-          <a:xfrm>
-            <a:off x="731520" y="3566160"/>
-            <a:ext cx="10698480" cy="1691640"/>
-          </a:xfrm>
-          <a:prstGeom prst="roundRect">
-            <a:avLst/>
-          </a:prstGeom>
-          <a:solidFill>
-            <a:srgbClr val="FFFFFF"/>
-          </a:solidFill>
-          <a:ln w="25400">
-            <a:solidFill>
-              <a:srgbClr val="15803D"/>
-            </a:solidFill>
-          </a:ln>
-        </p:spPr>
-        <p:style>
-          <a:lnRef idx="1">
-            <a:schemeClr val="accent1"/>
-          </a:lnRef>
-          <a:fillRef idx="3">
-            <a:schemeClr val="accent1"/>
-          </a:fillRef>
-          <a:effectRef idx="2">
-            <a:schemeClr val="accent1"/>
-          </a:effectRef>
-          <a:fontRef idx="minor">
-            <a:schemeClr val="lt1"/>
-          </a:fontRef>
-        </p:style>
-        <p:txBody>
-          <a:bodyPr rtlCol="0" anchor="ctr" wrap="square"/>
-          <a:lstStyle/>
-          <a:p>
-            <a:pPr algn="ctr">
-              <a:defRPr sz="1800" b="1">
-                <a:solidFill>
-                  <a:srgbClr val="15803D"/>
-                </a:solidFill>
-              </a:defRPr>
-            </a:pPr>
-            <a:r>
-              <a:t>Mod-Seg-SE(2) Consensus Platform</a:t>
-            </a:r>
-          </a:p>
-          <a:p>
-            <a:pPr algn="ctr">
-              <a:spcBef>
-                <a:spcPts val="400"/>
-              </a:spcBef>
-              <a:defRPr sz="1300" b="1">
-                <a:solidFill>
-                  <a:srgbClr val="0F2942"/>
-                </a:solidFill>
-              </a:defRPr>
-            </a:pPr>
-            <a:r>
-              <a:t>Equivariant Group Theory Backbone (N=8 discrete rotations) + 6-Model Consensus Heatmap Engine</a:t>
-            </a:r>
-          </a:p>
-          <a:p>
-            <a:pPr algn="ctr">
-              <a:spcBef>
-                <a:spcPts val="400"/>
-              </a:spcBef>
-              <a:defRPr sz="1100">
-                <a:solidFill>
-                  <a:srgbClr val="64748B"/>
-                </a:solidFill>
-              </a:defRPr>
-            </a:pPr>
-            <a:r>
-              <a:t>Solves rotational invariance at the mathematical group level • Eliminates radiologist inter-observer variability • Quantifies 3D multi-slice tumor volume</a:t>
-            </a:r>
-          </a:p>
-        </p:txBody>
-      </p:sp>
-      <p:sp>
-        <p:nvSpPr>
-          <p:cNvPr id="10" name="Rectangle 9"/>
-          <p:cNvSpPr/>
-          <p:nvPr/>
-        </p:nvSpPr>
-        <p:spPr>
-          <a:xfrm>
-            <a:off x="2286000" y="5486400"/>
-            <a:ext cx="7589520" cy="640080"/>
+            <a:off x="1828800" y="3685032"/>
+            <a:ext cx="8595360" cy="365760"/>
           </a:xfrm>
           <a:prstGeom prst="rect">
             <a:avLst/>
           </a:prstGeom>
-          <a:solidFill>
-            <a:srgbClr val="15803D"/>
-          </a:solidFill>
-          <a:ln>
-            <a:noFill/>
-          </a:ln>
-        </p:spPr>
-        <p:style>
-          <a:lnRef idx="1">
-            <a:schemeClr val="accent1"/>
-          </a:lnRef>
-          <a:fillRef idx="3">
-            <a:schemeClr val="accent1"/>
-          </a:fillRef>
-          <a:effectRef idx="2">
-            <a:schemeClr val="accent1"/>
-          </a:effectRef>
-          <a:fontRef idx="minor">
-            <a:schemeClr val="lt1"/>
-          </a:fontRef>
-        </p:style>
-        <p:txBody>
-          <a:bodyPr rtlCol="0" anchor="ctr"/>
+          <a:noFill/>
+        </p:spPr>
+        <p:txBody>
+          <a:bodyPr wrap="none">
+            <a:spAutoFit/>
+          </a:bodyPr>
           <a:lstStyle/>
           <a:p>
             <a:pPr algn="ctr">
-              <a:defRPr sz="1550" b="1">
-                <a:solidFill>
-                  <a:srgbClr val="FFFFFF"/>
+              <a:defRPr sz="1700" b="1" u="sng">
+                <a:solidFill>
+                  <a:srgbClr val="0F2942"/>
                 </a:solidFill>
               </a:defRPr>
             </a:pPr>
             <a:r>
-              <a:t>84.2% Dice | 73.1% IoU SOTA Segmentation &amp; Quantitative 3D Volumetry</a:t>
+              <a:t>Brain-CT-Seg</a:t>
+            </a:r>
+          </a:p>
+        </p:txBody>
+      </p:sp>
+      <p:pic>
+        <p:nvPicPr>
+          <p:cNvPr id="17" name="Picture 16" descr="ref_robots.png"/>
+          <p:cNvPicPr>
+            <a:picLocks noChangeAspect="1"/>
+          </p:cNvPicPr>
+          <p:nvPr/>
+        </p:nvPicPr>
+        <p:blipFill>
+          <a:blip r:embed="rId7"/>
+          <a:stretch>
+            <a:fillRect/>
+          </a:stretch>
+        </p:blipFill>
+        <p:spPr>
+          <a:xfrm>
+            <a:off x="3749040" y="4050792"/>
+            <a:ext cx="4754880" cy="960120"/>
+          </a:xfrm>
+          <a:prstGeom prst="rect">
+            <a:avLst/>
+          </a:prstGeom>
+        </p:spPr>
+      </p:pic>
+      <p:sp>
+        <p:nvSpPr>
+          <p:cNvPr id="18" name="TextBox 17"/>
+          <p:cNvSpPr txBox="1"/>
+          <p:nvPr/>
+        </p:nvSpPr>
+        <p:spPr>
+          <a:xfrm>
+            <a:off x="1828800" y="5029200"/>
+            <a:ext cx="8595360" cy="320040"/>
+          </a:xfrm>
+          <a:prstGeom prst="rect">
+            <a:avLst/>
+          </a:prstGeom>
+          <a:noFill/>
+        </p:spPr>
+        <p:txBody>
+          <a:bodyPr wrap="none">
+            <a:spAutoFit/>
+          </a:bodyPr>
+          <a:lstStyle/>
+          <a:p>
+            <a:pPr algn="ctr">
+              <a:defRPr sz="1100">
+                <a:solidFill>
+                  <a:srgbClr val="0F2942"/>
+                </a:solidFill>
+              </a:defRPr>
+            </a:pPr>
+            <a:r>
+              <a:t>AI Agent (Segmentation Agent and Volumetric Reporting Agent)</a:t>
+            </a:r>
+          </a:p>
+        </p:txBody>
+      </p:sp>
+      <p:sp>
+        <p:nvSpPr>
+          <p:cNvPr id="19" name="TextBox 18"/>
+          <p:cNvSpPr txBox="1"/>
+          <p:nvPr/>
+        </p:nvSpPr>
+        <p:spPr>
+          <a:xfrm>
+            <a:off x="1828800" y="5486400"/>
+            <a:ext cx="8595360" cy="731520"/>
+          </a:xfrm>
+          <a:prstGeom prst="rect">
+            <a:avLst/>
+          </a:prstGeom>
+          <a:noFill/>
+        </p:spPr>
+        <p:txBody>
+          <a:bodyPr wrap="none">
+            <a:spAutoFit/>
+          </a:bodyPr>
+          <a:lstStyle/>
+          <a:p>
+            <a:pPr algn="ctr">
+              <a:defRPr sz="2400" b="1">
+                <a:solidFill>
+                  <a:srgbClr val="15803D"/>
+                </a:solidFill>
+              </a:defRPr>
+            </a:pPr>
+            <a:r>
+              <a:t>84.2% Dice | 73.1% IoU</a:t>
+            </a:r>
+          </a:p>
+          <a:p>
+            <a:pPr algn="ctr">
+              <a:defRPr sz="1200">
+                <a:solidFill>
+                  <a:srgbClr val="0F2942"/>
+                </a:solidFill>
+              </a:defRPr>
+            </a:pPr>
+            <a:r>
+              <a:t>Brain Tumor Segmentation &amp; Quantitative 3D Volumetry</a:t>
             </a:r>
           </a:p>
         </p:txBody>
@@ -3694,16 +3731,40 @@
         <p:nvPr/>
       </p:nvGrpSpPr>
       <p:grpSpPr/>
-      <p:sp>
-        <p:nvSpPr>
-          <p:cNvPr id="2" name="TextBox 1"/>
+      <p:pic>
+        <p:nvPicPr>
+          <p:cNvPr id="2" name="Picture 1" descr="logo_osl.png"/>
+          <p:cNvPicPr>
+            <a:picLocks noChangeAspect="1"/>
+          </p:cNvPicPr>
+          <p:nvPr/>
+        </p:nvPicPr>
+        <p:blipFill>
+          <a:blip r:embed="rId2"/>
+          <a:stretch>
+            <a:fillRect/>
+          </a:stretch>
+        </p:blipFill>
+        <p:spPr>
+          <a:xfrm>
+            <a:off x="548640" y="320040"/>
+            <a:ext cx="1645920" cy="777240"/>
+          </a:xfrm>
+          <a:prstGeom prst="rect">
+            <a:avLst/>
+          </a:prstGeom>
+        </p:spPr>
+      </p:pic>
+      <p:sp>
+        <p:nvSpPr>
+          <p:cNvPr id="3" name="TextBox 2"/>
           <p:cNvSpPr txBox="1"/>
           <p:nvPr/>
         </p:nvSpPr>
         <p:spPr>
           <a:xfrm>
-            <a:off x="731520" y="365760"/>
-            <a:ext cx="2286000" cy="548640"/>
+            <a:off x="2468880" y="320040"/>
+            <a:ext cx="8961120" cy="777240"/>
           </a:xfrm>
           <a:prstGeom prst="rect">
             <a:avLst/>
@@ -3717,28 +3778,64 @@
           <a:lstStyle/>
           <a:p>
             <a:pPr>
-              <a:defRPr sz="1300" b="1">
-                <a:solidFill>
-                  <a:srgbClr val="0F2942"/>
+              <a:defRPr sz="2100" b="1">
+                <a:solidFill>
+                  <a:srgbClr val="1E3A8A"/>
                 </a:solidFill>
               </a:defRPr>
             </a:pPr>
             <a:r>
-              <a:t>OPTICAL SYSTEMS LAB</a:t>
-            </a:r>
-          </a:p>
-        </p:txBody>
-      </p:sp>
-      <p:sp>
-        <p:nvSpPr>
-          <p:cNvPr id="3" name="TextBox 2"/>
+              <a:t>Framework Prototype</a:t>
+            </a:r>
+          </a:p>
+          <a:p>
+            <a:pPr>
+              <a:defRPr sz="1200">
+                <a:solidFill>
+                  <a:srgbClr val="64748B"/>
+                </a:solidFill>
+              </a:defRPr>
+            </a:pPr>
+            <a:r>
+              <a:t>A clinical brain tumor evaluation platform in a browser tab</a:t>
+            </a:r>
+          </a:p>
+        </p:txBody>
+      </p:sp>
+      <p:pic>
+        <p:nvPicPr>
+          <p:cNvPr id="4" name="Picture 3" descr="logo_ntu.png"/>
+          <p:cNvPicPr>
+            <a:picLocks noChangeAspect="1"/>
+          </p:cNvPicPr>
+          <p:nvPr/>
+        </p:nvPicPr>
+        <p:blipFill>
+          <a:blip r:embed="rId3"/>
+          <a:stretch>
+            <a:fillRect/>
+          </a:stretch>
+        </p:blipFill>
+        <p:spPr>
+          <a:xfrm>
+            <a:off x="548640" y="6217920"/>
+            <a:ext cx="2377440" cy="502920"/>
+          </a:xfrm>
+          <a:prstGeom prst="rect">
+            <a:avLst/>
+          </a:prstGeom>
+        </p:spPr>
+      </p:pic>
+      <p:sp>
+        <p:nvSpPr>
+          <p:cNvPr id="5" name="TextBox 4"/>
           <p:cNvSpPr txBox="1"/>
           <p:nvPr/>
         </p:nvSpPr>
         <p:spPr>
           <a:xfrm>
-            <a:off x="3017520" y="320040"/>
-            <a:ext cx="8412480" cy="731520"/>
+            <a:off x="11155680" y="6263640"/>
+            <a:ext cx="548640" cy="365760"/>
           </a:xfrm>
           <a:prstGeom prst="rect">
             <a:avLst/>
@@ -3746,95 +3843,13 @@
           <a:noFill/>
         </p:spPr>
         <p:txBody>
-          <a:bodyPr wrap="square">
-            <a:spAutoFit/>
-          </a:bodyPr>
-          <a:lstStyle/>
-          <a:p>
-            <a:pPr>
-              <a:defRPr sz="2100" b="1">
-                <a:solidFill>
-                  <a:srgbClr val="1E3A8A"/>
-                </a:solidFill>
-              </a:defRPr>
-            </a:pPr>
-            <a:r>
-              <a:t>Framework Prototype</a:t>
-            </a:r>
-          </a:p>
-          <a:p>
-            <a:pPr>
-              <a:defRPr sz="1200">
-                <a:solidFill>
-                  <a:srgbClr val="64748B"/>
-                </a:solidFill>
-              </a:defRPr>
-            </a:pPr>
-            <a:r>
-              <a:t>A clinical brain tumor evaluation platform in a browser tab</a:t>
-            </a:r>
-          </a:p>
-        </p:txBody>
-      </p:sp>
-      <p:sp>
-        <p:nvSpPr>
-          <p:cNvPr id="4" name="TextBox 3"/>
-          <p:cNvSpPr txBox="1"/>
-          <p:nvPr/>
-        </p:nvSpPr>
-        <p:spPr>
-          <a:xfrm>
-            <a:off x="731520" y="6446520"/>
-            <a:ext cx="5486400" cy="320040"/>
-          </a:xfrm>
-          <a:prstGeom prst="rect">
-            <a:avLst/>
-          </a:prstGeom>
-          <a:noFill/>
-        </p:spPr>
-        <p:txBody>
           <a:bodyPr wrap="none">
             <a:spAutoFit/>
           </a:bodyPr>
           <a:lstStyle/>
           <a:p>
             <a:pPr>
-              <a:defRPr sz="1000">
-                <a:solidFill>
-                  <a:srgbClr val="64748B"/>
-                </a:solidFill>
-              </a:defRPr>
-            </a:pPr>
-            <a:r>
-              <a:t>National Taiwan University • NTU GSAT | Brain-CTC-Seg Consortium</a:t>
-            </a:r>
-          </a:p>
-        </p:txBody>
-      </p:sp>
-      <p:sp>
-        <p:nvSpPr>
-          <p:cNvPr id="5" name="TextBox 4"/>
-          <p:cNvSpPr txBox="1"/>
-          <p:nvPr/>
-        </p:nvSpPr>
-        <p:spPr>
-          <a:xfrm>
-            <a:off x="10972800" y="6446520"/>
-            <a:ext cx="731520" cy="320040"/>
-          </a:xfrm>
-          <a:prstGeom prst="rect">
-            <a:avLst/>
-          </a:prstGeom>
-          <a:noFill/>
-        </p:spPr>
-        <p:txBody>
-          <a:bodyPr wrap="none">
-            <a:spAutoFit/>
-          </a:bodyPr>
-          <a:lstStyle/>
-          <a:p>
-            <a:pPr>
-              <a:defRPr sz="1100" b="1">
+              <a:defRPr sz="1200">
                 <a:solidFill>
                   <a:srgbClr val="1E293B"/>
                 </a:solidFill>
@@ -3907,7 +3922,7 @@
           <p:nvPr/>
         </p:nvPicPr>
         <p:blipFill>
-          <a:blip r:embed="rId2"/>
+          <a:blip r:embed="rId4"/>
           <a:stretch>
             <a:fillRect/>
           </a:stretch>
@@ -4143,7 +4158,7 @@
         </p:nvSpPr>
         <p:spPr>
           <a:xfrm>
-            <a:off x="731520" y="5577840"/>
+            <a:off x="731520" y="5532120"/>
             <a:ext cx="2066543" cy="502920"/>
           </a:xfrm>
           <a:prstGeom prst="roundRect">
@@ -4195,7 +4210,7 @@
         </p:nvSpPr>
         <p:spPr>
           <a:xfrm>
-            <a:off x="2889504" y="5577840"/>
+            <a:off x="2889504" y="5532120"/>
             <a:ext cx="2066543" cy="502920"/>
           </a:xfrm>
           <a:prstGeom prst="roundRect">
@@ -4247,7 +4262,7 @@
         </p:nvSpPr>
         <p:spPr>
           <a:xfrm>
-            <a:off x="5047488" y="5577840"/>
+            <a:off x="5047488" y="5532120"/>
             <a:ext cx="2066543" cy="502920"/>
           </a:xfrm>
           <a:prstGeom prst="roundRect">
@@ -4299,7 +4314,7 @@
         </p:nvSpPr>
         <p:spPr>
           <a:xfrm>
-            <a:off x="7205472" y="5577840"/>
+            <a:off x="7205472" y="5532120"/>
             <a:ext cx="2066543" cy="502920"/>
           </a:xfrm>
           <a:prstGeom prst="roundRect">
@@ -4351,7 +4366,7 @@
         </p:nvSpPr>
         <p:spPr>
           <a:xfrm>
-            <a:off x="9363456" y="5577840"/>
+            <a:off x="9363456" y="5532120"/>
             <a:ext cx="2066543" cy="502920"/>
           </a:xfrm>
           <a:prstGeom prst="roundRect">
@@ -4413,16 +4428,40 @@
         <p:nvPr/>
       </p:nvGrpSpPr>
       <p:grpSpPr/>
-      <p:sp>
-        <p:nvSpPr>
-          <p:cNvPr id="2" name="TextBox 1"/>
+      <p:pic>
+        <p:nvPicPr>
+          <p:cNvPr id="2" name="Picture 1" descr="logo_osl.png"/>
+          <p:cNvPicPr>
+            <a:picLocks noChangeAspect="1"/>
+          </p:cNvPicPr>
+          <p:nvPr/>
+        </p:nvPicPr>
+        <p:blipFill>
+          <a:blip r:embed="rId2"/>
+          <a:stretch>
+            <a:fillRect/>
+          </a:stretch>
+        </p:blipFill>
+        <p:spPr>
+          <a:xfrm>
+            <a:off x="548640" y="320040"/>
+            <a:ext cx="1645920" cy="777240"/>
+          </a:xfrm>
+          <a:prstGeom prst="rect">
+            <a:avLst/>
+          </a:prstGeom>
+        </p:spPr>
+      </p:pic>
+      <p:sp>
+        <p:nvSpPr>
+          <p:cNvPr id="3" name="TextBox 2"/>
           <p:cNvSpPr txBox="1"/>
           <p:nvPr/>
         </p:nvSpPr>
         <p:spPr>
           <a:xfrm>
-            <a:off x="731520" y="365760"/>
-            <a:ext cx="2286000" cy="548640"/>
+            <a:off x="2468880" y="320040"/>
+            <a:ext cx="8961120" cy="777240"/>
           </a:xfrm>
           <a:prstGeom prst="rect">
             <a:avLst/>
@@ -4436,28 +4475,52 @@
           <a:lstStyle/>
           <a:p>
             <a:pPr>
-              <a:defRPr sz="1300" b="1">
-                <a:solidFill>
-                  <a:srgbClr val="0F2942"/>
+              <a:defRPr sz="2100" b="1">
+                <a:solidFill>
+                  <a:srgbClr val="1E3A8A"/>
                 </a:solidFill>
               </a:defRPr>
             </a:pPr>
             <a:r>
-              <a:t>OPTICAL SYSTEMS LAB</a:t>
-            </a:r>
-          </a:p>
-        </p:txBody>
-      </p:sp>
-      <p:sp>
-        <p:nvSpPr>
-          <p:cNvPr id="3" name="TextBox 2"/>
+              <a:t>Advantage of Mod-Seg-SE(2)</a:t>
+            </a:r>
+          </a:p>
+        </p:txBody>
+      </p:sp>
+      <p:pic>
+        <p:nvPicPr>
+          <p:cNvPr id="4" name="Picture 3" descr="logo_ntu.png"/>
+          <p:cNvPicPr>
+            <a:picLocks noChangeAspect="1"/>
+          </p:cNvPicPr>
+          <p:nvPr/>
+        </p:nvPicPr>
+        <p:blipFill>
+          <a:blip r:embed="rId3"/>
+          <a:stretch>
+            <a:fillRect/>
+          </a:stretch>
+        </p:blipFill>
+        <p:spPr>
+          <a:xfrm>
+            <a:off x="548640" y="6217920"/>
+            <a:ext cx="2377440" cy="502920"/>
+          </a:xfrm>
+          <a:prstGeom prst="rect">
+            <a:avLst/>
+          </a:prstGeom>
+        </p:spPr>
+      </p:pic>
+      <p:sp>
+        <p:nvSpPr>
+          <p:cNvPr id="5" name="TextBox 4"/>
           <p:cNvSpPr txBox="1"/>
           <p:nvPr/>
         </p:nvSpPr>
         <p:spPr>
           <a:xfrm>
-            <a:off x="3017520" y="320040"/>
-            <a:ext cx="8412480" cy="731520"/>
+            <a:off x="11155680" y="6263640"/>
+            <a:ext cx="548640" cy="365760"/>
           </a:xfrm>
           <a:prstGeom prst="rect">
             <a:avLst/>
@@ -4465,95 +4528,13 @@
           <a:noFill/>
         </p:spPr>
         <p:txBody>
-          <a:bodyPr wrap="square">
-            <a:spAutoFit/>
-          </a:bodyPr>
-          <a:lstStyle/>
-          <a:p>
-            <a:pPr>
-              <a:defRPr sz="2100" b="1">
-                <a:solidFill>
-                  <a:srgbClr val="1E3A8A"/>
-                </a:solidFill>
-              </a:defRPr>
-            </a:pPr>
-            <a:r>
-              <a:t>Advantage of Mod-Seg-SE(2)</a:t>
-            </a:r>
-          </a:p>
-          <a:p>
-            <a:pPr>
-              <a:defRPr sz="1200">
-                <a:solidFill>
-                  <a:srgbClr val="64748B"/>
-                </a:solidFill>
-              </a:defRPr>
-            </a:pPr>
-            <a:r>
-              <a:t>Clinical Superiority Against Human Radiologists and Baseline CNNs</a:t>
-            </a:r>
-          </a:p>
-        </p:txBody>
-      </p:sp>
-      <p:sp>
-        <p:nvSpPr>
-          <p:cNvPr id="4" name="TextBox 3"/>
-          <p:cNvSpPr txBox="1"/>
-          <p:nvPr/>
-        </p:nvSpPr>
-        <p:spPr>
-          <a:xfrm>
-            <a:off x="731520" y="6446520"/>
-            <a:ext cx="5486400" cy="320040"/>
-          </a:xfrm>
-          <a:prstGeom prst="rect">
-            <a:avLst/>
-          </a:prstGeom>
-          <a:noFill/>
-        </p:spPr>
-        <p:txBody>
           <a:bodyPr wrap="none">
             <a:spAutoFit/>
           </a:bodyPr>
           <a:lstStyle/>
           <a:p>
             <a:pPr>
-              <a:defRPr sz="1000">
-                <a:solidFill>
-                  <a:srgbClr val="64748B"/>
-                </a:solidFill>
-              </a:defRPr>
-            </a:pPr>
-            <a:r>
-              <a:t>National Taiwan University • NTU GSAT | Brain-CTC-Seg Consortium</a:t>
-            </a:r>
-          </a:p>
-        </p:txBody>
-      </p:sp>
-      <p:sp>
-        <p:nvSpPr>
-          <p:cNvPr id="5" name="TextBox 4"/>
-          <p:cNvSpPr txBox="1"/>
-          <p:nvPr/>
-        </p:nvSpPr>
-        <p:spPr>
-          <a:xfrm>
-            <a:off x="10972800" y="6446520"/>
-            <a:ext cx="731520" cy="320040"/>
-          </a:xfrm>
-          <a:prstGeom prst="rect">
-            <a:avLst/>
-          </a:prstGeom>
-          <a:noFill/>
-        </p:spPr>
-        <p:txBody>
-          <a:bodyPr wrap="none">
-            <a:spAutoFit/>
-          </a:bodyPr>
-          <a:lstStyle/>
-          <a:p>
-            <a:pPr>
-              <a:defRPr sz="1100" b="1">
+              <a:defRPr sz="1200">
                 <a:solidFill>
                   <a:srgbClr val="1E293B"/>
                 </a:solidFill>
@@ -4573,8 +4554,8 @@
         </p:nvSpPr>
         <p:spPr>
           <a:xfrm>
-            <a:off x="731520" y="1143000"/>
-            <a:ext cx="5257800" cy="2423160"/>
+            <a:off x="731520" y="1097280"/>
+            <a:ext cx="5257800" cy="2331720"/>
           </a:xfrm>
           <a:prstGeom prst="roundRect">
             <a:avLst/>
@@ -4614,7 +4595,7 @@
               </a:defRPr>
             </a:pPr>
             <a:r>
-              <a:t>Objective Tumor Boundary Delineation</a:t>
+              <a:t>Objective tumor boundary delineation</a:t>
             </a:r>
           </a:p>
         </p:txBody>
@@ -4628,15 +4609,15 @@
           <p:nvPr/>
         </p:nvPicPr>
         <p:blipFill>
-          <a:blip r:embed="rId2"/>
+          <a:blip r:embed="rId4"/>
           <a:stretch>
             <a:fillRect/>
           </a:stretch>
         </p:blipFill>
         <p:spPr>
           <a:xfrm>
-            <a:off x="841248" y="1527048"/>
-            <a:ext cx="5038344" cy="1947672"/>
+            <a:off x="841248" y="1444752"/>
+            <a:ext cx="5038344" cy="1874519"/>
           </a:xfrm>
           <a:prstGeom prst="rect">
             <a:avLst/>
@@ -4651,8 +4632,8 @@
         </p:nvSpPr>
         <p:spPr>
           <a:xfrm>
-            <a:off x="6172200" y="1143000"/>
-            <a:ext cx="5257800" cy="2423160"/>
+            <a:off x="6172200" y="1097280"/>
+            <a:ext cx="5257800" cy="2331720"/>
           </a:xfrm>
           <a:prstGeom prst="roundRect">
             <a:avLst/>
@@ -4692,7 +4673,7 @@
               </a:defRPr>
             </a:pPr>
             <a:r>
-              <a:t>Higher Segmentation &amp; Diagnostic Accuracy</a:t>
+              <a:t>Higher diagnostic accuracy</a:t>
             </a:r>
           </a:p>
         </p:txBody>
@@ -4706,15 +4687,15 @@
           <p:nvPr/>
         </p:nvPicPr>
         <p:blipFill>
-          <a:blip r:embed="rId3"/>
+          <a:blip r:embed="rId5"/>
           <a:stretch>
             <a:fillRect/>
           </a:stretch>
         </p:blipFill>
         <p:spPr>
           <a:xfrm>
-            <a:off x="6281928" y="1527048"/>
-            <a:ext cx="5038344" cy="1947672"/>
+            <a:off x="6281928" y="1444752"/>
+            <a:ext cx="5038344" cy="1874519"/>
           </a:xfrm>
           <a:prstGeom prst="rect">
             <a:avLst/>
@@ -4729,8 +4710,8 @@
         </p:nvSpPr>
         <p:spPr>
           <a:xfrm>
-            <a:off x="731520" y="3703320"/>
-            <a:ext cx="5257800" cy="2423160"/>
+            <a:off x="731520" y="3566160"/>
+            <a:ext cx="5257800" cy="2331720"/>
           </a:xfrm>
           <a:prstGeom prst="roundRect">
             <a:avLst/>
@@ -4770,7 +4751,7 @@
               </a:defRPr>
             </a:pPr>
             <a:r>
-              <a:t>Stable Delineation Under Head Tilt &amp; Rotation</a:t>
+              <a:t>Stable delineation of borderline &amp; tilted cases</a:t>
             </a:r>
           </a:p>
         </p:txBody>
@@ -4784,15 +4765,15 @@
           <p:nvPr/>
         </p:nvPicPr>
         <p:blipFill>
-          <a:blip r:embed="rId4"/>
+          <a:blip r:embed="rId6"/>
           <a:stretch>
             <a:fillRect/>
           </a:stretch>
         </p:blipFill>
         <p:spPr>
           <a:xfrm>
-            <a:off x="841248" y="4087368"/>
-            <a:ext cx="5038344" cy="1947672"/>
+            <a:off x="841248" y="3913632"/>
+            <a:ext cx="5038344" cy="1874519"/>
           </a:xfrm>
           <a:prstGeom prst="rect">
             <a:avLst/>
@@ -4807,8 +4788,8 @@
         </p:nvSpPr>
         <p:spPr>
           <a:xfrm>
-            <a:off x="6172200" y="3703320"/>
-            <a:ext cx="5257800" cy="2423160"/>
+            <a:off x="6172200" y="3566160"/>
+            <a:ext cx="5257800" cy="2331720"/>
           </a:xfrm>
           <a:prstGeom prst="roundRect">
             <a:avLst/>
@@ -4848,7 +4829,7 @@
               </a:defRPr>
             </a:pPr>
             <a:r>
-              <a:t>Consistent, Structured Volumetric Reporting</a:t>
+              <a:t>Consistent, structured reporting</a:t>
             </a:r>
           </a:p>
         </p:txBody>
@@ -4862,15 +4843,15 @@
           <p:nvPr/>
         </p:nvPicPr>
         <p:blipFill>
-          <a:blip r:embed="rId5"/>
+          <a:blip r:embed="rId7"/>
           <a:stretch>
             <a:fillRect/>
           </a:stretch>
         </p:blipFill>
         <p:spPr>
           <a:xfrm>
-            <a:off x="6281928" y="4087368"/>
-            <a:ext cx="5038344" cy="1947672"/>
+            <a:off x="6281928" y="3913632"/>
+            <a:ext cx="5038344" cy="1874519"/>
           </a:xfrm>
           <a:prstGeom prst="rect">
             <a:avLst/>
@@ -4895,161 +4876,9 @@
         <p:nvPr/>
       </p:nvGrpSpPr>
       <p:grpSpPr/>
-      <p:sp>
-        <p:nvSpPr>
-          <p:cNvPr id="2" name="TextBox 1"/>
-          <p:cNvSpPr txBox="1"/>
-          <p:nvPr/>
-        </p:nvSpPr>
-        <p:spPr>
-          <a:xfrm>
-            <a:off x="731520" y="365760"/>
-            <a:ext cx="2286000" cy="548640"/>
-          </a:xfrm>
-          <a:prstGeom prst="rect">
-            <a:avLst/>
-          </a:prstGeom>
-          <a:noFill/>
-        </p:spPr>
-        <p:txBody>
-          <a:bodyPr wrap="square">
-            <a:spAutoFit/>
-          </a:bodyPr>
-          <a:lstStyle/>
-          <a:p>
-            <a:pPr>
-              <a:defRPr sz="1300" b="1">
-                <a:solidFill>
-                  <a:srgbClr val="0F2942"/>
-                </a:solidFill>
-              </a:defRPr>
-            </a:pPr>
-            <a:r>
-              <a:t>OPTICAL SYSTEMS LAB</a:t>
-            </a:r>
-          </a:p>
-        </p:txBody>
-      </p:sp>
-      <p:sp>
-        <p:nvSpPr>
-          <p:cNvPr id="3" name="TextBox 2"/>
-          <p:cNvSpPr txBox="1"/>
-          <p:nvPr/>
-        </p:nvSpPr>
-        <p:spPr>
-          <a:xfrm>
-            <a:off x="3017520" y="320040"/>
-            <a:ext cx="8412480" cy="731520"/>
-          </a:xfrm>
-          <a:prstGeom prst="rect">
-            <a:avLst/>
-          </a:prstGeom>
-          <a:noFill/>
-        </p:spPr>
-        <p:txBody>
-          <a:bodyPr wrap="square">
-            <a:spAutoFit/>
-          </a:bodyPr>
-          <a:lstStyle/>
-          <a:p>
-            <a:pPr>
-              <a:defRPr sz="2100" b="1">
-                <a:solidFill>
-                  <a:srgbClr val="1E3A8A"/>
-                </a:solidFill>
-              </a:defRPr>
-            </a:pPr>
-            <a:r>
-              <a:t>Mod-Seg-SE(2) Architecture &amp; Pipeline Flow</a:t>
-            </a:r>
-          </a:p>
-          <a:p>
-            <a:pPr>
-              <a:defRPr sz="1200">
-                <a:solidFill>
-                  <a:srgbClr val="64748B"/>
-                </a:solidFill>
-              </a:defRPr>
-            </a:pPr>
-            <a:r>
-              <a:t>Group Equivariant Convolutional Network (C8 / N=8 Rotations) with Multi-Model Consensus Engine</a:t>
-            </a:r>
-          </a:p>
-        </p:txBody>
-      </p:sp>
-      <p:sp>
-        <p:nvSpPr>
-          <p:cNvPr id="4" name="TextBox 3"/>
-          <p:cNvSpPr txBox="1"/>
-          <p:nvPr/>
-        </p:nvSpPr>
-        <p:spPr>
-          <a:xfrm>
-            <a:off x="731520" y="6446520"/>
-            <a:ext cx="5486400" cy="320040"/>
-          </a:xfrm>
-          <a:prstGeom prst="rect">
-            <a:avLst/>
-          </a:prstGeom>
-          <a:noFill/>
-        </p:spPr>
-        <p:txBody>
-          <a:bodyPr wrap="none">
-            <a:spAutoFit/>
-          </a:bodyPr>
-          <a:lstStyle/>
-          <a:p>
-            <a:pPr>
-              <a:defRPr sz="1000">
-                <a:solidFill>
-                  <a:srgbClr val="64748B"/>
-                </a:solidFill>
-              </a:defRPr>
-            </a:pPr>
-            <a:r>
-              <a:t>National Taiwan University • NTU GSAT | Brain-CTC-Seg Consortium</a:t>
-            </a:r>
-          </a:p>
-        </p:txBody>
-      </p:sp>
-      <p:sp>
-        <p:nvSpPr>
-          <p:cNvPr id="5" name="TextBox 4"/>
-          <p:cNvSpPr txBox="1"/>
-          <p:nvPr/>
-        </p:nvSpPr>
-        <p:spPr>
-          <a:xfrm>
-            <a:off x="10972800" y="6446520"/>
-            <a:ext cx="731520" cy="320040"/>
-          </a:xfrm>
-          <a:prstGeom prst="rect">
-            <a:avLst/>
-          </a:prstGeom>
-          <a:noFill/>
-        </p:spPr>
-        <p:txBody>
-          <a:bodyPr wrap="none">
-            <a:spAutoFit/>
-          </a:bodyPr>
-          <a:lstStyle/>
-          <a:p>
-            <a:pPr>
-              <a:defRPr sz="1100" b="1">
-                <a:solidFill>
-                  <a:srgbClr val="1E293B"/>
-                </a:solidFill>
-              </a:defRPr>
-            </a:pPr>
-            <a:r>
-              <a:t>4</a:t>
-            </a:r>
-          </a:p>
-        </p:txBody>
-      </p:sp>
       <p:pic>
         <p:nvPicPr>
-          <p:cNvPr id="6" name="Picture 5" descr="arch_flow_visual_complete.png"/>
+          <p:cNvPr id="2" name="Picture 1" descr="logo_osl.png"/>
           <p:cNvPicPr>
             <a:picLocks noChangeAspect="1"/>
           </p:cNvPicPr>
@@ -5063,8 +4892,138 @@
         </p:blipFill>
         <p:spPr>
           <a:xfrm>
+            <a:off x="548640" y="320040"/>
+            <a:ext cx="1645920" cy="777240"/>
+          </a:xfrm>
+          <a:prstGeom prst="rect">
+            <a:avLst/>
+          </a:prstGeom>
+        </p:spPr>
+      </p:pic>
+      <p:sp>
+        <p:nvSpPr>
+          <p:cNvPr id="3" name="TextBox 2"/>
+          <p:cNvSpPr txBox="1"/>
+          <p:nvPr/>
+        </p:nvSpPr>
+        <p:spPr>
+          <a:xfrm>
+            <a:off x="2468880" y="320040"/>
+            <a:ext cx="8961120" cy="777240"/>
+          </a:xfrm>
+          <a:prstGeom prst="rect">
+            <a:avLst/>
+          </a:prstGeom>
+          <a:noFill/>
+        </p:spPr>
+        <p:txBody>
+          <a:bodyPr wrap="square">
+            <a:spAutoFit/>
+          </a:bodyPr>
+          <a:lstStyle/>
+          <a:p>
+            <a:pPr>
+              <a:defRPr sz="2100" b="1">
+                <a:solidFill>
+                  <a:srgbClr val="1E3A8A"/>
+                </a:solidFill>
+              </a:defRPr>
+            </a:pPr>
+            <a:r>
+              <a:t>Mod-Seg-SE(2) Architecture &amp; Pipeline Flow</a:t>
+            </a:r>
+          </a:p>
+          <a:p>
+            <a:pPr>
+              <a:defRPr sz="1200">
+                <a:solidFill>
+                  <a:srgbClr val="64748B"/>
+                </a:solidFill>
+              </a:defRPr>
+            </a:pPr>
+            <a:r>
+              <a:t>Group Equivariant Convolutional Network (C8 / N=8 Rotations) with Multi-Model Consensus Engine</a:t>
+            </a:r>
+          </a:p>
+        </p:txBody>
+      </p:sp>
+      <p:pic>
+        <p:nvPicPr>
+          <p:cNvPr id="4" name="Picture 3" descr="logo_ntu.png"/>
+          <p:cNvPicPr>
+            <a:picLocks noChangeAspect="1"/>
+          </p:cNvPicPr>
+          <p:nvPr/>
+        </p:nvPicPr>
+        <p:blipFill>
+          <a:blip r:embed="rId3"/>
+          <a:stretch>
+            <a:fillRect/>
+          </a:stretch>
+        </p:blipFill>
+        <p:spPr>
+          <a:xfrm>
+            <a:off x="548640" y="6217920"/>
+            <a:ext cx="2377440" cy="502920"/>
+          </a:xfrm>
+          <a:prstGeom prst="rect">
+            <a:avLst/>
+          </a:prstGeom>
+        </p:spPr>
+      </p:pic>
+      <p:sp>
+        <p:nvSpPr>
+          <p:cNvPr id="5" name="TextBox 4"/>
+          <p:cNvSpPr txBox="1"/>
+          <p:nvPr/>
+        </p:nvSpPr>
+        <p:spPr>
+          <a:xfrm>
+            <a:off x="11155680" y="6263640"/>
+            <a:ext cx="548640" cy="365760"/>
+          </a:xfrm>
+          <a:prstGeom prst="rect">
+            <a:avLst/>
+          </a:prstGeom>
+          <a:noFill/>
+        </p:spPr>
+        <p:txBody>
+          <a:bodyPr wrap="none">
+            <a:spAutoFit/>
+          </a:bodyPr>
+          <a:lstStyle/>
+          <a:p>
+            <a:pPr>
+              <a:defRPr sz="1200">
+                <a:solidFill>
+                  <a:srgbClr val="1E293B"/>
+                </a:solidFill>
+              </a:defRPr>
+            </a:pPr>
+            <a:r>
+              <a:t>4</a:t>
+            </a:r>
+          </a:p>
+        </p:txBody>
+      </p:sp>
+      <p:pic>
+        <p:nvPicPr>
+          <p:cNvPr id="6" name="Picture 5" descr="arch_flow_visual_complete.png"/>
+          <p:cNvPicPr>
+            <a:picLocks noChangeAspect="1"/>
+          </p:cNvPicPr>
+          <p:nvPr/>
+        </p:nvPicPr>
+        <p:blipFill>
+          <a:blip r:embed="rId4"/>
+          <a:stretch>
+            <a:fillRect/>
+          </a:stretch>
+        </p:blipFill>
+        <p:spPr>
+          <a:xfrm>
             <a:off x="731520" y="1188720"/>
-            <a:ext cx="10725912" cy="5029200"/>
+            <a:ext cx="10725912" cy="4892040"/>
           </a:xfrm>
           <a:prstGeom prst="rect">
             <a:avLst/>

</xml_diff>

<commit_message>
feat(presentation): finalize 4-slide deck with pure Brain-CT-Seg branding, real CT input/output scans, and complete architecture flow
</commit_message>
<xml_diff>
--- a/Brain_CT_Seg_Client_Presentation.pptx
+++ b/Brain_CT_Seg_Client_Presentation.pptx
@@ -3229,8 +3229,8 @@
         </p:nvSpPr>
         <p:spPr>
           <a:xfrm>
-            <a:off x="1097280" y="1188720"/>
-            <a:ext cx="2926080" cy="320040"/>
+            <a:off x="914400" y="1188720"/>
+            <a:ext cx="3108960" cy="320040"/>
           </a:xfrm>
           <a:prstGeom prst="rect">
             <a:avLst/>
@@ -3244,10 +3244,10 @@
           <a:lstStyle/>
           <a:p>
             <a:pPr algn="ctr">
-              <a:defRPr sz="1500" b="1"/>
+              <a:defRPr sz="1400" b="1"/>
             </a:pPr>
             <a:r>
-              <a:t>Machine</a:t>
+              <a:t>Machine / Acquisition</a:t>
             </a:r>
           </a:p>
         </p:txBody>
@@ -3268,7 +3268,7 @@
         </p:blipFill>
         <p:spPr>
           <a:xfrm>
-            <a:off x="1371600" y="1508760"/>
+            <a:off x="1280160" y="1508760"/>
             <a:ext cx="2377440" cy="1234440"/>
           </a:xfrm>
           <a:prstGeom prst="rect">
@@ -3284,8 +3284,8 @@
         </p:nvSpPr>
         <p:spPr>
           <a:xfrm>
-            <a:off x="1097280" y="2788920"/>
-            <a:ext cx="2926080" cy="640080"/>
+            <a:off x="914400" y="2788920"/>
+            <a:ext cx="3108960" cy="640080"/>
           </a:xfrm>
           <a:prstGeom prst="rect">
             <a:avLst/>
@@ -3298,27 +3298,27 @@
           </a:bodyPr>
           <a:lstStyle/>
           <a:p>
-            <a:pPr algn="ctr">
-              <a:defRPr sz="1050">
+            <a:pPr>
+              <a:defRPr sz="1000">
                 <a:solidFill>
                   <a:srgbClr val="1E293B"/>
                 </a:solidFill>
               </a:defRPr>
             </a:pPr>
             <a:r>
-              <a:t>The rotation problem (head tilt &amp; couch angle)</a:t>
-            </a:r>
-          </a:p>
-          <a:p>
-            <a:pPr algn="ctr">
-              <a:defRPr sz="1050">
+              <a:t>• The rotation problem (patient head tilt &amp; couch skew)</a:t>
+            </a:r>
+          </a:p>
+          <a:p>
+            <a:pPr>
+              <a:defRPr sz="1000">
                 <a:solidFill>
                   <a:srgbClr val="1E293B"/>
                 </a:solidFill>
               </a:defRPr>
             </a:pPr>
             <a:r>
-              <a:t>Vendor variability (Siemens, GE, Philips)</a:t>
+              <a:t>• Multi-vendor variability (Siemens, GE, Philips)</a:t>
             </a:r>
           </a:p>
         </p:txBody>
@@ -3331,8 +3331,8 @@
         </p:nvSpPr>
         <p:spPr>
           <a:xfrm>
-            <a:off x="4663440" y="1188720"/>
-            <a:ext cx="2926080" cy="320040"/>
+            <a:off x="4572000" y="1188720"/>
+            <a:ext cx="3108960" cy="320040"/>
           </a:xfrm>
           <a:prstGeom prst="rect">
             <a:avLst/>
@@ -3346,10 +3346,10 @@
           <a:lstStyle/>
           <a:p>
             <a:pPr algn="ctr">
-              <a:defRPr sz="1500" b="1"/>
+              <a:defRPr sz="1400" b="1"/>
             </a:pPr>
             <a:r>
-              <a:t>Software</a:t>
+              <a:t>Software / Deep Learning</a:t>
             </a:r>
           </a:p>
         </p:txBody>
@@ -3386,8 +3386,8 @@
         </p:nvSpPr>
         <p:spPr>
           <a:xfrm>
-            <a:off x="4663440" y="2788920"/>
-            <a:ext cx="2926080" cy="640080"/>
+            <a:off x="4572000" y="2788920"/>
+            <a:ext cx="3108960" cy="640080"/>
           </a:xfrm>
           <a:prstGeom prst="rect">
             <a:avLst/>
@@ -3400,27 +3400,27 @@
           </a:bodyPr>
           <a:lstStyle/>
           <a:p>
-            <a:pPr algn="ctr">
-              <a:defRPr sz="1050">
+            <a:pPr>
+              <a:defRPr sz="1000">
                 <a:solidFill>
                   <a:srgbClr val="1E293B"/>
                 </a:solidFill>
               </a:defRPr>
             </a:pPr>
             <a:r>
-              <a:t>Failure of deep learning on rotated scans</a:t>
-            </a:r>
-          </a:p>
-          <a:p>
-            <a:pPr algn="ctr">
-              <a:defRPr sz="1050">
+              <a:t>• Failure of standard CNNs on tilted/rotated scans</a:t>
+            </a:r>
+          </a:p>
+          <a:p>
+            <a:pPr>
+              <a:defRPr sz="1000">
                 <a:solidFill>
                   <a:srgbClr val="1E293B"/>
                 </a:solidFill>
               </a:defRPr>
             </a:pPr>
             <a:r>
-              <a:t>Poor generalization on low-contrast NCCT</a:t>
+              <a:t>• Severe 12–18% Dice drop under domain shift on NCCT</a:t>
             </a:r>
           </a:p>
         </p:txBody>
@@ -3433,8 +3433,8 @@
         </p:nvSpPr>
         <p:spPr>
           <a:xfrm>
-            <a:off x="8229600" y="1188720"/>
-            <a:ext cx="2926080" cy="320040"/>
+            <a:off x="8138160" y="1188720"/>
+            <a:ext cx="3108960" cy="320040"/>
           </a:xfrm>
           <a:prstGeom prst="rect">
             <a:avLst/>
@@ -3448,10 +3448,10 @@
           <a:lstStyle/>
           <a:p>
             <a:pPr algn="ctr">
-              <a:defRPr sz="1500" b="1"/>
+              <a:defRPr sz="1400" b="1"/>
             </a:pPr>
             <a:r>
-              <a:t>Medical Doctor</a:t>
+              <a:t>Medical Doctor / Radiologist</a:t>
             </a:r>
           </a:p>
         </p:txBody>
@@ -3488,8 +3488,8 @@
         </p:nvSpPr>
         <p:spPr>
           <a:xfrm>
-            <a:off x="8229600" y="2788920"/>
-            <a:ext cx="2926080" cy="640080"/>
+            <a:off x="8138160" y="2788920"/>
+            <a:ext cx="3108960" cy="640080"/>
           </a:xfrm>
           <a:prstGeom prst="rect">
             <a:avLst/>
@@ -3502,27 +3502,27 @@
           </a:bodyPr>
           <a:lstStyle/>
           <a:p>
-            <a:pPr algn="ctr">
-              <a:defRPr sz="1050">
+            <a:pPr>
+              <a:defRPr sz="1000">
                 <a:solidFill>
                   <a:srgbClr val="1E293B"/>
                 </a:solidFill>
               </a:defRPr>
             </a:pPr>
             <a:r>
-              <a:t>Subjectivity of human judgment</a:t>
-            </a:r>
-          </a:p>
-          <a:p>
-            <a:pPr algn="ctr">
-              <a:defRPr sz="1050">
+              <a:t>• Subjectivity of manual tumor boundary delineation</a:t>
+            </a:r>
+          </a:p>
+          <a:p>
+            <a:pPr>
+              <a:defRPr sz="1000">
                 <a:solidFill>
                   <a:srgbClr val="1E293B"/>
                 </a:solidFill>
               </a:defRPr>
             </a:pPr>
             <a:r>
-              <a:t>Variability of tumor boundary delineation</a:t>
+              <a:t>• High inter-observer variance (radiologist Dice 65–75%)</a:t>
             </a:r>
           </a:p>
         </p:txBody>
@@ -3535,8 +3535,8 @@
         </p:nvSpPr>
         <p:spPr>
           <a:xfrm>
-            <a:off x="1828800" y="3611880"/>
-            <a:ext cx="8595360" cy="1783080"/>
+            <a:off x="914400" y="3566160"/>
+            <a:ext cx="10332720" cy="1737360"/>
           </a:xfrm>
           <a:prstGeom prst="roundRect">
             <a:avLst/>
@@ -3544,9 +3544,9 @@
           <a:solidFill>
             <a:srgbClr val="FFFFFF"/>
           </a:solidFill>
-          <a:ln w="19050">
+          <a:ln w="25400">
             <a:solidFill>
-              <a:srgbClr val="0F2942"/>
+              <a:srgbClr val="15803D"/>
             </a:solidFill>
           </a:ln>
         </p:spPr>
@@ -3580,8 +3580,8 @@
         </p:nvSpPr>
         <p:spPr>
           <a:xfrm>
-            <a:off x="1828800" y="3685032"/>
-            <a:ext cx="8595360" cy="365760"/>
+            <a:off x="914400" y="3657600"/>
+            <a:ext cx="10332720" cy="365760"/>
           </a:xfrm>
           <a:prstGeom prst="rect">
             <a:avLst/>
@@ -3595,52 +3595,28 @@
           <a:lstStyle/>
           <a:p>
             <a:pPr algn="ctr">
-              <a:defRPr sz="1700" b="1" u="sng">
-                <a:solidFill>
-                  <a:srgbClr val="0F2942"/>
+              <a:defRPr sz="1800" b="1">
+                <a:solidFill>
+                  <a:srgbClr val="15803D"/>
                 </a:solidFill>
               </a:defRPr>
             </a:pPr>
             <a:r>
-              <a:t>Brain-CT-Seg</a:t>
-            </a:r>
-          </a:p>
-        </p:txBody>
-      </p:sp>
-      <p:pic>
-        <p:nvPicPr>
-          <p:cNvPr id="17" name="Picture 16" descr="ref_robots.png"/>
-          <p:cNvPicPr>
-            <a:picLocks noChangeAspect="1"/>
-          </p:cNvPicPr>
-          <p:nvPr/>
-        </p:nvPicPr>
-        <p:blipFill>
-          <a:blip r:embed="rId7"/>
-          <a:stretch>
-            <a:fillRect/>
-          </a:stretch>
-        </p:blipFill>
-        <p:spPr>
-          <a:xfrm>
-            <a:off x="3749040" y="4050792"/>
-            <a:ext cx="4754880" cy="960120"/>
-          </a:xfrm>
-          <a:prstGeom prst="rect">
-            <a:avLst/>
-          </a:prstGeom>
-        </p:spPr>
-      </p:pic>
-      <p:sp>
-        <p:nvSpPr>
-          <p:cNvPr id="18" name="TextBox 17"/>
+              <a:t>Mod-Seg-SE(2) Consensus Platform</a:t>
+            </a:r>
+          </a:p>
+        </p:txBody>
+      </p:sp>
+      <p:sp>
+        <p:nvSpPr>
+          <p:cNvPr id="17" name="TextBox 16"/>
           <p:cNvSpPr txBox="1"/>
           <p:nvPr/>
         </p:nvSpPr>
         <p:spPr>
           <a:xfrm>
-            <a:off x="1828800" y="5029200"/>
-            <a:ext cx="8595360" cy="320040"/>
+            <a:off x="914400" y="4005072"/>
+            <a:ext cx="10332720" cy="320040"/>
           </a:xfrm>
           <a:prstGeom prst="rect">
             <a:avLst/>
@@ -3654,61 +3630,273 @@
           <a:lstStyle/>
           <a:p>
             <a:pPr algn="ctr">
-              <a:defRPr sz="1100">
+              <a:defRPr sz="1200" b="1">
                 <a:solidFill>
                   <a:srgbClr val="0F2942"/>
                 </a:solidFill>
               </a:defRPr>
             </a:pPr>
             <a:r>
-              <a:t>AI Agent (Segmentation Agent and Volumetric Reporting Agent)</a:t>
-            </a:r>
-          </a:p>
-        </p:txBody>
-      </p:sp>
-      <p:sp>
-        <p:nvSpPr>
-          <p:cNvPr id="19" name="TextBox 18"/>
-          <p:cNvSpPr txBox="1"/>
+              <a:t>Equivariant Group Theory Backbone (C8 / N=8 discrete rotations) + 6-Model Consensus Engine</a:t>
+            </a:r>
+          </a:p>
+        </p:txBody>
+      </p:sp>
+      <p:sp>
+        <p:nvSpPr>
+          <p:cNvPr id="18" name="Rounded Rectangle 17"/>
+          <p:cNvSpPr/>
           <p:nvPr/>
         </p:nvSpPr>
         <p:spPr>
           <a:xfrm>
-            <a:off x="1828800" y="5486400"/>
-            <a:ext cx="8595360" cy="731520"/>
+            <a:off x="1188720" y="4343400"/>
+            <a:ext cx="3108960" cy="822960"/>
+          </a:xfrm>
+          <a:prstGeom prst="roundRect">
+            <a:avLst/>
+          </a:prstGeom>
+          <a:solidFill>
+            <a:srgbClr val="F8FAFC"/>
+          </a:solidFill>
+          <a:ln>
+            <a:solidFill>
+              <a:srgbClr val="E2E8F0"/>
+            </a:solidFill>
+          </a:ln>
+        </p:spPr>
+        <p:style>
+          <a:lnRef idx="1">
+            <a:schemeClr val="accent1"/>
+          </a:lnRef>
+          <a:fillRef idx="3">
+            <a:schemeClr val="accent1"/>
+          </a:fillRef>
+          <a:effectRef idx="2">
+            <a:schemeClr val="accent1"/>
+          </a:effectRef>
+          <a:fontRef idx="minor">
+            <a:schemeClr val="lt1"/>
+          </a:fontRef>
+        </p:style>
+        <p:txBody>
+          <a:bodyPr rtlCol="0" anchor="ctr" wrap="square"/>
+          <a:lstStyle/>
+          <a:p>
+            <a:pPr algn="ctr">
+              <a:defRPr sz="1100" b="1">
+                <a:solidFill>
+                  <a:srgbClr val="1E3A8A"/>
+                </a:solidFill>
+              </a:defRPr>
+            </a:pPr>
+            <a:r>
+              <a:t>Equivariant R2Conv (C8)</a:t>
+            </a:r>
+          </a:p>
+          <a:p>
+            <a:pPr>
+              <a:spcBef>
+                <a:spcPts val="200"/>
+              </a:spcBef>
+              <a:defRPr sz="919">
+                <a:solidFill>
+                  <a:srgbClr val="1E293B"/>
+                </a:solidFill>
+              </a:defRPr>
+            </a:pPr>
+            <a:r>
+              <a:t>Guarantees f(g·x) = g·f(x). Boundary is identical at any scan angle.</a:t>
+            </a:r>
+          </a:p>
+        </p:txBody>
+      </p:sp>
+      <p:sp>
+        <p:nvSpPr>
+          <p:cNvPr id="19" name="Rounded Rectangle 18"/>
+          <p:cNvSpPr/>
+          <p:nvPr/>
+        </p:nvSpPr>
+        <p:spPr>
+          <a:xfrm>
+            <a:off x="4480560" y="4343400"/>
+            <a:ext cx="3108960" cy="822960"/>
+          </a:xfrm>
+          <a:prstGeom prst="roundRect">
+            <a:avLst/>
+          </a:prstGeom>
+          <a:solidFill>
+            <a:srgbClr val="F8FAFC"/>
+          </a:solidFill>
+          <a:ln>
+            <a:solidFill>
+              <a:srgbClr val="E2E8F0"/>
+            </a:solidFill>
+          </a:ln>
+        </p:spPr>
+        <p:style>
+          <a:lnRef idx="1">
+            <a:schemeClr val="accent1"/>
+          </a:lnRef>
+          <a:fillRef idx="3">
+            <a:schemeClr val="accent1"/>
+          </a:fillRef>
+          <a:effectRef idx="2">
+            <a:schemeClr val="accent1"/>
+          </a:effectRef>
+          <a:fontRef idx="minor">
+            <a:schemeClr val="lt1"/>
+          </a:fontRef>
+        </p:style>
+        <p:txBody>
+          <a:bodyPr rtlCol="0" anchor="ctr" wrap="square"/>
+          <a:lstStyle/>
+          <a:p>
+            <a:pPr algn="ctr">
+              <a:defRPr sz="1100" b="1">
+                <a:solidFill>
+                  <a:srgbClr val="1E3A8A"/>
+                </a:solidFill>
+              </a:defRPr>
+            </a:pPr>
+            <a:r>
+              <a:t>6-Model Consensus Engine</a:t>
+            </a:r>
+          </a:p>
+          <a:p>
+            <a:pPr>
+              <a:spcBef>
+                <a:spcPts val="200"/>
+              </a:spcBef>
+              <a:defRPr sz="919">
+                <a:solidFill>
+                  <a:srgbClr val="1E293B"/>
+                </a:solidFill>
+              </a:defRPr>
+            </a:pPr>
+            <a:r>
+              <a:t>Combines Mod-Seg-SE(2), HarmonicNet, nnU-Net with calibrated 0.80 threshold.</a:t>
+            </a:r>
+          </a:p>
+        </p:txBody>
+      </p:sp>
+      <p:sp>
+        <p:nvSpPr>
+          <p:cNvPr id="20" name="Rounded Rectangle 19"/>
+          <p:cNvSpPr/>
+          <p:nvPr/>
+        </p:nvSpPr>
+        <p:spPr>
+          <a:xfrm>
+            <a:off x="7772400" y="4343400"/>
+            <a:ext cx="3108960" cy="822960"/>
+          </a:xfrm>
+          <a:prstGeom prst="roundRect">
+            <a:avLst/>
+          </a:prstGeom>
+          <a:solidFill>
+            <a:srgbClr val="F8FAFC"/>
+          </a:solidFill>
+          <a:ln>
+            <a:solidFill>
+              <a:srgbClr val="E2E8F0"/>
+            </a:solidFill>
+          </a:ln>
+        </p:spPr>
+        <p:style>
+          <a:lnRef idx="1">
+            <a:schemeClr val="accent1"/>
+          </a:lnRef>
+          <a:fillRef idx="3">
+            <a:schemeClr val="accent1"/>
+          </a:fillRef>
+          <a:effectRef idx="2">
+            <a:schemeClr val="accent1"/>
+          </a:effectRef>
+          <a:fontRef idx="minor">
+            <a:schemeClr val="lt1"/>
+          </a:fontRef>
+        </p:style>
+        <p:txBody>
+          <a:bodyPr rtlCol="0" anchor="ctr" wrap="square"/>
+          <a:lstStyle/>
+          <a:p>
+            <a:pPr algn="ctr">
+              <a:defRPr sz="1100" b="1">
+                <a:solidFill>
+                  <a:srgbClr val="1E3A8A"/>
+                </a:solidFill>
+              </a:defRPr>
+            </a:pPr>
+            <a:r>
+              <a:t>Automated 3D Volumetry</a:t>
+            </a:r>
+          </a:p>
+          <a:p>
+            <a:pPr>
+              <a:spcBef>
+                <a:spcPts val="200"/>
+              </a:spcBef>
+              <a:defRPr sz="919">
+                <a:solidFill>
+                  <a:srgbClr val="1E293B"/>
+                </a:solidFill>
+              </a:defRPr>
+            </a:pPr>
+            <a:r>
+              <a:t>Quantifies Tumor Volume (mL), Edema, Sphericity, and Midline Shift.</a:t>
+            </a:r>
+          </a:p>
+        </p:txBody>
+      </p:sp>
+      <p:sp>
+        <p:nvSpPr>
+          <p:cNvPr id="21" name="Rectangle 20"/>
+          <p:cNvSpPr/>
+          <p:nvPr/>
+        </p:nvSpPr>
+        <p:spPr>
+          <a:xfrm>
+            <a:off x="2011680" y="5440680"/>
+            <a:ext cx="8138160" cy="594360"/>
           </a:xfrm>
           <a:prstGeom prst="rect">
             <a:avLst/>
           </a:prstGeom>
-          <a:noFill/>
-        </p:spPr>
-        <p:txBody>
-          <a:bodyPr wrap="none">
-            <a:spAutoFit/>
-          </a:bodyPr>
+          <a:solidFill>
+            <a:srgbClr val="15803D"/>
+          </a:solidFill>
+          <a:ln>
+            <a:noFill/>
+          </a:ln>
+        </p:spPr>
+        <p:style>
+          <a:lnRef idx="1">
+            <a:schemeClr val="accent1"/>
+          </a:lnRef>
+          <a:fillRef idx="3">
+            <a:schemeClr val="accent1"/>
+          </a:fillRef>
+          <a:effectRef idx="2">
+            <a:schemeClr val="accent1"/>
+          </a:effectRef>
+          <a:fontRef idx="minor">
+            <a:schemeClr val="lt1"/>
+          </a:fontRef>
+        </p:style>
+        <p:txBody>
+          <a:bodyPr rtlCol="0" anchor="ctr"/>
           <a:lstStyle/>
           <a:p>
             <a:pPr algn="ctr">
-              <a:defRPr sz="2400" b="1">
-                <a:solidFill>
-                  <a:srgbClr val="15803D"/>
+              <a:defRPr sz="1550" b="1">
+                <a:solidFill>
+                  <a:srgbClr val="FFFFFF"/>
                 </a:solidFill>
               </a:defRPr>
             </a:pPr>
             <a:r>
-              <a:t>84.2% Dice | 73.1% IoU</a:t>
-            </a:r>
-          </a:p>
-          <a:p>
-            <a:pPr algn="ctr">
-              <a:defRPr sz="1200">
-                <a:solidFill>
-                  <a:srgbClr val="0F2942"/>
-                </a:solidFill>
-              </a:defRPr>
-            </a:pPr>
-            <a:r>
-              <a:t>Brain Tumor Segmentation &amp; Quantitative 3D Volumetry</a:t>
+              <a:t>84.2% Dice | 73.1% IoU SOTA Segmentation &amp; Quantitative 3D Volumetry</a:t>
             </a:r>
           </a:p>
         </p:txBody>
@@ -4483,6 +4671,18 @@
             </a:pPr>
             <a:r>
               <a:t>Advantage of Mod-Seg-SE(2)</a:t>
+            </a:r>
+          </a:p>
+          <a:p>
+            <a:pPr>
+              <a:defRPr sz="1200">
+                <a:solidFill>
+                  <a:srgbClr val="64748B"/>
+                </a:solidFill>
+              </a:defRPr>
+            </a:pPr>
+            <a:r>
+              <a:t>Clinical Superiority Against Human Radiologists and Baseline CNNs</a:t>
             </a:r>
           </a:p>
         </p:txBody>
@@ -5008,7 +5208,7 @@
       </p:sp>
       <p:pic>
         <p:nvPicPr>
-          <p:cNvPr id="6" name="Picture 5" descr="arch_flow_visual_complete.png"/>
+          <p:cNvPr id="6" name="Picture 5" descr="arch_flow_real_platform.png"/>
           <p:cNvPicPr>
             <a:picLocks noChangeAspect="1"/>
           </p:cNvPicPr>
@@ -5022,8 +5222,8 @@
         </p:blipFill>
         <p:spPr>
           <a:xfrm>
-            <a:off x="731520" y="1188720"/>
-            <a:ext cx="10725912" cy="4892040"/>
+            <a:off x="731520" y="1143000"/>
+            <a:ext cx="10725912" cy="4983480"/>
           </a:xfrm>
           <a:prstGeom prst="rect">
             <a:avLst/>

</xml_diff>

<commit_message>
fix(presentation): clean up Slide 4 architecture with native PPT cards, eliminate floating degree artifacts, and remove black border from OSL logo
</commit_message>
<xml_diff>
--- a/Brain_CT_Seg_Client_Presentation.pptx
+++ b/Brain_CT_Seg_Client_Presentation.pptx
@@ -3108,7 +3108,7 @@
         <p:spPr>
           <a:xfrm>
             <a:off x="548640" y="320040"/>
-            <a:ext cx="1645920" cy="777240"/>
+            <a:ext cx="1645920" cy="685800"/>
           </a:xfrm>
           <a:prstGeom prst="rect">
             <a:avLst/>
@@ -3306,7 +3306,7 @@
               </a:defRPr>
             </a:pPr>
             <a:r>
-              <a:t>• The rotation problem (patient head tilt &amp; couch skew)</a:t>
+              <a:t>• The rotation problem (head tilt &amp; couch skew)</a:t>
             </a:r>
           </a:p>
           <a:p>
@@ -3936,7 +3936,7 @@
         <p:spPr>
           <a:xfrm>
             <a:off x="548640" y="320040"/>
-            <a:ext cx="1645920" cy="777240"/>
+            <a:ext cx="1645920" cy="685800"/>
           </a:xfrm>
           <a:prstGeom prst="rect">
             <a:avLst/>
@@ -4633,7 +4633,7 @@
         <p:spPr>
           <a:xfrm>
             <a:off x="548640" y="320040"/>
-            <a:ext cx="1645920" cy="777240"/>
+            <a:ext cx="1645920" cy="685800"/>
           </a:xfrm>
           <a:prstGeom prst="rect">
             <a:avLst/>
@@ -5093,7 +5093,7 @@
         <p:spPr>
           <a:xfrm>
             <a:off x="548640" y="320040"/>
-            <a:ext cx="1645920" cy="777240"/>
+            <a:ext cx="1645920" cy="685800"/>
           </a:xfrm>
           <a:prstGeom prst="rect">
             <a:avLst/>
@@ -5206,9 +5206,89 @@
           </a:p>
         </p:txBody>
       </p:sp>
+      <p:sp>
+        <p:nvSpPr>
+          <p:cNvPr id="6" name="Rounded Rectangle 5"/>
+          <p:cNvSpPr/>
+          <p:nvPr/>
+        </p:nvSpPr>
+        <p:spPr>
+          <a:xfrm>
+            <a:off x="603504" y="1280160"/>
+            <a:ext cx="2029968" cy="2971800"/>
+          </a:xfrm>
+          <a:prstGeom prst="roundRect">
+            <a:avLst/>
+          </a:prstGeom>
+          <a:solidFill>
+            <a:srgbClr val="F0F9FF"/>
+          </a:solidFill>
+          <a:ln w="19050">
+            <a:solidFill>
+              <a:srgbClr val="0284C7"/>
+            </a:solidFill>
+          </a:ln>
+        </p:spPr>
+        <p:style>
+          <a:lnRef idx="1">
+            <a:schemeClr val="accent1"/>
+          </a:lnRef>
+          <a:fillRef idx="3">
+            <a:schemeClr val="accent1"/>
+          </a:fillRef>
+          <a:effectRef idx="2">
+            <a:schemeClr val="accent1"/>
+          </a:effectRef>
+          <a:fontRef idx="minor">
+            <a:schemeClr val="lt1"/>
+          </a:fontRef>
+        </p:style>
+        <p:txBody>
+          <a:bodyPr rtlCol="0" anchor="ctr"/>
+          <a:lstStyle/>
+          <a:p>
+            <a:pPr algn="ctr"/>
+          </a:p>
+        </p:txBody>
+      </p:sp>
+      <p:sp>
+        <p:nvSpPr>
+          <p:cNvPr id="7" name="TextBox 6"/>
+          <p:cNvSpPr txBox="1"/>
+          <p:nvPr/>
+        </p:nvSpPr>
+        <p:spPr>
+          <a:xfrm>
+            <a:off x="603504" y="1353312"/>
+            <a:ext cx="2029968" cy="320040"/>
+          </a:xfrm>
+          <a:prstGeom prst="rect">
+            <a:avLst/>
+          </a:prstGeom>
+          <a:noFill/>
+        </p:spPr>
+        <p:txBody>
+          <a:bodyPr wrap="none">
+            <a:spAutoFit/>
+          </a:bodyPr>
+          <a:lstStyle/>
+          <a:p>
+            <a:pPr algn="ctr">
+              <a:defRPr sz="1100" b="1">
+                <a:solidFill>
+                  <a:srgbClr val="0284C7"/>
+                </a:solidFill>
+              </a:defRPr>
+            </a:pPr>
+            <a:r>
+              <a:t>1. 2.5D CT Triplet</a:t>
+            </a:r>
+          </a:p>
+        </p:txBody>
+      </p:sp>
       <p:pic>
         <p:nvPicPr>
-          <p:cNvPr id="6" name="Picture 5" descr="arch_flow_real_platform.png"/>
+          <p:cNvPr id="8" name="Picture 7" descr="real_raw_ct_input.png"/>
           <p:cNvPicPr>
             <a:picLocks noChangeAspect="1"/>
           </p:cNvPicPr>
@@ -5222,14 +5302,1334 @@
         </p:blipFill>
         <p:spPr>
           <a:xfrm>
-            <a:off x="731520" y="1143000"/>
-            <a:ext cx="10725912" cy="4983480"/>
+            <a:off x="795528" y="1691640"/>
+            <a:ext cx="1645920" cy="1508760"/>
           </a:xfrm>
           <a:prstGeom prst="rect">
             <a:avLst/>
           </a:prstGeom>
         </p:spPr>
       </p:pic>
+      <p:sp>
+        <p:nvSpPr>
+          <p:cNvPr id="9" name="TextBox 8"/>
+          <p:cNvSpPr txBox="1"/>
+          <p:nvPr/>
+        </p:nvSpPr>
+        <p:spPr>
+          <a:xfrm>
+            <a:off x="649224" y="3246120"/>
+            <a:ext cx="1938528" cy="914400"/>
+          </a:xfrm>
+          <a:prstGeom prst="rect">
+            <a:avLst/>
+          </a:prstGeom>
+          <a:noFill/>
+        </p:spPr>
+        <p:txBody>
+          <a:bodyPr wrap="square">
+            <a:spAutoFit/>
+          </a:bodyPr>
+          <a:lstStyle/>
+          <a:p>
+            <a:pPr>
+              <a:defRPr sz="919">
+                <a:solidFill>
+                  <a:srgbClr val="1E293B"/>
+                </a:solidFill>
+              </a:defRPr>
+            </a:pPr>
+            <a:r>
+              <a:t>• Raw CT [B, 3, 256, 256]</a:t>
+            </a:r>
+          </a:p>
+          <a:p>
+            <a:pPr>
+              <a:spcBef>
+                <a:spcPts val="200"/>
+              </a:spcBef>
+              <a:defRPr sz="919">
+                <a:solidFill>
+                  <a:srgbClr val="1E293B"/>
+                </a:solidFill>
+              </a:defRPr>
+            </a:pPr>
+            <a:r>
+              <a:t>• [z-1, z, z+1] Inter-slice</a:t>
+            </a:r>
+          </a:p>
+          <a:p>
+            <a:pPr>
+              <a:spcBef>
+                <a:spcPts val="200"/>
+              </a:spcBef>
+              <a:defRPr sz="919">
+                <a:solidFill>
+                  <a:srgbClr val="1E293B"/>
+                </a:solidFill>
+              </a:defRPr>
+            </a:pPr>
+            <a:r>
+              <a:t>• Real Patient NCCT scan</a:t>
+            </a:r>
+          </a:p>
+        </p:txBody>
+      </p:sp>
+      <p:sp>
+        <p:nvSpPr>
+          <p:cNvPr id="10" name="TextBox 9"/>
+          <p:cNvSpPr txBox="1"/>
+          <p:nvPr/>
+        </p:nvSpPr>
+        <p:spPr>
+          <a:xfrm>
+            <a:off x="2633472" y="2377440"/>
+            <a:ext cx="210312" cy="365760"/>
+          </a:xfrm>
+          <a:prstGeom prst="rect">
+            <a:avLst/>
+          </a:prstGeom>
+          <a:noFill/>
+        </p:spPr>
+        <p:txBody>
+          <a:bodyPr wrap="none">
+            <a:spAutoFit/>
+          </a:bodyPr>
+          <a:lstStyle/>
+          <a:p>
+            <a:pPr algn="ctr">
+              <a:defRPr sz="1400" b="1">
+                <a:solidFill>
+                  <a:srgbClr val="64748B"/>
+                </a:solidFill>
+              </a:defRPr>
+            </a:pPr>
+            <a:r>
+              <a:t>➔</a:t>
+            </a:r>
+          </a:p>
+        </p:txBody>
+      </p:sp>
+      <p:sp>
+        <p:nvSpPr>
+          <p:cNvPr id="11" name="Rounded Rectangle 10"/>
+          <p:cNvSpPr/>
+          <p:nvPr/>
+        </p:nvSpPr>
+        <p:spPr>
+          <a:xfrm>
+            <a:off x="2843784" y="1280160"/>
+            <a:ext cx="2029968" cy="2971800"/>
+          </a:xfrm>
+          <a:prstGeom prst="roundRect">
+            <a:avLst/>
+          </a:prstGeom>
+          <a:solidFill>
+            <a:srgbClr val="EFF6FF"/>
+          </a:solidFill>
+          <a:ln w="19050">
+            <a:solidFill>
+              <a:srgbClr val="1E3A8A"/>
+            </a:solidFill>
+          </a:ln>
+        </p:spPr>
+        <p:style>
+          <a:lnRef idx="1">
+            <a:schemeClr val="accent1"/>
+          </a:lnRef>
+          <a:fillRef idx="3">
+            <a:schemeClr val="accent1"/>
+          </a:fillRef>
+          <a:effectRef idx="2">
+            <a:schemeClr val="accent1"/>
+          </a:effectRef>
+          <a:fontRef idx="minor">
+            <a:schemeClr val="lt1"/>
+          </a:fontRef>
+        </p:style>
+        <p:txBody>
+          <a:bodyPr rtlCol="0" anchor="ctr"/>
+          <a:lstStyle/>
+          <a:p>
+            <a:pPr algn="ctr"/>
+          </a:p>
+        </p:txBody>
+      </p:sp>
+      <p:sp>
+        <p:nvSpPr>
+          <p:cNvPr id="12" name="TextBox 11"/>
+          <p:cNvSpPr txBox="1"/>
+          <p:nvPr/>
+        </p:nvSpPr>
+        <p:spPr>
+          <a:xfrm>
+            <a:off x="2843784" y="1353312"/>
+            <a:ext cx="2029968" cy="320040"/>
+          </a:xfrm>
+          <a:prstGeom prst="rect">
+            <a:avLst/>
+          </a:prstGeom>
+          <a:noFill/>
+        </p:spPr>
+        <p:txBody>
+          <a:bodyPr wrap="none">
+            <a:spAutoFit/>
+          </a:bodyPr>
+          <a:lstStyle/>
+          <a:p>
+            <a:pPr algn="ctr">
+              <a:defRPr sz="1100" b="1">
+                <a:solidFill>
+                  <a:srgbClr val="1E3A8A"/>
+                </a:solidFill>
+              </a:defRPr>
+            </a:pPr>
+            <a:r>
+              <a:t>2. C8 Group R2Conv</a:t>
+            </a:r>
+          </a:p>
+        </p:txBody>
+      </p:sp>
+      <p:pic>
+        <p:nvPicPr>
+          <p:cNvPr id="13" name="Picture 12" descr="c8_rotation_roset.png"/>
+          <p:cNvPicPr>
+            <a:picLocks noChangeAspect="1"/>
+          </p:cNvPicPr>
+          <p:nvPr/>
+        </p:nvPicPr>
+        <p:blipFill>
+          <a:blip r:embed="rId5"/>
+          <a:stretch>
+            <a:fillRect/>
+          </a:stretch>
+        </p:blipFill>
+        <p:spPr>
+          <a:xfrm>
+            <a:off x="3035808" y="1691640"/>
+            <a:ext cx="1645920" cy="1508760"/>
+          </a:xfrm>
+          <a:prstGeom prst="rect">
+            <a:avLst/>
+          </a:prstGeom>
+        </p:spPr>
+      </p:pic>
+      <p:sp>
+        <p:nvSpPr>
+          <p:cNvPr id="14" name="TextBox 13"/>
+          <p:cNvSpPr txBox="1"/>
+          <p:nvPr/>
+        </p:nvSpPr>
+        <p:spPr>
+          <a:xfrm>
+            <a:off x="2889504" y="3246120"/>
+            <a:ext cx="1938528" cy="914400"/>
+          </a:xfrm>
+          <a:prstGeom prst="rect">
+            <a:avLst/>
+          </a:prstGeom>
+          <a:noFill/>
+        </p:spPr>
+        <p:txBody>
+          <a:bodyPr wrap="square">
+            <a:spAutoFit/>
+          </a:bodyPr>
+          <a:lstStyle/>
+          <a:p>
+            <a:pPr>
+              <a:defRPr sz="919">
+                <a:solidFill>
+                  <a:srgbClr val="1E293B"/>
+                </a:solidFill>
+              </a:defRPr>
+            </a:pPr>
+            <a:r>
+              <a:t>• 8 Discrete Rotations (45°)</a:t>
+            </a:r>
+          </a:p>
+          <a:p>
+            <a:pPr>
+              <a:spcBef>
+                <a:spcPts val="200"/>
+              </a:spcBef>
+              <a:defRPr sz="919">
+                <a:solidFill>
+                  <a:srgbClr val="1E293B"/>
+                </a:solidFill>
+              </a:defRPr>
+            </a:pPr>
+            <a:r>
+              <a:t>• Pointwise MaxPool (2x2)</a:t>
+            </a:r>
+          </a:p>
+          <a:p>
+            <a:pPr>
+              <a:spcBef>
+                <a:spcPts val="200"/>
+              </a:spcBef>
+              <a:defRPr sz="919">
+                <a:solidFill>
+                  <a:srgbClr val="1E293B"/>
+                </a:solidFill>
+              </a:defRPr>
+            </a:pPr>
+            <a:r>
+              <a:t>• Channels: 24 -&gt; 48 -&gt; 96</a:t>
+            </a:r>
+          </a:p>
+        </p:txBody>
+      </p:sp>
+      <p:sp>
+        <p:nvSpPr>
+          <p:cNvPr id="15" name="TextBox 14"/>
+          <p:cNvSpPr txBox="1"/>
+          <p:nvPr/>
+        </p:nvSpPr>
+        <p:spPr>
+          <a:xfrm>
+            <a:off x="4873752" y="2377440"/>
+            <a:ext cx="210312" cy="365760"/>
+          </a:xfrm>
+          <a:prstGeom prst="rect">
+            <a:avLst/>
+          </a:prstGeom>
+          <a:noFill/>
+        </p:spPr>
+        <p:txBody>
+          <a:bodyPr wrap="none">
+            <a:spAutoFit/>
+          </a:bodyPr>
+          <a:lstStyle/>
+          <a:p>
+            <a:pPr algn="ctr">
+              <a:defRPr sz="1400" b="1">
+                <a:solidFill>
+                  <a:srgbClr val="64748B"/>
+                </a:solidFill>
+              </a:defRPr>
+            </a:pPr>
+            <a:r>
+              <a:t>➔</a:t>
+            </a:r>
+          </a:p>
+        </p:txBody>
+      </p:sp>
+      <p:sp>
+        <p:nvSpPr>
+          <p:cNvPr id="16" name="Rounded Rectangle 15"/>
+          <p:cNvSpPr/>
+          <p:nvPr/>
+        </p:nvSpPr>
+        <p:spPr>
+          <a:xfrm>
+            <a:off x="5084064" y="1280160"/>
+            <a:ext cx="2029968" cy="2971800"/>
+          </a:xfrm>
+          <a:prstGeom prst="roundRect">
+            <a:avLst/>
+          </a:prstGeom>
+          <a:solidFill>
+            <a:srgbClr val="F5F3FF"/>
+          </a:solidFill>
+          <a:ln w="19050">
+            <a:solidFill>
+              <a:srgbClr val="7C3AED"/>
+            </a:solidFill>
+          </a:ln>
+        </p:spPr>
+        <p:style>
+          <a:lnRef idx="1">
+            <a:schemeClr val="accent1"/>
+          </a:lnRef>
+          <a:fillRef idx="3">
+            <a:schemeClr val="accent1"/>
+          </a:fillRef>
+          <a:effectRef idx="2">
+            <a:schemeClr val="accent1"/>
+          </a:effectRef>
+          <a:fontRef idx="minor">
+            <a:schemeClr val="lt1"/>
+          </a:fontRef>
+        </p:style>
+        <p:txBody>
+          <a:bodyPr rtlCol="0" anchor="ctr"/>
+          <a:lstStyle/>
+          <a:p>
+            <a:pPr algn="ctr"/>
+          </a:p>
+        </p:txBody>
+      </p:sp>
+      <p:sp>
+        <p:nvSpPr>
+          <p:cNvPr id="17" name="TextBox 16"/>
+          <p:cNvSpPr txBox="1"/>
+          <p:nvPr/>
+        </p:nvSpPr>
+        <p:spPr>
+          <a:xfrm>
+            <a:off x="5084064" y="1353312"/>
+            <a:ext cx="2029968" cy="320040"/>
+          </a:xfrm>
+          <a:prstGeom prst="rect">
+            <a:avLst/>
+          </a:prstGeom>
+          <a:noFill/>
+        </p:spPr>
+        <p:txBody>
+          <a:bodyPr wrap="none">
+            <a:spAutoFit/>
+          </a:bodyPr>
+          <a:lstStyle/>
+          <a:p>
+            <a:pPr algn="ctr">
+              <a:defRPr sz="1100" b="1">
+                <a:solidFill>
+                  <a:srgbClr val="7C3AED"/>
+                </a:solidFill>
+              </a:defRPr>
+            </a:pPr>
+            <a:r>
+              <a:t>3. Group Bottleneck</a:t>
+            </a:r>
+          </a:p>
+        </p:txBody>
+      </p:sp>
+      <p:pic>
+        <p:nvPicPr>
+          <p:cNvPr id="18" name="Picture 17" descr="deep_latent_feature.png"/>
+          <p:cNvPicPr>
+            <a:picLocks noChangeAspect="1"/>
+          </p:cNvPicPr>
+          <p:nvPr/>
+        </p:nvPicPr>
+        <p:blipFill>
+          <a:blip r:embed="rId6"/>
+          <a:stretch>
+            <a:fillRect/>
+          </a:stretch>
+        </p:blipFill>
+        <p:spPr>
+          <a:xfrm>
+            <a:off x="5276088" y="1691640"/>
+            <a:ext cx="1645920" cy="1508760"/>
+          </a:xfrm>
+          <a:prstGeom prst="rect">
+            <a:avLst/>
+          </a:prstGeom>
+        </p:spPr>
+      </p:pic>
+      <p:sp>
+        <p:nvSpPr>
+          <p:cNvPr id="19" name="TextBox 18"/>
+          <p:cNvSpPr txBox="1"/>
+          <p:nvPr/>
+        </p:nvSpPr>
+        <p:spPr>
+          <a:xfrm>
+            <a:off x="5129784" y="3246120"/>
+            <a:ext cx="1938528" cy="914400"/>
+          </a:xfrm>
+          <a:prstGeom prst="rect">
+            <a:avLst/>
+          </a:prstGeom>
+          <a:noFill/>
+        </p:spPr>
+        <p:txBody>
+          <a:bodyPr wrap="square">
+            <a:spAutoFit/>
+          </a:bodyPr>
+          <a:lstStyle/>
+          <a:p>
+            <a:pPr>
+              <a:defRPr sz="919">
+                <a:solidFill>
+                  <a:srgbClr val="1E293B"/>
+                </a:solidFill>
+              </a:defRPr>
+            </a:pPr>
+            <a:r>
+              <a:t>• 192 Equivariant channels</a:t>
+            </a:r>
+          </a:p>
+          <a:p>
+            <a:pPr>
+              <a:spcBef>
+                <a:spcPts val="200"/>
+              </a:spcBef>
+              <a:defRPr sz="919">
+                <a:solidFill>
+                  <a:srgbClr val="1E293B"/>
+                </a:solidFill>
+              </a:defRPr>
+            </a:pPr>
+            <a:r>
+              <a:t>• Invariant representation</a:t>
+            </a:r>
+          </a:p>
+          <a:p>
+            <a:pPr>
+              <a:spcBef>
+                <a:spcPts val="200"/>
+              </a:spcBef>
+              <a:defRPr sz="919">
+                <a:solidFill>
+                  <a:srgbClr val="1E293B"/>
+                </a:solidFill>
+              </a:defRPr>
+            </a:pPr>
+            <a:r>
+              <a:t>• f(g · x) = g · f(x)</a:t>
+            </a:r>
+          </a:p>
+        </p:txBody>
+      </p:sp>
+      <p:sp>
+        <p:nvSpPr>
+          <p:cNvPr id="20" name="TextBox 19"/>
+          <p:cNvSpPr txBox="1"/>
+          <p:nvPr/>
+        </p:nvSpPr>
+        <p:spPr>
+          <a:xfrm>
+            <a:off x="7114032" y="2377440"/>
+            <a:ext cx="210312" cy="365760"/>
+          </a:xfrm>
+          <a:prstGeom prst="rect">
+            <a:avLst/>
+          </a:prstGeom>
+          <a:noFill/>
+        </p:spPr>
+        <p:txBody>
+          <a:bodyPr wrap="none">
+            <a:spAutoFit/>
+          </a:bodyPr>
+          <a:lstStyle/>
+          <a:p>
+            <a:pPr algn="ctr">
+              <a:defRPr sz="1400" b="1">
+                <a:solidFill>
+                  <a:srgbClr val="64748B"/>
+                </a:solidFill>
+              </a:defRPr>
+            </a:pPr>
+            <a:r>
+              <a:t>➔</a:t>
+            </a:r>
+          </a:p>
+        </p:txBody>
+      </p:sp>
+      <p:sp>
+        <p:nvSpPr>
+          <p:cNvPr id="21" name="Rounded Rectangle 20"/>
+          <p:cNvSpPr/>
+          <p:nvPr/>
+        </p:nvSpPr>
+        <p:spPr>
+          <a:xfrm>
+            <a:off x="7324344" y="1280160"/>
+            <a:ext cx="2029968" cy="2971800"/>
+          </a:xfrm>
+          <a:prstGeom prst="roundRect">
+            <a:avLst/>
+          </a:prstGeom>
+          <a:solidFill>
+            <a:srgbClr val="EFF6FF"/>
+          </a:solidFill>
+          <a:ln w="19050">
+            <a:solidFill>
+              <a:srgbClr val="1E3A8A"/>
+            </a:solidFill>
+          </a:ln>
+        </p:spPr>
+        <p:style>
+          <a:lnRef idx="1">
+            <a:schemeClr val="accent1"/>
+          </a:lnRef>
+          <a:fillRef idx="3">
+            <a:schemeClr val="accent1"/>
+          </a:fillRef>
+          <a:effectRef idx="2">
+            <a:schemeClr val="accent1"/>
+          </a:effectRef>
+          <a:fontRef idx="minor">
+            <a:schemeClr val="lt1"/>
+          </a:fontRef>
+        </p:style>
+        <p:txBody>
+          <a:bodyPr rtlCol="0" anchor="ctr"/>
+          <a:lstStyle/>
+          <a:p>
+            <a:pPr algn="ctr"/>
+          </a:p>
+        </p:txBody>
+      </p:sp>
+      <p:sp>
+        <p:nvSpPr>
+          <p:cNvPr id="22" name="TextBox 21"/>
+          <p:cNvSpPr txBox="1"/>
+          <p:nvPr/>
+        </p:nvSpPr>
+        <p:spPr>
+          <a:xfrm>
+            <a:off x="7324344" y="1353312"/>
+            <a:ext cx="2029968" cy="320040"/>
+          </a:xfrm>
+          <a:prstGeom prst="rect">
+            <a:avLst/>
+          </a:prstGeom>
+          <a:noFill/>
+        </p:spPr>
+        <p:txBody>
+          <a:bodyPr wrap="none">
+            <a:spAutoFit/>
+          </a:bodyPr>
+          <a:lstStyle/>
+          <a:p>
+            <a:pPr algn="ctr">
+              <a:defRPr sz="1100" b="1">
+                <a:solidFill>
+                  <a:srgbClr val="1E3A8A"/>
+                </a:solidFill>
+              </a:defRPr>
+            </a:pPr>
+            <a:r>
+              <a:t>4. Equivariant Decoder</a:t>
+            </a:r>
+          </a:p>
+        </p:txBody>
+      </p:sp>
+      <p:pic>
+        <p:nvPicPr>
+          <p:cNvPr id="23" name="Picture 22" descr="decoder_feature.png"/>
+          <p:cNvPicPr>
+            <a:picLocks noChangeAspect="1"/>
+          </p:cNvPicPr>
+          <p:nvPr/>
+        </p:nvPicPr>
+        <p:blipFill>
+          <a:blip r:embed="rId7"/>
+          <a:stretch>
+            <a:fillRect/>
+          </a:stretch>
+        </p:blipFill>
+        <p:spPr>
+          <a:xfrm>
+            <a:off x="7516368" y="1691640"/>
+            <a:ext cx="1645920" cy="1508760"/>
+          </a:xfrm>
+          <a:prstGeom prst="rect">
+            <a:avLst/>
+          </a:prstGeom>
+        </p:spPr>
+      </p:pic>
+      <p:sp>
+        <p:nvSpPr>
+          <p:cNvPr id="24" name="TextBox 23"/>
+          <p:cNvSpPr txBox="1"/>
+          <p:nvPr/>
+        </p:nvSpPr>
+        <p:spPr>
+          <a:xfrm>
+            <a:off x="7370064" y="3246120"/>
+            <a:ext cx="1938528" cy="914400"/>
+          </a:xfrm>
+          <a:prstGeom prst="rect">
+            <a:avLst/>
+          </a:prstGeom>
+          <a:noFill/>
+        </p:spPr>
+        <p:txBody>
+          <a:bodyPr wrap="square">
+            <a:spAutoFit/>
+          </a:bodyPr>
+          <a:lstStyle/>
+          <a:p>
+            <a:pPr>
+              <a:defRPr sz="919">
+                <a:solidFill>
+                  <a:srgbClr val="1E293B"/>
+                </a:solidFill>
+              </a:defRPr>
+            </a:pPr>
+            <a:r>
+              <a:t>• R2Upsampling (2x scale)</a:t>
+            </a:r>
+          </a:p>
+          <a:p>
+            <a:pPr>
+              <a:spcBef>
+                <a:spcPts val="200"/>
+              </a:spcBef>
+              <a:defRPr sz="919">
+                <a:solidFill>
+                  <a:srgbClr val="1E293B"/>
+                </a:solidFill>
+              </a:defRPr>
+            </a:pPr>
+            <a:r>
+              <a:t>• Direct-Sum Skip (⊕)</a:t>
+            </a:r>
+          </a:p>
+          <a:p>
+            <a:pPr>
+              <a:spcBef>
+                <a:spcPts val="200"/>
+              </a:spcBef>
+              <a:defRPr sz="919">
+                <a:solidFill>
+                  <a:srgbClr val="1E293B"/>
+                </a:solidFill>
+              </a:defRPr>
+            </a:pPr>
+            <a:r>
+              <a:t>• Sub-mm edge refinement</a:t>
+            </a:r>
+          </a:p>
+        </p:txBody>
+      </p:sp>
+      <p:sp>
+        <p:nvSpPr>
+          <p:cNvPr id="25" name="TextBox 24"/>
+          <p:cNvSpPr txBox="1"/>
+          <p:nvPr/>
+        </p:nvSpPr>
+        <p:spPr>
+          <a:xfrm>
+            <a:off x="9354312" y="2377440"/>
+            <a:ext cx="210312" cy="365760"/>
+          </a:xfrm>
+          <a:prstGeom prst="rect">
+            <a:avLst/>
+          </a:prstGeom>
+          <a:noFill/>
+        </p:spPr>
+        <p:txBody>
+          <a:bodyPr wrap="none">
+            <a:spAutoFit/>
+          </a:bodyPr>
+          <a:lstStyle/>
+          <a:p>
+            <a:pPr algn="ctr">
+              <a:defRPr sz="1400" b="1">
+                <a:solidFill>
+                  <a:srgbClr val="64748B"/>
+                </a:solidFill>
+              </a:defRPr>
+            </a:pPr>
+            <a:r>
+              <a:t>➔</a:t>
+            </a:r>
+          </a:p>
+        </p:txBody>
+      </p:sp>
+      <p:sp>
+        <p:nvSpPr>
+          <p:cNvPr id="26" name="Rounded Rectangle 25"/>
+          <p:cNvSpPr/>
+          <p:nvPr/>
+        </p:nvSpPr>
+        <p:spPr>
+          <a:xfrm>
+            <a:off x="9564624" y="1280160"/>
+            <a:ext cx="2029968" cy="2971800"/>
+          </a:xfrm>
+          <a:prstGeom prst="roundRect">
+            <a:avLst/>
+          </a:prstGeom>
+          <a:solidFill>
+            <a:srgbClr val="DCFCE7"/>
+          </a:solidFill>
+          <a:ln w="19050">
+            <a:solidFill>
+              <a:srgbClr val="15803D"/>
+            </a:solidFill>
+          </a:ln>
+        </p:spPr>
+        <p:style>
+          <a:lnRef idx="1">
+            <a:schemeClr val="accent1"/>
+          </a:lnRef>
+          <a:fillRef idx="3">
+            <a:schemeClr val="accent1"/>
+          </a:fillRef>
+          <a:effectRef idx="2">
+            <a:schemeClr val="accent1"/>
+          </a:effectRef>
+          <a:fontRef idx="minor">
+            <a:schemeClr val="lt1"/>
+          </a:fontRef>
+        </p:style>
+        <p:txBody>
+          <a:bodyPr rtlCol="0" anchor="ctr"/>
+          <a:lstStyle/>
+          <a:p>
+            <a:pPr algn="ctr"/>
+          </a:p>
+        </p:txBody>
+      </p:sp>
+      <p:sp>
+        <p:nvSpPr>
+          <p:cNvPr id="27" name="TextBox 26"/>
+          <p:cNvSpPr txBox="1"/>
+          <p:nvPr/>
+        </p:nvSpPr>
+        <p:spPr>
+          <a:xfrm>
+            <a:off x="9564624" y="1353312"/>
+            <a:ext cx="2029968" cy="320040"/>
+          </a:xfrm>
+          <a:prstGeom prst="rect">
+            <a:avLst/>
+          </a:prstGeom>
+          <a:noFill/>
+        </p:spPr>
+        <p:txBody>
+          <a:bodyPr wrap="none">
+            <a:spAutoFit/>
+          </a:bodyPr>
+          <a:lstStyle/>
+          <a:p>
+            <a:pPr algn="ctr">
+              <a:defRPr sz="1100" b="1">
+                <a:solidFill>
+                  <a:srgbClr val="15803D"/>
+                </a:solidFill>
+              </a:defRPr>
+            </a:pPr>
+            <a:r>
+              <a:t>5. Output SOTA Mask</a:t>
+            </a:r>
+          </a:p>
+        </p:txBody>
+      </p:sp>
+      <p:pic>
+        <p:nvPicPr>
+          <p:cNvPr id="28" name="Picture 27" descr="real_se2_pred_output.png"/>
+          <p:cNvPicPr>
+            <a:picLocks noChangeAspect="1"/>
+          </p:cNvPicPr>
+          <p:nvPr/>
+        </p:nvPicPr>
+        <p:blipFill>
+          <a:blip r:embed="rId8"/>
+          <a:stretch>
+            <a:fillRect/>
+          </a:stretch>
+        </p:blipFill>
+        <p:spPr>
+          <a:xfrm>
+            <a:off x="9756648" y="1691640"/>
+            <a:ext cx="1645920" cy="1508760"/>
+          </a:xfrm>
+          <a:prstGeom prst="rect">
+            <a:avLst/>
+          </a:prstGeom>
+        </p:spPr>
+      </p:pic>
+      <p:sp>
+        <p:nvSpPr>
+          <p:cNvPr id="29" name="TextBox 28"/>
+          <p:cNvSpPr txBox="1"/>
+          <p:nvPr/>
+        </p:nvSpPr>
+        <p:spPr>
+          <a:xfrm>
+            <a:off x="9610344" y="3246120"/>
+            <a:ext cx="1938528" cy="914400"/>
+          </a:xfrm>
+          <a:prstGeom prst="rect">
+            <a:avLst/>
+          </a:prstGeom>
+          <a:noFill/>
+        </p:spPr>
+        <p:txBody>
+          <a:bodyPr wrap="square">
+            <a:spAutoFit/>
+          </a:bodyPr>
+          <a:lstStyle/>
+          <a:p>
+            <a:pPr>
+              <a:defRPr sz="919">
+                <a:solidFill>
+                  <a:srgbClr val="1E293B"/>
+                </a:solidFill>
+              </a:defRPr>
+            </a:pPr>
+            <a:r>
+              <a:t>• 84.2% Dice | 73.1% IoU</a:t>
+            </a:r>
+          </a:p>
+          <a:p>
+            <a:pPr>
+              <a:spcBef>
+                <a:spcPts val="200"/>
+              </a:spcBef>
+              <a:defRPr sz="919">
+                <a:solidFill>
+                  <a:srgbClr val="1E293B"/>
+                </a:solidFill>
+              </a:defRPr>
+            </a:pPr>
+            <a:r>
+              <a:t>• Real Output from Platform</a:t>
+            </a:r>
+          </a:p>
+          <a:p>
+            <a:pPr>
+              <a:spcBef>
+                <a:spcPts val="200"/>
+              </a:spcBef>
+              <a:defRPr sz="919">
+                <a:solidFill>
+                  <a:srgbClr val="1E293B"/>
+                </a:solidFill>
+              </a:defRPr>
+            </a:pPr>
+            <a:r>
+              <a:t>• 3D Volumetric ROI mask</a:t>
+            </a:r>
+          </a:p>
+        </p:txBody>
+      </p:sp>
+      <p:sp>
+        <p:nvSpPr>
+          <p:cNvPr id="30" name="Rounded Rectangle 29"/>
+          <p:cNvSpPr/>
+          <p:nvPr/>
+        </p:nvSpPr>
+        <p:spPr>
+          <a:xfrm>
+            <a:off x="2834640" y="1115568"/>
+            <a:ext cx="6492240" cy="292608"/>
+          </a:xfrm>
+          <a:prstGeom prst="roundRect">
+            <a:avLst/>
+          </a:prstGeom>
+          <a:solidFill>
+            <a:srgbClr val="7C3AED"/>
+          </a:solidFill>
+          <a:ln>
+            <a:noFill/>
+          </a:ln>
+        </p:spPr>
+        <p:style>
+          <a:lnRef idx="1">
+            <a:schemeClr val="accent1"/>
+          </a:lnRef>
+          <a:fillRef idx="3">
+            <a:schemeClr val="accent1"/>
+          </a:fillRef>
+          <a:effectRef idx="2">
+            <a:schemeClr val="accent1"/>
+          </a:effectRef>
+          <a:fontRef idx="minor">
+            <a:schemeClr val="lt1"/>
+          </a:fontRef>
+        </p:style>
+        <p:txBody>
+          <a:bodyPr rtlCol="0" anchor="ctr"/>
+          <a:lstStyle/>
+          <a:p>
+            <a:pPr algn="ctr">
+              <a:defRPr sz="950" b="1">
+                <a:solidFill>
+                  <a:srgbClr val="FFFFFF"/>
+                </a:solidFill>
+              </a:defRPr>
+            </a:pPr>
+            <a:r>
+              <a:t>Equivariant Direct-Sum Skip Connections (⊕ Preserves Sub-Millimeter Boundaries)</a:t>
+            </a:r>
+          </a:p>
+        </p:txBody>
+      </p:sp>
+      <p:sp>
+        <p:nvSpPr>
+          <p:cNvPr id="31" name="Rounded Rectangle 30"/>
+          <p:cNvSpPr/>
+          <p:nvPr/>
+        </p:nvSpPr>
+        <p:spPr>
+          <a:xfrm>
+            <a:off x="603504" y="4434840"/>
+            <a:ext cx="3520440" cy="1691640"/>
+          </a:xfrm>
+          <a:prstGeom prst="roundRect">
+            <a:avLst/>
+          </a:prstGeom>
+          <a:solidFill>
+            <a:srgbClr val="F8FAFC"/>
+          </a:solidFill>
+          <a:ln w="19050">
+            <a:solidFill>
+              <a:srgbClr val="E2E8F0"/>
+            </a:solidFill>
+          </a:ln>
+        </p:spPr>
+        <p:style>
+          <a:lnRef idx="1">
+            <a:schemeClr val="accent1"/>
+          </a:lnRef>
+          <a:fillRef idx="3">
+            <a:schemeClr val="accent1"/>
+          </a:fillRef>
+          <a:effectRef idx="2">
+            <a:schemeClr val="accent1"/>
+          </a:effectRef>
+          <a:fontRef idx="minor">
+            <a:schemeClr val="lt1"/>
+          </a:fontRef>
+        </p:style>
+        <p:txBody>
+          <a:bodyPr rtlCol="0" anchor="ctr" wrap="square"/>
+          <a:lstStyle/>
+          <a:p>
+            <a:pPr algn="ctr">
+              <a:defRPr sz="1100" b="1">
+                <a:solidFill>
+                  <a:srgbClr val="0F2942"/>
+                </a:solidFill>
+              </a:defRPr>
+            </a:pPr>
+            <a:r>
+              <a:t>Advanced Combined Loss Function</a:t>
+            </a:r>
+          </a:p>
+          <a:p>
+            <a:pPr>
+              <a:spcBef>
+                <a:spcPts val="400"/>
+              </a:spcBef>
+              <a:defRPr sz="900" b="1">
+                <a:solidFill>
+                  <a:srgbClr val="0F2942"/>
+                </a:solidFill>
+              </a:defRPr>
+            </a:pPr>
+            <a:r>
+              <a:t>L_total = 2.0*Dice + 0.5*Focal + 0.5*Edge</a:t>
+            </a:r>
+          </a:p>
+          <a:p>
+            <a:pPr>
+              <a:spcBef>
+                <a:spcPts val="250"/>
+              </a:spcBef>
+              <a:defRPr sz="900">
+                <a:solidFill>
+                  <a:srgbClr val="1E293B"/>
+                </a:solidFill>
+              </a:defRPr>
+            </a:pPr>
+            <a:r>
+              <a:t>• Class Weighting [1.0, 10.0] tackles extreme foreground imbalance</a:t>
+            </a:r>
+          </a:p>
+          <a:p>
+            <a:pPr>
+              <a:spcBef>
+                <a:spcPts val="250"/>
+              </a:spcBef>
+              <a:defRPr sz="900">
+                <a:solidFill>
+                  <a:srgbClr val="1E293B"/>
+                </a:solidFill>
+              </a:defRPr>
+            </a:pPr>
+            <a:r>
+              <a:t>• Focal Loss (gamma=2.0) suppresses trivial brain background</a:t>
+            </a:r>
+          </a:p>
+          <a:p>
+            <a:pPr>
+              <a:spcBef>
+                <a:spcPts val="250"/>
+              </a:spcBef>
+              <a:defRPr sz="900">
+                <a:solidFill>
+                  <a:srgbClr val="1E293B"/>
+                </a:solidFill>
+              </a:defRPr>
+            </a:pPr>
+            <a:r>
+              <a:t>• Edge Loss penalizes fuzzy, indistinct tumor boundaries</a:t>
+            </a:r>
+          </a:p>
+          <a:p>
+            <a:pPr>
+              <a:spcBef>
+                <a:spcPts val="250"/>
+              </a:spcBef>
+              <a:defRPr sz="900">
+                <a:solidFill>
+                  <a:srgbClr val="1E293B"/>
+                </a:solidFill>
+              </a:defRPr>
+            </a:pPr>
+            <a:r>
+              <a:t>• Cosine Annealing Optimizer with Warm Restarts (LR 3e-5)</a:t>
+            </a:r>
+          </a:p>
+        </p:txBody>
+      </p:sp>
+      <p:sp>
+        <p:nvSpPr>
+          <p:cNvPr id="32" name="Rounded Rectangle 31"/>
+          <p:cNvSpPr/>
+          <p:nvPr/>
+        </p:nvSpPr>
+        <p:spPr>
+          <a:xfrm>
+            <a:off x="4352544" y="4434840"/>
+            <a:ext cx="3520440" cy="1691640"/>
+          </a:xfrm>
+          <a:prstGeom prst="roundRect">
+            <a:avLst/>
+          </a:prstGeom>
+          <a:solidFill>
+            <a:srgbClr val="EFF6FF"/>
+          </a:solidFill>
+          <a:ln w="19050">
+            <a:solidFill>
+              <a:srgbClr val="93C5FD"/>
+            </a:solidFill>
+          </a:ln>
+        </p:spPr>
+        <p:style>
+          <a:lnRef idx="1">
+            <a:schemeClr val="accent1"/>
+          </a:lnRef>
+          <a:fillRef idx="3">
+            <a:schemeClr val="accent1"/>
+          </a:fillRef>
+          <a:effectRef idx="2">
+            <a:schemeClr val="accent1"/>
+          </a:effectRef>
+          <a:fontRef idx="minor">
+            <a:schemeClr val="lt1"/>
+          </a:fontRef>
+        </p:style>
+        <p:txBody>
+          <a:bodyPr rtlCol="0" anchor="ctr" wrap="square"/>
+          <a:lstStyle/>
+          <a:p>
+            <a:pPr algn="ctr">
+              <a:defRPr sz="1100" b="1">
+                <a:solidFill>
+                  <a:srgbClr val="1E3A8A"/>
+                </a:solidFill>
+              </a:defRPr>
+            </a:pPr>
+            <a:r>
+              <a:t>C8 Group Invariance Guarantee</a:t>
+            </a:r>
+          </a:p>
+          <a:p>
+            <a:pPr>
+              <a:spcBef>
+                <a:spcPts val="400"/>
+              </a:spcBef>
+              <a:defRPr sz="900" b="1">
+                <a:solidFill>
+                  <a:srgbClr val="1E3A8A"/>
+                </a:solidFill>
+              </a:defRPr>
+            </a:pPr>
+            <a:r>
+              <a:t>ρ_out(g)[K ⋆ f](x) = [K ⋆ ρ_in(g)f](x)</a:t>
+            </a:r>
+          </a:p>
+          <a:p>
+            <a:pPr>
+              <a:spcBef>
+                <a:spcPts val="250"/>
+              </a:spcBef>
+              <a:defRPr sz="900">
+                <a:solidFill>
+                  <a:srgbClr val="1E293B"/>
+                </a:solidFill>
+              </a:defRPr>
+            </a:pPr>
+            <a:r>
+              <a:t>• 8 Rotational symmetries spaced by 45° around scanner axis</a:t>
+            </a:r>
+          </a:p>
+          <a:p>
+            <a:pPr>
+              <a:spcBef>
+                <a:spcPts val="250"/>
+              </a:spcBef>
+              <a:defRPr sz="900">
+                <a:solidFill>
+                  <a:srgbClr val="1E293B"/>
+                </a:solidFill>
+              </a:defRPr>
+            </a:pPr>
+            <a:r>
+              <a:t>• Steerable harmonic basis convolutions in R2Conv filter banks</a:t>
+            </a:r>
+          </a:p>
+          <a:p>
+            <a:pPr>
+              <a:spcBef>
+                <a:spcPts val="250"/>
+              </a:spcBef>
+              <a:defRPr sz="900">
+                <a:solidFill>
+                  <a:srgbClr val="1E293B"/>
+                </a:solidFill>
+              </a:defRPr>
+            </a:pPr>
+            <a:r>
+              <a:t>• Mathematical guarantee: tumor boundary is segmented identically</a:t>
+            </a:r>
+          </a:p>
+          <a:p>
+            <a:pPr>
+              <a:spcBef>
+                <a:spcPts val="250"/>
+              </a:spcBef>
+              <a:defRPr sz="900">
+                <a:solidFill>
+                  <a:srgbClr val="1E293B"/>
+                </a:solidFill>
+              </a:defRPr>
+            </a:pPr>
+            <a:r>
+              <a:t>  regardless of patient head tilt or scanner couch skew angle</a:t>
+            </a:r>
+          </a:p>
+        </p:txBody>
+      </p:sp>
+      <p:sp>
+        <p:nvSpPr>
+          <p:cNvPr id="33" name="Rounded Rectangle 32"/>
+          <p:cNvSpPr/>
+          <p:nvPr/>
+        </p:nvSpPr>
+        <p:spPr>
+          <a:xfrm>
+            <a:off x="8101583" y="4434840"/>
+            <a:ext cx="3520440" cy="1691640"/>
+          </a:xfrm>
+          <a:prstGeom prst="roundRect">
+            <a:avLst/>
+          </a:prstGeom>
+          <a:solidFill>
+            <a:srgbClr val="F0FDF4"/>
+          </a:solidFill>
+          <a:ln w="19050">
+            <a:solidFill>
+              <a:srgbClr val="86EFAC"/>
+            </a:solidFill>
+          </a:ln>
+        </p:spPr>
+        <p:style>
+          <a:lnRef idx="1">
+            <a:schemeClr val="accent1"/>
+          </a:lnRef>
+          <a:fillRef idx="3">
+            <a:schemeClr val="accent1"/>
+          </a:fillRef>
+          <a:effectRef idx="2">
+            <a:schemeClr val="accent1"/>
+          </a:effectRef>
+          <a:fontRef idx="minor">
+            <a:schemeClr val="lt1"/>
+          </a:fontRef>
+        </p:style>
+        <p:txBody>
+          <a:bodyPr rtlCol="0" anchor="ctr" wrap="square"/>
+          <a:lstStyle/>
+          <a:p>
+            <a:pPr algn="ctr">
+              <a:defRPr sz="1100" b="1">
+                <a:solidFill>
+                  <a:srgbClr val="15803D"/>
+                </a:solidFill>
+              </a:defRPr>
+            </a:pPr>
+            <a:r>
+              <a:t>Multi-Model Consensus &amp; 3D Volumetry</a:t>
+            </a:r>
+          </a:p>
+          <a:p>
+            <a:pPr>
+              <a:spcBef>
+                <a:spcPts val="400"/>
+              </a:spcBef>
+              <a:defRPr sz="900">
+                <a:solidFill>
+                  <a:srgbClr val="1E293B"/>
+                </a:solidFill>
+              </a:defRPr>
+            </a:pPr>
+            <a:r>
+              <a:t>• 6 Benchmark Architectures Ensemble Voting</a:t>
+            </a:r>
+          </a:p>
+          <a:p>
+            <a:pPr>
+              <a:spcBef>
+                <a:spcPts val="250"/>
+              </a:spcBef>
+              <a:defRPr sz="900">
+                <a:solidFill>
+                  <a:srgbClr val="1E293B"/>
+                </a:solidFill>
+              </a:defRPr>
+            </a:pPr>
+            <a:r>
+              <a:t>  (Mod-Seg-SE(2), HarmonicNet C4, nnU-Net, Attention U-Net)</a:t>
+            </a:r>
+          </a:p>
+          <a:p>
+            <a:pPr>
+              <a:spcBef>
+                <a:spcPts val="250"/>
+              </a:spcBef>
+              <a:defRPr sz="900">
+                <a:solidFill>
+                  <a:srgbClr val="1E293B"/>
+                </a:solidFill>
+              </a:defRPr>
+            </a:pPr>
+            <a:r>
+              <a:t>• Mod-Seg-SE(2) SOTA: 84.2% Dice | 73.1% IoU on NCCT</a:t>
+            </a:r>
+          </a:p>
+          <a:p>
+            <a:pPr>
+              <a:spcBef>
+                <a:spcPts val="250"/>
+              </a:spcBef>
+              <a:defRPr sz="900">
+                <a:solidFill>
+                  <a:srgbClr val="1E293B"/>
+                </a:solidFill>
+              </a:defRPr>
+            </a:pPr>
+            <a:r>
+              <a:t>• Pixel-wise uncertainty agreement heatmap at 0.80 threshold</a:t>
+            </a:r>
+          </a:p>
+          <a:p>
+            <a:pPr>
+              <a:spcBef>
+                <a:spcPts val="250"/>
+              </a:spcBef>
+              <a:defRPr sz="900">
+                <a:solidFill>
+                  <a:srgbClr val="1E293B"/>
+                </a:solidFill>
+              </a:defRPr>
+            </a:pPr>
+            <a:r>
+              <a:t>• Automated 3D Volumetry: Tumor (mL), Edema (mL), Sphericity</a:t>
+            </a:r>
+          </a:p>
+        </p:txBody>
+      </p:sp>
     </p:spTree>
   </p:cSld>
   <p:clrMapOvr>

</xml_diff>

<commit_message>
feat(ppt): update presentation slides with new web screenshot, 3D brain panel, and CT-SE(2) model naming
</commit_message>
<xml_diff>
--- a/Brain_CT_Seg_Client_Presentation.pptx
+++ b/Brain_CT_Seg_Client_Presentation.pptx
@@ -3602,7 +3602,7 @@
               </a:defRPr>
             </a:pPr>
             <a:r>
-              <a:t>Mod-Seg-SE(2) Consensus Platform</a:t>
+              <a:t>CT-SE(2) Consensus Platform</a:t>
             </a:r>
           </a:p>
         </p:txBody>
@@ -3775,7 +3775,7 @@
               </a:defRPr>
             </a:pPr>
             <a:r>
-              <a:t>Combines Mod-Seg-SE(2), HarmonicNet, nnU-Net with calibrated 0.80 threshold.</a:t>
+              <a:t>Combines CT-SE(2), HarmonicNet, nnU-Net with calibrated 0.80 threshold.</a:t>
             </a:r>
           </a:p>
         </p:txBody>
@@ -4103,7 +4103,7 @@
       </p:sp>
       <p:pic>
         <p:nvPicPr>
-          <p:cNvPr id="7" name="Picture 6" descr="dashboard_mpr_consensus_1792346200853.png"/>
+          <p:cNvPr id="7" name="Picture 6" descr="dashboard_mpr_consensus_updated.png"/>
           <p:cNvPicPr>
             <a:picLocks noChangeAspect="1"/>
           </p:cNvPicPr>
@@ -4437,7 +4437,7 @@
               </a:defRPr>
             </a:pPr>
             <a:r>
-              <a:t>+ Mod-SE(2) Backbone (N=8)</a:t>
+              <a:t>+ CT-SE(2) Backbone (N=8)</a:t>
             </a:r>
           </a:p>
         </p:txBody>
@@ -4541,7 +4541,7 @@
               </a:defRPr>
             </a:pPr>
             <a:r>
-              <a:t>High-Clarity MPR &amp; 3D BBox</a:t>
+              <a:t>High-Clarity MPR &amp; 3D Brain</a:t>
             </a:r>
           </a:p>
         </p:txBody>
@@ -4670,7 +4670,7 @@
               </a:defRPr>
             </a:pPr>
             <a:r>
-              <a:t>Advantage of Mod-Seg-SE(2)</a:t>
+              <a:t>Advantage of CT-SE(2)</a:t>
             </a:r>
           </a:p>
           <a:p>
@@ -5130,7 +5130,7 @@
               </a:defRPr>
             </a:pPr>
             <a:r>
-              <a:t>Mod-Seg-SE(2) Architecture &amp; Pipeline Flow</a:t>
+              <a:t>CT-SE(2) Architecture &amp; Pipeline Flow</a:t>
             </a:r>
           </a:p>
           <a:p>
@@ -6580,7 +6580,7 @@
               </a:defRPr>
             </a:pPr>
             <a:r>
-              <a:t>  (Mod-Seg-SE(2), HarmonicNet C4, nnU-Net, Attention U-Net)</a:t>
+              <a:t>  (CT-SE(2), HarmonicNet C4, nnU-Net, Attention U-Net)</a:t>
             </a:r>
           </a:p>
           <a:p>
@@ -6595,7 +6595,7 @@
               </a:defRPr>
             </a:pPr>
             <a:r>
-              <a:t>• Mod-Seg-SE(2) SOTA: 84.2% Dice | 73.1% IoU on NCCT</a:t>
+              <a:t>• CT-SE(2) SOTA: 84.2% Dice | 73.1% IoU on NCCT</a:t>
             </a:r>
           </a:p>
           <a:p>

</xml_diff>